<commit_message>
Expand presentation to 18-slide master edition with exhaustive explanations and dedicated theory & NS-2 slides for each technique
</commit_message>
<xml_diff>
--- a/Error_Detection_and_Correction_Presentation.pptx
+++ b/Error_Detection_and_Correction_Presentation.pptx
@@ -17,6 +17,12 @@
     <p:sldId id="265" r:id="rId16"/>
     <p:sldId id="266" r:id="rId17"/>
     <p:sldId id="267" r:id="rId18"/>
+    <p:sldId id="268" r:id="rId19"/>
+    <p:sldId id="269" r:id="rId20"/>
+    <p:sldId id="270" r:id="rId21"/>
+    <p:sldId id="271" r:id="rId22"/>
+    <p:sldId id="272" r:id="rId23"/>
+    <p:sldId id="273" r:id="rId24"/>
   </p:sldIdLst>
   <p:sldSz cx="12191695" cy="6858000" type="screen4x3"/>
   <p:notesSz cx="6858000" cy="9144000"/>
@@ -3193,7 +3199,7 @@
         </p:nvSpPr>
         <p:spPr>
           <a:xfrm>
-            <a:off x="914400" y="777240"/>
+            <a:off x="914400" y="731520"/>
             <a:ext cx="3474720" cy="384048"/>
           </a:xfrm>
           <a:prstGeom prst="roundRect">
@@ -3248,7 +3254,7 @@
         </p:nvSpPr>
         <p:spPr>
           <a:xfrm>
-            <a:off x="914400" y="1280160"/>
+            <a:off x="914400" y="1234440"/>
             <a:ext cx="10360152" cy="1371600"/>
           </a:xfrm>
           <a:prstGeom prst="rect">
@@ -3263,7 +3269,7 @@
           <a:lstStyle/>
           <a:p>
             <a:pPr>
-              <a:defRPr sz="3200" b="1">
+              <a:defRPr sz="3000" b="1">
                 <a:solidFill>
                   <a:srgbClr val="F8FAFC"/>
                 </a:solidFill>
@@ -3279,7 +3285,7 @@
               <a:spcBef>
                 <a:spcPts val="400"/>
               </a:spcBef>
-              <a:defRPr sz="1400">
+              <a:defRPr sz="1300">
                 <a:solidFill>
                   <a:srgbClr val="38BDF8"/>
                 </a:solidFill>
@@ -3287,7 +3293,7 @@
               </a:defRPr>
             </a:pPr>
             <a:r>
-              <a:t>Comprehensive Mathematical Simulation of Data Link Layer Error Control Mechanisms Integrated with Network Simulator 2 (NS-2) Physical Channel Discrete-Event Modeling</a:t>
+              <a:t>A Comprehensive Mathematical Simulation of Data Link Layer Error Control Mechanisms Integrated with Network Simulator 2 (NS-2) Physical Channel Discrete-Event Modeling</a:t>
             </a:r>
           </a:p>
         </p:txBody>
@@ -3300,8 +3306,8 @@
         </p:nvSpPr>
         <p:spPr>
           <a:xfrm>
-            <a:off x="914400" y="2834640"/>
-            <a:ext cx="10360152" cy="1920240"/>
+            <a:off x="914400" y="2788920"/>
+            <a:ext cx="10360152" cy="1965960"/>
           </a:xfrm>
           <a:prstGeom prst="roundRect">
             <a:avLst/>
@@ -3345,8 +3351,8 @@
         </p:nvSpPr>
         <p:spPr>
           <a:xfrm>
-            <a:off x="1143000" y="2999232"/>
-            <a:ext cx="9902952" cy="1591056"/>
+            <a:off x="1143000" y="2935224"/>
+            <a:ext cx="9902952" cy="1673351"/>
           </a:xfrm>
           <a:prstGeom prst="rect">
             <a:avLst/>
@@ -3360,7 +3366,7 @@
           <a:lstStyle/>
           <a:p>
             <a:pPr>
-              <a:defRPr sz="1500" b="1">
+              <a:defRPr sz="1400" b="1">
                 <a:solidFill>
                   <a:srgbClr val="38BDF8"/>
                 </a:solidFill>
@@ -3368,39 +3374,39 @@
               </a:defRPr>
             </a:pPr>
             <a:r>
-              <a:t>Project Overview &amp; Engineering Scope</a:t>
+              <a:t>Project Scope &amp; Technical Abstract</a:t>
             </a:r>
           </a:p>
           <a:p>
             <a:pPr>
               <a:spcBef>
-                <a:spcPts val="400"/>
-              </a:spcBef>
-              <a:defRPr sz="1150">
-                <a:solidFill>
-                  <a:srgbClr val="F8FAFC"/>
-                </a:solidFill>
-                <a:latin typeface="Segoe UI"/>
-              </a:defRPr>
-            </a:pPr>
-            <a:r>
-              <a:t>This project presents an end-to-end interactive simulation platform designed to model Data Link Layer error control mechanisms, physical channel noise propagation, mathematical syndrome verification, and Network Simulator 2 (NS-2) discrete-event packet loss modeling. The platform unites five foundational error control algorithms—1D Parity, 2D Parity Matrix, Hamming Code (7, 4), Internet Checksum (RFC 1071), and Cyclic Redundancy Check (CRC)—with an interactive noise injection workbench, automated Forward Error Correction (FEC), and real-time trace file analytics.</a:t>
-            </a:r>
-          </a:p>
-          <a:p>
-            <a:pPr>
-              <a:spcBef>
-                <a:spcPts val="400"/>
+                <a:spcPts val="300"/>
               </a:spcBef>
               <a:defRPr sz="1100">
                 <a:solidFill>
+                  <a:srgbClr val="F8FAFC"/>
+                </a:solidFill>
+                <a:latin typeface="Segoe UI"/>
+              </a:defRPr>
+            </a:pPr>
+            <a:r>
+              <a:t>This project presents an enterprise-grade academic simulation platform designed to model Data Link Layer error control mechanisms, physical transmission channel noise propagation, mathematical syndrome verification, and Network Simulator 2 (NS-2) discrete-event packet loss modeling. The platform unifies five foundational error control techniques—1D Parity, 2D Parity Matrix, Hamming Code (7, 4), Internet Checksum (RFC 1071), and Cyclic Redundancy Check (CRC)—alongside an interactive error-injection workbench and real-time trace file analytics.</a:t>
+            </a:r>
+          </a:p>
+          <a:p>
+            <a:pPr>
+              <a:spcBef>
+                <a:spcPts val="300"/>
+              </a:spcBef>
+              <a:defRPr sz="1050">
+                <a:solidFill>
                   <a:srgbClr val="94A3B8"/>
                 </a:solidFill>
                 <a:latin typeface="Segoe UI"/>
               </a:defRPr>
             </a:pPr>
             <a:r>
-              <a:t>By pairing rigorous mathematical encoding with discrete-event network channel simulation, students and researchers can dynamically inspect every stage of network transmission: codeword construction, bitwise noise injection, syndrome evaluation, and packet recovery across duplex links.</a:t>
+              <a:t>By pairing rigorous discrete mathematics with discrete-event network simulation, students and professors can dynamically inspect every stage of network transmission: codeword construction, bitwise noise injection, syndrome evaluation, and autonomous packet recovery across simulated duplex links.</a:t>
             </a:r>
           </a:p>
         </p:txBody>
@@ -3413,8 +3419,8 @@
         </p:nvSpPr>
         <p:spPr>
           <a:xfrm>
-            <a:off x="914400" y="4937760"/>
-            <a:ext cx="10360152" cy="1463040"/>
+            <a:off x="914400" y="4892040"/>
+            <a:ext cx="10360152" cy="1508760"/>
           </a:xfrm>
           <a:prstGeom prst="roundRect">
             <a:avLst/>
@@ -3458,7 +3464,7 @@
         </p:nvSpPr>
         <p:spPr>
           <a:xfrm>
-            <a:off x="1143000" y="5029200"/>
+            <a:off x="1143000" y="4983480"/>
             <a:ext cx="4572000" cy="274320"/>
           </a:xfrm>
           <a:prstGeom prst="rect">
@@ -3473,7 +3479,7 @@
           <a:lstStyle/>
           <a:p>
             <a:pPr>
-              <a:defRPr sz="1150" b="1">
+              <a:defRPr sz="1100" b="1">
                 <a:solidFill>
                   <a:srgbClr val="38BDF8"/>
                 </a:solidFill>
@@ -3494,8 +3500,8 @@
         </p:nvSpPr>
         <p:spPr>
           <a:xfrm>
-            <a:off x="1143000" y="5349240"/>
-            <a:ext cx="3291840" cy="960120"/>
+            <a:off x="1143000" y="5303520"/>
+            <a:ext cx="3291840" cy="1005840"/>
           </a:xfrm>
           <a:prstGeom prst="rect">
             <a:avLst/>
@@ -3509,7 +3515,7 @@
           <a:lstStyle/>
           <a:p>
             <a:pPr>
-              <a:defRPr sz="1400" b="1">
+              <a:defRPr sz="1350" b="1">
                 <a:solidFill>
                   <a:srgbClr val="F8FAFC"/>
                 </a:solidFill>
@@ -3525,7 +3531,7 @@
               <a:spcBef>
                 <a:spcPts val="200"/>
               </a:spcBef>
-              <a:defRPr sz="1050">
+              <a:defRPr sz="1000">
                 <a:solidFill>
                   <a:srgbClr val="94A3B8"/>
                 </a:solidFill>
@@ -3550,8 +3556,8 @@
         </p:nvSpPr>
         <p:spPr>
           <a:xfrm>
-            <a:off x="4572000" y="5349240"/>
-            <a:ext cx="3291840" cy="960120"/>
+            <a:off x="4572000" y="5303520"/>
+            <a:ext cx="3291840" cy="1005840"/>
           </a:xfrm>
           <a:prstGeom prst="rect">
             <a:avLst/>
@@ -3565,7 +3571,7 @@
           <a:lstStyle/>
           <a:p>
             <a:pPr>
-              <a:defRPr sz="1400" b="1">
+              <a:defRPr sz="1350" b="1">
                 <a:solidFill>
                   <a:srgbClr val="F8FAFC"/>
                 </a:solidFill>
@@ -3581,7 +3587,7 @@
               <a:spcBef>
                 <a:spcPts val="200"/>
               </a:spcBef>
-              <a:defRPr sz="1050">
+              <a:defRPr sz="1000">
                 <a:solidFill>
                   <a:srgbClr val="94A3B8"/>
                 </a:solidFill>
@@ -3606,8 +3612,8 @@
         </p:nvSpPr>
         <p:spPr>
           <a:xfrm>
-            <a:off x="8001000" y="5349240"/>
-            <a:ext cx="3291840" cy="960120"/>
+            <a:off x="8001000" y="5303520"/>
+            <a:ext cx="3291840" cy="1005840"/>
           </a:xfrm>
           <a:prstGeom prst="rect">
             <a:avLst/>
@@ -3621,7 +3627,7 @@
           <a:lstStyle/>
           <a:p>
             <a:pPr>
-              <a:defRPr sz="1400" b="1">
+              <a:defRPr sz="1350" b="1">
                 <a:solidFill>
                   <a:srgbClr val="F8FAFC"/>
                 </a:solidFill>
@@ -3637,7 +3643,7 @@
               <a:spcBef>
                 <a:spcPts val="200"/>
               </a:spcBef>
-              <a:defRPr sz="1050">
+              <a:defRPr sz="1000">
                 <a:solidFill>
                   <a:srgbClr val="94A3B8"/>
                 </a:solidFill>
@@ -3746,7 +3752,7 @@
               </a:defRPr>
             </a:pPr>
             <a:r>
-              <a:t>●  EMPIRICAL VALIDATION</a:t>
+              <a:t>●  ALGORITHM 4 OF 5: PART A</a:t>
             </a:r>
           </a:p>
         </p:txBody>
@@ -3774,7 +3780,7 @@
           <a:lstStyle/>
           <a:p>
             <a:pPr>
-              <a:defRPr sz="2200" b="1">
+              <a:defRPr sz="2100" b="1">
                 <a:solidFill>
                   <a:srgbClr val="F8FAFC"/>
                 </a:solidFill>
@@ -3782,7 +3788,7 @@
               </a:defRPr>
             </a:pPr>
             <a:r>
-              <a:t>Multi-Technique NS-2 Verification Matrix</a:t>
+              <a:t>Internet Checksum: RFC 1071 Specifications</a:t>
             </a:r>
           </a:p>
         </p:txBody>
@@ -3810,7 +3816,2569 @@
           <a:lstStyle/>
           <a:p>
             <a:pPr>
-              <a:defRPr sz="1200">
+              <a:defRPr sz="1150">
+                <a:solidFill>
+                  <a:srgbClr val="94A3B8"/>
+                </a:solidFill>
+                <a:latin typeface="Segoe UI"/>
+              </a:defRPr>
+            </a:pPr>
+            <a:r>
+              <a:t>1's complement arithmetic, word segmentation, and end-around carry mechanics</a:t>
+            </a:r>
+          </a:p>
+        </p:txBody>
+      </p:sp>
+      <p:sp>
+        <p:nvSpPr>
+          <p:cNvPr id="6" name="Rounded Rectangle 5"/>
+          <p:cNvSpPr/>
+          <p:nvPr/>
+        </p:nvSpPr>
+        <p:spPr>
+          <a:xfrm>
+            <a:off x="731520" y="1600200"/>
+            <a:ext cx="5212080" cy="4846320"/>
+          </a:xfrm>
+          <a:prstGeom prst="roundRect">
+            <a:avLst/>
+          </a:prstGeom>
+          <a:solidFill>
+            <a:srgbClr val="1E293B"/>
+          </a:solidFill>
+          <a:ln w="19050">
+            <a:solidFill>
+              <a:srgbClr val="334155"/>
+            </a:solidFill>
+          </a:ln>
+        </p:spPr>
+        <p:style>
+          <a:lnRef idx="1">
+            <a:schemeClr val="accent1"/>
+          </a:lnRef>
+          <a:fillRef idx="3">
+            <a:schemeClr val="accent1"/>
+          </a:fillRef>
+          <a:effectRef idx="2">
+            <a:schemeClr val="accent1"/>
+          </a:effectRef>
+          <a:fontRef idx="minor">
+            <a:schemeClr val="lt1"/>
+          </a:fontRef>
+        </p:style>
+        <p:txBody>
+          <a:bodyPr rtlCol="0" anchor="ctr"/>
+          <a:lstStyle/>
+          <a:p>
+            <a:pPr algn="ctr"/>
+          </a:p>
+        </p:txBody>
+      </p:sp>
+      <p:sp>
+        <p:nvSpPr>
+          <p:cNvPr id="7" name="TextBox 6"/>
+          <p:cNvSpPr txBox="1"/>
+          <p:nvPr/>
+        </p:nvSpPr>
+        <p:spPr>
+          <a:xfrm>
+            <a:off x="960120" y="1746504"/>
+            <a:ext cx="4754880" cy="4553712"/>
+          </a:xfrm>
+          <a:prstGeom prst="rect">
+            <a:avLst/>
+          </a:prstGeom>
+          <a:noFill/>
+        </p:spPr>
+        <p:txBody>
+          <a:bodyPr wrap="square">
+            <a:spAutoFit/>
+          </a:bodyPr>
+          <a:lstStyle/>
+          <a:p>
+            <a:pPr>
+              <a:defRPr sz="1400" b="1">
+                <a:solidFill>
+                  <a:srgbClr val="38BDF8"/>
+                </a:solidFill>
+                <a:latin typeface="Segoe UI"/>
+              </a:defRPr>
+            </a:pPr>
+            <a:r>
+              <a:t>RFC 1071 Standard Specification &amp; 1's Complement</a:t>
+            </a:r>
+          </a:p>
+          <a:p>
+            <a:pPr>
+              <a:spcBef>
+                <a:spcPts val="200"/>
+              </a:spcBef>
+              <a:defRPr sz="1050">
+                <a:solidFill>
+                  <a:srgbClr val="94A3B8"/>
+                </a:solidFill>
+                <a:latin typeface="Segoe UI"/>
+              </a:defRPr>
+            </a:pPr>
+            <a:r>
+              <a:t>Software-oriented design for router forwarding engines and IP stacks:</a:t>
+            </a:r>
+          </a:p>
+          <a:p>
+            <a:pPr>
+              <a:spcBef>
+                <a:spcPts val="500"/>
+              </a:spcBef>
+              <a:defRPr sz="1050">
+                <a:solidFill>
+                  <a:srgbClr val="F8FAFC"/>
+                </a:solidFill>
+                <a:latin typeface="Segoe UI"/>
+              </a:defRPr>
+            </a:pPr>
+            <a:r>
+              <a:t>The Internet Checksum is the foundational error-detection algorithm standardized in RFC 1071 and deployed across the core protocols of the Internet Protocol Suite, including the IPv4 header checksum, TCP segment integrity, and UDP datagram validation. The algorithm was intentionally designed for high-speed software execution inside network routers and host operating system kernels, where dedicated hardware division circuits are unavailable.</a:t>
+            </a:r>
+          </a:p>
+          <a:p>
+            <a:pPr>
+              <a:spcBef>
+                <a:spcPts val="500"/>
+              </a:spcBef>
+              <a:defRPr sz="1000">
+                <a:solidFill>
+                  <a:srgbClr val="94A3B8"/>
+                </a:solidFill>
+                <a:latin typeface="Segoe UI"/>
+              </a:defRPr>
+            </a:pPr>
+            <a:r>
+              <a:t>The algorithm segments the input byte stream into uniform k-bit words (standardized as 16-bit integers in IPv4 and TCP). These 16-bit words are summed sequentially using One's Complement Arithmetic. Unlike conventional two's complement addition, one's complement arithmetic treats signed and unsigned numbers such that negative values are bitwise inversions of positive values, establishing an arithmetic field where zero has two representations: positive zero (0x0000) and negative zero (0xFFFF).</a:t>
+            </a:r>
+          </a:p>
+        </p:txBody>
+      </p:sp>
+      <p:sp>
+        <p:nvSpPr>
+          <p:cNvPr id="8" name="Rounded Rectangle 7"/>
+          <p:cNvSpPr/>
+          <p:nvPr/>
+        </p:nvSpPr>
+        <p:spPr>
+          <a:xfrm>
+            <a:off x="6217920" y="1600200"/>
+            <a:ext cx="5212080" cy="4846320"/>
+          </a:xfrm>
+          <a:prstGeom prst="roundRect">
+            <a:avLst/>
+          </a:prstGeom>
+          <a:solidFill>
+            <a:srgbClr val="1E293B"/>
+          </a:solidFill>
+          <a:ln w="19050">
+            <a:solidFill>
+              <a:srgbClr val="334155"/>
+            </a:solidFill>
+          </a:ln>
+        </p:spPr>
+        <p:style>
+          <a:lnRef idx="1">
+            <a:schemeClr val="accent1"/>
+          </a:lnRef>
+          <a:fillRef idx="3">
+            <a:schemeClr val="accent1"/>
+          </a:fillRef>
+          <a:effectRef idx="2">
+            <a:schemeClr val="accent1"/>
+          </a:effectRef>
+          <a:fontRef idx="minor">
+            <a:schemeClr val="lt1"/>
+          </a:fontRef>
+        </p:style>
+        <p:txBody>
+          <a:bodyPr rtlCol="0" anchor="ctr"/>
+          <a:lstStyle/>
+          <a:p>
+            <a:pPr algn="ctr"/>
+          </a:p>
+        </p:txBody>
+      </p:sp>
+      <p:sp>
+        <p:nvSpPr>
+          <p:cNvPr id="9" name="TextBox 8"/>
+          <p:cNvSpPr txBox="1"/>
+          <p:nvPr/>
+        </p:nvSpPr>
+        <p:spPr>
+          <a:xfrm>
+            <a:off x="6446520" y="1746504"/>
+            <a:ext cx="4754880" cy="4553712"/>
+          </a:xfrm>
+          <a:prstGeom prst="rect">
+            <a:avLst/>
+          </a:prstGeom>
+          <a:noFill/>
+        </p:spPr>
+        <p:txBody>
+          <a:bodyPr wrap="square">
+            <a:spAutoFit/>
+          </a:bodyPr>
+          <a:lstStyle/>
+          <a:p>
+            <a:pPr>
+              <a:defRPr sz="1400" b="1">
+                <a:solidFill>
+                  <a:srgbClr val="38BDF8"/>
+                </a:solidFill>
+                <a:latin typeface="Segoe UI"/>
+              </a:defRPr>
+            </a:pPr>
+            <a:r>
+              <a:t>End-Around Carry Wraparound &amp; Checksum Inversion</a:t>
+            </a:r>
+          </a:p>
+          <a:p>
+            <a:pPr>
+              <a:spcBef>
+                <a:spcPts val="200"/>
+              </a:spcBef>
+              <a:defRPr sz="1050">
+                <a:solidFill>
+                  <a:srgbClr val="94A3B8"/>
+                </a:solidFill>
+                <a:latin typeface="Segoe UI"/>
+              </a:defRPr>
+            </a:pPr>
+            <a:r>
+              <a:t>Mathematical wraparound of high-order overflow carry bits:</a:t>
+            </a:r>
+          </a:p>
+          <a:p>
+            <a:pPr>
+              <a:spcBef>
+                <a:spcPts val="500"/>
+              </a:spcBef>
+              <a:defRPr sz="1050">
+                <a:solidFill>
+                  <a:srgbClr val="F8FAFC"/>
+                </a:solidFill>
+                <a:latin typeface="Segoe UI"/>
+              </a:defRPr>
+            </a:pPr>
+            <a:r>
+              <a:t>During the sequential accumulation of 16-bit words, an addition will frequently generate an overflow carry bit beyond the 16th bit position (bit 17). In one's complement arithmetic, this overflow carry is not discarded; instead, it is wrapped around and added back into the least significant bit (LSB), a process designated as end-around carry. This ensures that carries from high-order bit positions contribute to lower-order bit positions, preserving arithmetic symmetry.</a:t>
+            </a:r>
+          </a:p>
+          <a:p>
+            <a:pPr>
+              <a:spcBef>
+                <a:spcPts val="500"/>
+              </a:spcBef>
+              <a:defRPr sz="1000">
+                <a:solidFill>
+                  <a:srgbClr val="94A3B8"/>
+                </a:solidFill>
+                <a:latin typeface="Segoe UI"/>
+              </a:defRPr>
+            </a:pPr>
+            <a:r>
+              <a:t>Once all 16-bit words have been accumulated into the running sum, the bitwise one's complement (NOT operation) of the final sum is calculated. This resulting 16-bit value is placed into the Checksum field of the packet header and transmitted alongside the payload.</a:t>
+            </a:r>
+          </a:p>
+        </p:txBody>
+      </p:sp>
+    </p:spTree>
+  </p:cSld>
+  <p:clrMapOvr>
+    <a:masterClrMapping/>
+  </p:clrMapOvr>
+</p:sld>
+</file>
+
+<file path=ppt/slides/slide11.xml><?xml version="1.0" encoding="utf-8"?>
+<p:sld xmlns:a="http://schemas.openxmlformats.org/drawingml/2006/main" xmlns:p="http://schemas.openxmlformats.org/presentationml/2006/main" xmlns:r="http://schemas.openxmlformats.org/officeDocument/2006/relationships">
+  <p:cSld>
+    <p:spTree>
+      <p:nvGrpSpPr>
+        <p:cNvPr id="1" name=""/>
+        <p:cNvGrpSpPr/>
+        <p:nvPr/>
+      </p:nvGrpSpPr>
+      <p:grpSpPr/>
+      <p:sp>
+        <p:nvSpPr>
+          <p:cNvPr id="2" name="Rectangle 1"/>
+          <p:cNvSpPr/>
+          <p:nvPr/>
+        </p:nvSpPr>
+        <p:spPr>
+          <a:xfrm>
+            <a:off x="0" y="0"/>
+            <a:ext cx="12191695" cy="6858000"/>
+          </a:xfrm>
+          <a:prstGeom prst="rect">
+            <a:avLst/>
+          </a:prstGeom>
+          <a:solidFill>
+            <a:srgbClr val="0F172A"/>
+          </a:solidFill>
+          <a:ln>
+            <a:noFill/>
+          </a:ln>
+        </p:spPr>
+        <p:style>
+          <a:lnRef idx="1">
+            <a:schemeClr val="accent1"/>
+          </a:lnRef>
+          <a:fillRef idx="3">
+            <a:schemeClr val="accent1"/>
+          </a:fillRef>
+          <a:effectRef idx="2">
+            <a:schemeClr val="accent1"/>
+          </a:effectRef>
+          <a:fontRef idx="minor">
+            <a:schemeClr val="lt1"/>
+          </a:fontRef>
+        </p:style>
+        <p:txBody>
+          <a:bodyPr rtlCol="0" anchor="ctr"/>
+          <a:lstStyle/>
+          <a:p>
+            <a:pPr algn="ctr"/>
+          </a:p>
+        </p:txBody>
+      </p:sp>
+      <p:sp>
+        <p:nvSpPr>
+          <p:cNvPr id="3" name="TextBox 2"/>
+          <p:cNvSpPr txBox="1"/>
+          <p:nvPr/>
+        </p:nvSpPr>
+        <p:spPr>
+          <a:xfrm>
+            <a:off x="731520" y="320040"/>
+            <a:ext cx="7315200" cy="320040"/>
+          </a:xfrm>
+          <a:prstGeom prst="rect">
+            <a:avLst/>
+          </a:prstGeom>
+          <a:noFill/>
+        </p:spPr>
+        <p:txBody>
+          <a:bodyPr wrap="square">
+            <a:spAutoFit/>
+          </a:bodyPr>
+          <a:lstStyle/>
+          <a:p>
+            <a:pPr>
+              <a:defRPr sz="1050" b="1">
+                <a:solidFill>
+                  <a:srgbClr val="38BDF8"/>
+                </a:solidFill>
+                <a:latin typeface="Segoe UI"/>
+              </a:defRPr>
+            </a:pPr>
+            <a:r>
+              <a:t>●  ALGORITHM 4 OF 5: PART B</a:t>
+            </a:r>
+          </a:p>
+        </p:txBody>
+      </p:sp>
+      <p:sp>
+        <p:nvSpPr>
+          <p:cNvPr id="4" name="TextBox 3"/>
+          <p:cNvSpPr txBox="1"/>
+          <p:nvPr/>
+        </p:nvSpPr>
+        <p:spPr>
+          <a:xfrm>
+            <a:off x="731520" y="594360"/>
+            <a:ext cx="10725912" cy="594360"/>
+          </a:xfrm>
+          <a:prstGeom prst="rect">
+            <a:avLst/>
+          </a:prstGeom>
+          <a:noFill/>
+        </p:spPr>
+        <p:txBody>
+          <a:bodyPr wrap="square">
+            <a:spAutoFit/>
+          </a:bodyPr>
+          <a:lstStyle/>
+          <a:p>
+            <a:pPr>
+              <a:defRPr sz="2100" b="1">
+                <a:solidFill>
+                  <a:srgbClr val="F8FAFC"/>
+                </a:solidFill>
+                <a:latin typeface="Segoe UI"/>
+              </a:defRPr>
+            </a:pPr>
+            <a:r>
+              <a:t>Internet Checksum: Receiver Zero-Sum &amp; NS-2</a:t>
+            </a:r>
+          </a:p>
+        </p:txBody>
+      </p:sp>
+      <p:sp>
+        <p:nvSpPr>
+          <p:cNvPr id="5" name="TextBox 4"/>
+          <p:cNvSpPr txBox="1"/>
+          <p:nvPr/>
+        </p:nvSpPr>
+        <p:spPr>
+          <a:xfrm>
+            <a:off x="731520" y="1115568"/>
+            <a:ext cx="10725912" cy="365760"/>
+          </a:xfrm>
+          <a:prstGeom prst="rect">
+            <a:avLst/>
+          </a:prstGeom>
+          <a:noFill/>
+        </p:spPr>
+        <p:txBody>
+          <a:bodyPr wrap="square">
+            <a:spAutoFit/>
+          </a:bodyPr>
+          <a:lstStyle/>
+          <a:p>
+            <a:pPr>
+              <a:defRPr sz="1150">
+                <a:solidFill>
+                  <a:srgbClr val="94A3B8"/>
+                </a:solidFill>
+                <a:latin typeface="Segoe UI"/>
+              </a:defRPr>
+            </a:pPr>
+            <a:r>
+              <a:t>Receiver zero-check, algorithmic vulnerabilities, and packet drop modeling</a:t>
+            </a:r>
+          </a:p>
+        </p:txBody>
+      </p:sp>
+      <p:sp>
+        <p:nvSpPr>
+          <p:cNvPr id="6" name="Rounded Rectangle 5"/>
+          <p:cNvSpPr/>
+          <p:nvPr/>
+        </p:nvSpPr>
+        <p:spPr>
+          <a:xfrm>
+            <a:off x="731520" y="1600200"/>
+            <a:ext cx="5212080" cy="4846320"/>
+          </a:xfrm>
+          <a:prstGeom prst="roundRect">
+            <a:avLst/>
+          </a:prstGeom>
+          <a:solidFill>
+            <a:srgbClr val="1E293B"/>
+          </a:solidFill>
+          <a:ln w="19050">
+            <a:solidFill>
+              <a:srgbClr val="334155"/>
+            </a:solidFill>
+          </a:ln>
+        </p:spPr>
+        <p:style>
+          <a:lnRef idx="1">
+            <a:schemeClr val="accent1"/>
+          </a:lnRef>
+          <a:fillRef idx="3">
+            <a:schemeClr val="accent1"/>
+          </a:fillRef>
+          <a:effectRef idx="2">
+            <a:schemeClr val="accent1"/>
+          </a:effectRef>
+          <a:fontRef idx="minor">
+            <a:schemeClr val="lt1"/>
+          </a:fontRef>
+        </p:style>
+        <p:txBody>
+          <a:bodyPr rtlCol="0" anchor="ctr"/>
+          <a:lstStyle/>
+          <a:p>
+            <a:pPr algn="ctr"/>
+          </a:p>
+        </p:txBody>
+      </p:sp>
+      <p:sp>
+        <p:nvSpPr>
+          <p:cNvPr id="7" name="TextBox 6"/>
+          <p:cNvSpPr txBox="1"/>
+          <p:nvPr/>
+        </p:nvSpPr>
+        <p:spPr>
+          <a:xfrm>
+            <a:off x="960120" y="1746504"/>
+            <a:ext cx="4754880" cy="4553712"/>
+          </a:xfrm>
+          <a:prstGeom prst="rect">
+            <a:avLst/>
+          </a:prstGeom>
+          <a:noFill/>
+        </p:spPr>
+        <p:txBody>
+          <a:bodyPr wrap="square">
+            <a:spAutoFit/>
+          </a:bodyPr>
+          <a:lstStyle/>
+          <a:p>
+            <a:pPr>
+              <a:defRPr sz="1400" b="1">
+                <a:solidFill>
+                  <a:srgbClr val="38BDF8"/>
+                </a:solidFill>
+                <a:latin typeface="Segoe UI"/>
+              </a:defRPr>
+            </a:pPr>
+            <a:r>
+              <a:t>Receiver Zero-Sum Verification &amp; Efficiency</a:t>
+            </a:r>
+          </a:p>
+          <a:p>
+            <a:pPr>
+              <a:spcBef>
+                <a:spcPts val="200"/>
+              </a:spcBef>
+              <a:defRPr sz="1050">
+                <a:solidFill>
+                  <a:srgbClr val="94A3B8"/>
+                </a:solidFill>
+                <a:latin typeface="Segoe UI"/>
+              </a:defRPr>
+            </a:pPr>
+            <a:r>
+              <a:t>High-speed router verification and incremental TTL checksum updates:</a:t>
+            </a:r>
+          </a:p>
+          <a:p>
+            <a:pPr>
+              <a:spcBef>
+                <a:spcPts val="500"/>
+              </a:spcBef>
+              <a:defRPr sz="1050">
+                <a:solidFill>
+                  <a:srgbClr val="F8FAFC"/>
+                </a:solidFill>
+                <a:latin typeface="Segoe UI"/>
+              </a:defRPr>
+            </a:pPr>
+            <a:r>
+              <a:t>At the receiving destination, the verification procedure is exceptionally elegant and computationally optimal for high-throughput router forwarding engines: the receiver sums all incoming 16-bit data words including the received checksum field using one's complement addition. If no bits were corrupted during transit, the resulting sum must evaluate to all 1-bits (0xFFFF), which inverts to 0x0000 (zero) upon complementation.</a:t>
+            </a:r>
+          </a:p>
+          <a:p>
+            <a:pPr>
+              <a:spcBef>
+                <a:spcPts val="500"/>
+              </a:spcBef>
+              <a:defRPr sz="1000">
+                <a:solidFill>
+                  <a:srgbClr val="94A3B8"/>
+                </a:solidFill>
+                <a:latin typeface="Segoe UI"/>
+              </a:defRPr>
+            </a:pPr>
+            <a:r>
+              <a:t>Any non-zero result alerts the receiving stack that transmission corruption occurred, prompting the immediate discard of the packet. Because one's complement addition is associative and commutative, intermediate routers can update the IPv4 header checksum incrementally when decrementing the Time-to-Live (TTL) field without recalculating the entire checksum from scratch: C' = C + m - m'.</a:t>
+            </a:r>
+          </a:p>
+        </p:txBody>
+      </p:sp>
+      <p:sp>
+        <p:nvSpPr>
+          <p:cNvPr id="8" name="Rounded Rectangle 7"/>
+          <p:cNvSpPr/>
+          <p:nvPr/>
+        </p:nvSpPr>
+        <p:spPr>
+          <a:xfrm>
+            <a:off x="6217920" y="1600200"/>
+            <a:ext cx="5212080" cy="4846320"/>
+          </a:xfrm>
+          <a:prstGeom prst="roundRect">
+            <a:avLst/>
+          </a:prstGeom>
+          <a:solidFill>
+            <a:srgbClr val="1E293B"/>
+          </a:solidFill>
+          <a:ln w="19050">
+            <a:solidFill>
+              <a:srgbClr val="334155"/>
+            </a:solidFill>
+          </a:ln>
+        </p:spPr>
+        <p:style>
+          <a:lnRef idx="1">
+            <a:schemeClr val="accent1"/>
+          </a:lnRef>
+          <a:fillRef idx="3">
+            <a:schemeClr val="accent1"/>
+          </a:fillRef>
+          <a:effectRef idx="2">
+            <a:schemeClr val="accent1"/>
+          </a:effectRef>
+          <a:fontRef idx="minor">
+            <a:schemeClr val="lt1"/>
+          </a:fontRef>
+        </p:style>
+        <p:txBody>
+          <a:bodyPr rtlCol="0" anchor="ctr"/>
+          <a:lstStyle/>
+          <a:p>
+            <a:pPr algn="ctr"/>
+          </a:p>
+        </p:txBody>
+      </p:sp>
+      <p:sp>
+        <p:nvSpPr>
+          <p:cNvPr id="9" name="TextBox 8"/>
+          <p:cNvSpPr txBox="1"/>
+          <p:nvPr/>
+        </p:nvSpPr>
+        <p:spPr>
+          <a:xfrm>
+            <a:off x="6446520" y="1746504"/>
+            <a:ext cx="4754880" cy="4553712"/>
+          </a:xfrm>
+          <a:prstGeom prst="rect">
+            <a:avLst/>
+          </a:prstGeom>
+          <a:noFill/>
+        </p:spPr>
+        <p:txBody>
+          <a:bodyPr wrap="square">
+            <a:spAutoFit/>
+          </a:bodyPr>
+          <a:lstStyle/>
+          <a:p>
+            <a:pPr>
+              <a:defRPr sz="1400" b="1">
+                <a:solidFill>
+                  <a:srgbClr val="38BDF8"/>
+                </a:solidFill>
+                <a:latin typeface="Segoe UI"/>
+              </a:defRPr>
+            </a:pPr>
+            <a:r>
+              <a:t>Algorithmic Weaknesses &amp; NS-2 Link Loss Modeling</a:t>
+            </a:r>
+          </a:p>
+          <a:p>
+            <a:pPr>
+              <a:spcBef>
+                <a:spcPts val="200"/>
+              </a:spcBef>
+              <a:defRPr sz="1050">
+                <a:solidFill>
+                  <a:srgbClr val="94A3B8"/>
+                </a:solidFill>
+                <a:latin typeface="Segoe UI"/>
+              </a:defRPr>
+            </a:pPr>
+            <a:r>
+              <a:t>Transposition blind spots, compensating errors, and trace logs (ns2_checksum.tr):</a:t>
+            </a:r>
+          </a:p>
+          <a:p>
+            <a:pPr>
+              <a:spcBef>
+                <a:spcPts val="500"/>
+              </a:spcBef>
+              <a:defRPr sz="1050">
+                <a:solidFill>
+                  <a:srgbClr val="F8FAFC"/>
+                </a:solidFill>
+                <a:latin typeface="Segoe UI"/>
+              </a:defRPr>
+            </a:pPr>
+            <a:r>
+              <a:t>Despite its widespread adoption, the Internet Checksum possesses recognized algorithmic limitations: because addition is commutative, it is completely invariant to word transposition (swapping two 16-bit words leaves the sum unchanged). Furthermore, it cannot detect compensating bit errors where an increment in one word is mathematically cancelled by a decrement in another word. It also fails to detect the insertion or deletion of zero words (0x0000).</a:t>
+            </a:r>
+          </a:p>
+          <a:p>
+            <a:pPr>
+              <a:spcBef>
+                <a:spcPts val="500"/>
+              </a:spcBef>
+              <a:defRPr sz="1000">
+                <a:solidFill>
+                  <a:srgbClr val="94A3B8"/>
+                </a:solidFill>
+                <a:latin typeface="Segoe UI"/>
+              </a:defRPr>
+            </a:pPr>
+            <a:r>
+              <a:t>In our NS-2 simulation bridge, checksum-protected frames traverse the duplex link between Node 0 and Node 1 (ns2_checksum.tr). Corrupted packets that fail the receiver checksum validation trigger immediate link drops, modeling the exact behavior of IP routers encountering corrupted transport headers.</a:t>
+            </a:r>
+          </a:p>
+        </p:txBody>
+      </p:sp>
+    </p:spTree>
+  </p:cSld>
+  <p:clrMapOvr>
+    <a:masterClrMapping/>
+  </p:clrMapOvr>
+</p:sld>
+</file>
+
+<file path=ppt/slides/slide12.xml><?xml version="1.0" encoding="utf-8"?>
+<p:sld xmlns:a="http://schemas.openxmlformats.org/drawingml/2006/main" xmlns:p="http://schemas.openxmlformats.org/presentationml/2006/main" xmlns:r="http://schemas.openxmlformats.org/officeDocument/2006/relationships">
+  <p:cSld>
+    <p:spTree>
+      <p:nvGrpSpPr>
+        <p:cNvPr id="1" name=""/>
+        <p:cNvGrpSpPr/>
+        <p:nvPr/>
+      </p:nvGrpSpPr>
+      <p:grpSpPr/>
+      <p:sp>
+        <p:nvSpPr>
+          <p:cNvPr id="2" name="Rectangle 1"/>
+          <p:cNvSpPr/>
+          <p:nvPr/>
+        </p:nvSpPr>
+        <p:spPr>
+          <a:xfrm>
+            <a:off x="0" y="0"/>
+            <a:ext cx="12191695" cy="6858000"/>
+          </a:xfrm>
+          <a:prstGeom prst="rect">
+            <a:avLst/>
+          </a:prstGeom>
+          <a:solidFill>
+            <a:srgbClr val="0F172A"/>
+          </a:solidFill>
+          <a:ln>
+            <a:noFill/>
+          </a:ln>
+        </p:spPr>
+        <p:style>
+          <a:lnRef idx="1">
+            <a:schemeClr val="accent1"/>
+          </a:lnRef>
+          <a:fillRef idx="3">
+            <a:schemeClr val="accent1"/>
+          </a:fillRef>
+          <a:effectRef idx="2">
+            <a:schemeClr val="accent1"/>
+          </a:effectRef>
+          <a:fontRef idx="minor">
+            <a:schemeClr val="lt1"/>
+          </a:fontRef>
+        </p:style>
+        <p:txBody>
+          <a:bodyPr rtlCol="0" anchor="ctr"/>
+          <a:lstStyle/>
+          <a:p>
+            <a:pPr algn="ctr"/>
+          </a:p>
+        </p:txBody>
+      </p:sp>
+      <p:sp>
+        <p:nvSpPr>
+          <p:cNvPr id="3" name="TextBox 2"/>
+          <p:cNvSpPr txBox="1"/>
+          <p:nvPr/>
+        </p:nvSpPr>
+        <p:spPr>
+          <a:xfrm>
+            <a:off x="731520" y="320040"/>
+            <a:ext cx="7315200" cy="320040"/>
+          </a:xfrm>
+          <a:prstGeom prst="rect">
+            <a:avLst/>
+          </a:prstGeom>
+          <a:noFill/>
+        </p:spPr>
+        <p:txBody>
+          <a:bodyPr wrap="square">
+            <a:spAutoFit/>
+          </a:bodyPr>
+          <a:lstStyle/>
+          <a:p>
+            <a:pPr>
+              <a:defRPr sz="1050" b="1">
+                <a:solidFill>
+                  <a:srgbClr val="38BDF8"/>
+                </a:solidFill>
+                <a:latin typeface="Segoe UI"/>
+              </a:defRPr>
+            </a:pPr>
+            <a:r>
+              <a:t>●  ALGORITHM 5 OF 5: PART A</a:t>
+            </a:r>
+          </a:p>
+        </p:txBody>
+      </p:sp>
+      <p:sp>
+        <p:nvSpPr>
+          <p:cNvPr id="4" name="TextBox 3"/>
+          <p:cNvSpPr txBox="1"/>
+          <p:nvPr/>
+        </p:nvSpPr>
+        <p:spPr>
+          <a:xfrm>
+            <a:off x="731520" y="594360"/>
+            <a:ext cx="10725912" cy="594360"/>
+          </a:xfrm>
+          <a:prstGeom prst="rect">
+            <a:avLst/>
+          </a:prstGeom>
+          <a:noFill/>
+        </p:spPr>
+        <p:txBody>
+          <a:bodyPr wrap="square">
+            <a:spAutoFit/>
+          </a:bodyPr>
+          <a:lstStyle/>
+          <a:p>
+            <a:pPr>
+              <a:defRPr sz="2100" b="1">
+                <a:solidFill>
+                  <a:srgbClr val="F8FAFC"/>
+                </a:solidFill>
+                <a:latin typeface="Segoe UI"/>
+              </a:defRPr>
+            </a:pPr>
+            <a:r>
+              <a:t>CRC Modulo-2 Division: Galois Field GF(2) Theory</a:t>
+            </a:r>
+          </a:p>
+        </p:txBody>
+      </p:sp>
+      <p:sp>
+        <p:nvSpPr>
+          <p:cNvPr id="5" name="TextBox 4"/>
+          <p:cNvSpPr txBox="1"/>
+          <p:nvPr/>
+        </p:nvSpPr>
+        <p:spPr>
+          <a:xfrm>
+            <a:off x="731520" y="1115568"/>
+            <a:ext cx="10725912" cy="365760"/>
+          </a:xfrm>
+          <a:prstGeom prst="rect">
+            <a:avLst/>
+          </a:prstGeom>
+          <a:noFill/>
+        </p:spPr>
+        <p:txBody>
+          <a:bodyPr wrap="square">
+            <a:spAutoFit/>
+          </a:bodyPr>
+          <a:lstStyle/>
+          <a:p>
+            <a:pPr>
+              <a:defRPr sz="1150">
+                <a:solidFill>
+                  <a:srgbClr val="94A3B8"/>
+                </a:solidFill>
+                <a:latin typeface="Segoe UI"/>
+              </a:defRPr>
+            </a:pPr>
+            <a:r>
+              <a:t>Algebraic coding theory over GF(2), polynomial arithmetic, and Frame Check Sequence generation</a:t>
+            </a:r>
+          </a:p>
+        </p:txBody>
+      </p:sp>
+      <p:sp>
+        <p:nvSpPr>
+          <p:cNvPr id="6" name="Rounded Rectangle 5"/>
+          <p:cNvSpPr/>
+          <p:nvPr/>
+        </p:nvSpPr>
+        <p:spPr>
+          <a:xfrm>
+            <a:off x="731520" y="1600200"/>
+            <a:ext cx="5212080" cy="4846320"/>
+          </a:xfrm>
+          <a:prstGeom prst="roundRect">
+            <a:avLst/>
+          </a:prstGeom>
+          <a:solidFill>
+            <a:srgbClr val="1E293B"/>
+          </a:solidFill>
+          <a:ln w="19050">
+            <a:solidFill>
+              <a:srgbClr val="334155"/>
+            </a:solidFill>
+          </a:ln>
+        </p:spPr>
+        <p:style>
+          <a:lnRef idx="1">
+            <a:schemeClr val="accent1"/>
+          </a:lnRef>
+          <a:fillRef idx="3">
+            <a:schemeClr val="accent1"/>
+          </a:fillRef>
+          <a:effectRef idx="2">
+            <a:schemeClr val="accent1"/>
+          </a:effectRef>
+          <a:fontRef idx="minor">
+            <a:schemeClr val="lt1"/>
+          </a:fontRef>
+        </p:style>
+        <p:txBody>
+          <a:bodyPr rtlCol="0" anchor="ctr"/>
+          <a:lstStyle/>
+          <a:p>
+            <a:pPr algn="ctr"/>
+          </a:p>
+        </p:txBody>
+      </p:sp>
+      <p:sp>
+        <p:nvSpPr>
+          <p:cNvPr id="7" name="TextBox 6"/>
+          <p:cNvSpPr txBox="1"/>
+          <p:nvPr/>
+        </p:nvSpPr>
+        <p:spPr>
+          <a:xfrm>
+            <a:off x="960120" y="1746504"/>
+            <a:ext cx="4754880" cy="4553712"/>
+          </a:xfrm>
+          <a:prstGeom prst="rect">
+            <a:avLst/>
+          </a:prstGeom>
+          <a:noFill/>
+        </p:spPr>
+        <p:txBody>
+          <a:bodyPr wrap="square">
+            <a:spAutoFit/>
+          </a:bodyPr>
+          <a:lstStyle/>
+          <a:p>
+            <a:pPr>
+              <a:defRPr sz="1400" b="1">
+                <a:solidFill>
+                  <a:srgbClr val="38BDF8"/>
+                </a:solidFill>
+                <a:latin typeface="Segoe UI"/>
+              </a:defRPr>
+            </a:pPr>
+            <a:r>
+              <a:t>Algebraic Foundations &amp; Polynomial Ring Arithmetic</a:t>
+            </a:r>
+          </a:p>
+          <a:p>
+            <a:pPr>
+              <a:spcBef>
+                <a:spcPts val="200"/>
+              </a:spcBef>
+              <a:defRPr sz="1050">
+                <a:solidFill>
+                  <a:srgbClr val="94A3B8"/>
+                </a:solidFill>
+                <a:latin typeface="Segoe UI"/>
+              </a:defRPr>
+            </a:pPr>
+            <a:r>
+              <a:t>Galois Field GF(2) coefficients and XOR addition without borrow:</a:t>
+            </a:r>
+          </a:p>
+          <a:p>
+            <a:pPr>
+              <a:spcBef>
+                <a:spcPts val="500"/>
+              </a:spcBef>
+              <a:defRPr sz="1050">
+                <a:solidFill>
+                  <a:srgbClr val="F8FAFC"/>
+                </a:solidFill>
+                <a:latin typeface="Segoe UI"/>
+              </a:defRPr>
+            </a:pPr>
+            <a:r>
+              <a:t>Cyclic Redundancy Check (CRC) is the most powerful, mathematically rigorous, and widely deployed error-detection mechanism in modern computer networking, serving as the mandatory standard for Ethernet (IEEE 802.3), Wi-Fi (IEEE 802.11), USB, SATA, and cellular wireless links. CRC treats binary data sequences as algebraic polynomials whose coefficients belong to the Galois Field of two elements, GF(2).</a:t>
+            </a:r>
+          </a:p>
+          <a:p>
+            <a:pPr>
+              <a:spcBef>
+                <a:spcPts val="500"/>
+              </a:spcBef>
+              <a:defRPr sz="1000">
+                <a:solidFill>
+                  <a:srgbClr val="94A3B8"/>
+                </a:solidFill>
+                <a:latin typeface="Segoe UI"/>
+              </a:defRPr>
+            </a:pPr>
+            <a:r>
+              <a:t>In GF(2) polynomial arithmetic, addition and subtraction are identical and equivalent to the bitwise Exclusive-OR (XOR) operation performed without carries or borrows. For example, 1 + 1 = 0, 1 + 0 = 1, and 0 + 0 = 0. A binary data sequence such as '1101001' is represented as the polynomial D(x) = x^6 + x^5 + x^3 + 1. The sender and receiver agree in advance upon a generator polynomial G(x) of degree r, where the most significant bit and least significant bit are always 1.</a:t>
+            </a:r>
+          </a:p>
+        </p:txBody>
+      </p:sp>
+      <p:sp>
+        <p:nvSpPr>
+          <p:cNvPr id="8" name="Rounded Rectangle 7"/>
+          <p:cNvSpPr/>
+          <p:nvPr/>
+        </p:nvSpPr>
+        <p:spPr>
+          <a:xfrm>
+            <a:off x="6217920" y="1600200"/>
+            <a:ext cx="5212080" cy="4846320"/>
+          </a:xfrm>
+          <a:prstGeom prst="roundRect">
+            <a:avLst/>
+          </a:prstGeom>
+          <a:solidFill>
+            <a:srgbClr val="1E293B"/>
+          </a:solidFill>
+          <a:ln w="19050">
+            <a:solidFill>
+              <a:srgbClr val="334155"/>
+            </a:solidFill>
+          </a:ln>
+        </p:spPr>
+        <p:style>
+          <a:lnRef idx="1">
+            <a:schemeClr val="accent1"/>
+          </a:lnRef>
+          <a:fillRef idx="3">
+            <a:schemeClr val="accent1"/>
+          </a:fillRef>
+          <a:effectRef idx="2">
+            <a:schemeClr val="accent1"/>
+          </a:effectRef>
+          <a:fontRef idx="minor">
+            <a:schemeClr val="lt1"/>
+          </a:fontRef>
+        </p:style>
+        <p:txBody>
+          <a:bodyPr rtlCol="0" anchor="ctr"/>
+          <a:lstStyle/>
+          <a:p>
+            <a:pPr algn="ctr"/>
+          </a:p>
+        </p:txBody>
+      </p:sp>
+      <p:sp>
+        <p:nvSpPr>
+          <p:cNvPr id="9" name="TextBox 8"/>
+          <p:cNvSpPr txBox="1"/>
+          <p:nvPr/>
+        </p:nvSpPr>
+        <p:spPr>
+          <a:xfrm>
+            <a:off x="6446520" y="1746504"/>
+            <a:ext cx="4754880" cy="4553712"/>
+          </a:xfrm>
+          <a:prstGeom prst="rect">
+            <a:avLst/>
+          </a:prstGeom>
+          <a:noFill/>
+        </p:spPr>
+        <p:txBody>
+          <a:bodyPr wrap="square">
+            <a:spAutoFit/>
+          </a:bodyPr>
+          <a:lstStyle/>
+          <a:p>
+            <a:pPr>
+              <a:defRPr sz="1400" b="1">
+                <a:solidFill>
+                  <a:srgbClr val="38BDF8"/>
+                </a:solidFill>
+                <a:latin typeface="Segoe UI"/>
+              </a:defRPr>
+            </a:pPr>
+            <a:r>
+              <a:t>Sender Encoding Algorithm &amp; Frame Check Sequence (FCS)</a:t>
+            </a:r>
+          </a:p>
+          <a:p>
+            <a:pPr>
+              <a:spcBef>
+                <a:spcPts val="200"/>
+              </a:spcBef>
+              <a:defRPr sz="1050">
+                <a:solidFill>
+                  <a:srgbClr val="94A3B8"/>
+                </a:solidFill>
+                <a:latin typeface="Segoe UI"/>
+              </a:defRPr>
+            </a:pPr>
+            <a:r>
+              <a:t>Modulo-2 polynomial long division and transmitted codeword construction:</a:t>
+            </a:r>
+          </a:p>
+          <a:p>
+            <a:pPr>
+              <a:spcBef>
+                <a:spcPts val="500"/>
+              </a:spcBef>
+              <a:defRPr sz="1050">
+                <a:solidFill>
+                  <a:srgbClr val="F8FAFC"/>
+                </a:solidFill>
+                <a:latin typeface="Segoe UI"/>
+              </a:defRPr>
+            </a:pPr>
+            <a:r>
+              <a:t>The sender encoding procedure proceeds in four formal algebraic steps: First, the n-bit data polynomial D(x) is multiplied by x^r, effectively shifting the data left by r bit positions and appending r zero bits: D(x) * x^r. Second, D(x) * x^r is divided by the generator polynomial G(x) using Modulo-2 polynomial long division.</a:t>
+            </a:r>
+          </a:p>
+          <a:p>
+            <a:pPr>
+              <a:spcBef>
+                <a:spcPts val="500"/>
+              </a:spcBef>
+              <a:defRPr sz="1000">
+                <a:solidFill>
+                  <a:srgbClr val="94A3B8"/>
+                </a:solidFill>
+                <a:latin typeface="Segoe UI"/>
+              </a:defRPr>
+            </a:pPr>
+            <a:r>
+              <a:t>Third, the resulting r-bit remainder polynomial R(x) = rem(D(x) * x^r / G(x)) constitutes the Frame Check Sequence (FCS). Fourth, the FCS is added to the shifted data polynomial to construct the transmitted codeword: T(x) = D(x) * x^r ^ R(x). By polynomial algebra, T(x) is mathematically guaranteed to be exactly divisible by G(x) without remainder: T(x) mod G(x) == 0.</a:t>
+            </a:r>
+          </a:p>
+        </p:txBody>
+      </p:sp>
+    </p:spTree>
+  </p:cSld>
+  <p:clrMapOvr>
+    <a:masterClrMapping/>
+  </p:clrMapOvr>
+</p:sld>
+</file>
+
+<file path=ppt/slides/slide13.xml><?xml version="1.0" encoding="utf-8"?>
+<p:sld xmlns:a="http://schemas.openxmlformats.org/drawingml/2006/main" xmlns:p="http://schemas.openxmlformats.org/presentationml/2006/main" xmlns:r="http://schemas.openxmlformats.org/officeDocument/2006/relationships">
+  <p:cSld>
+    <p:spTree>
+      <p:nvGrpSpPr>
+        <p:cNvPr id="1" name=""/>
+        <p:cNvGrpSpPr/>
+        <p:nvPr/>
+      </p:nvGrpSpPr>
+      <p:grpSpPr/>
+      <p:sp>
+        <p:nvSpPr>
+          <p:cNvPr id="2" name="Rectangle 1"/>
+          <p:cNvSpPr/>
+          <p:nvPr/>
+        </p:nvSpPr>
+        <p:spPr>
+          <a:xfrm>
+            <a:off x="0" y="0"/>
+            <a:ext cx="12191695" cy="6858000"/>
+          </a:xfrm>
+          <a:prstGeom prst="rect">
+            <a:avLst/>
+          </a:prstGeom>
+          <a:solidFill>
+            <a:srgbClr val="0F172A"/>
+          </a:solidFill>
+          <a:ln>
+            <a:noFill/>
+          </a:ln>
+        </p:spPr>
+        <p:style>
+          <a:lnRef idx="1">
+            <a:schemeClr val="accent1"/>
+          </a:lnRef>
+          <a:fillRef idx="3">
+            <a:schemeClr val="accent1"/>
+          </a:fillRef>
+          <a:effectRef idx="2">
+            <a:schemeClr val="accent1"/>
+          </a:effectRef>
+          <a:fontRef idx="minor">
+            <a:schemeClr val="lt1"/>
+          </a:fontRef>
+        </p:style>
+        <p:txBody>
+          <a:bodyPr rtlCol="0" anchor="ctr"/>
+          <a:lstStyle/>
+          <a:p>
+            <a:pPr algn="ctr"/>
+          </a:p>
+        </p:txBody>
+      </p:sp>
+      <p:sp>
+        <p:nvSpPr>
+          <p:cNvPr id="3" name="TextBox 2"/>
+          <p:cNvSpPr txBox="1"/>
+          <p:nvPr/>
+        </p:nvSpPr>
+        <p:spPr>
+          <a:xfrm>
+            <a:off x="731520" y="320040"/>
+            <a:ext cx="7315200" cy="320040"/>
+          </a:xfrm>
+          <a:prstGeom prst="rect">
+            <a:avLst/>
+          </a:prstGeom>
+          <a:noFill/>
+        </p:spPr>
+        <p:txBody>
+          <a:bodyPr wrap="square">
+            <a:spAutoFit/>
+          </a:bodyPr>
+          <a:lstStyle/>
+          <a:p>
+            <a:pPr>
+              <a:defRPr sz="1050" b="1">
+                <a:solidFill>
+                  <a:srgbClr val="38BDF8"/>
+                </a:solidFill>
+                <a:latin typeface="Segoe UI"/>
+              </a:defRPr>
+            </a:pPr>
+            <a:r>
+              <a:t>●  ALGORITHM 5 OF 5: PART B</a:t>
+            </a:r>
+          </a:p>
+        </p:txBody>
+      </p:sp>
+      <p:sp>
+        <p:nvSpPr>
+          <p:cNvPr id="4" name="TextBox 3"/>
+          <p:cNvSpPr txBox="1"/>
+          <p:nvPr/>
+        </p:nvSpPr>
+        <p:spPr>
+          <a:xfrm>
+            <a:off x="731520" y="594360"/>
+            <a:ext cx="10725912" cy="594360"/>
+          </a:xfrm>
+          <a:prstGeom prst="rect">
+            <a:avLst/>
+          </a:prstGeom>
+          <a:noFill/>
+        </p:spPr>
+        <p:txBody>
+          <a:bodyPr wrap="square">
+            <a:spAutoFit/>
+          </a:bodyPr>
+          <a:lstStyle/>
+          <a:p>
+            <a:pPr>
+              <a:defRPr sz="2100" b="1">
+                <a:solidFill>
+                  <a:srgbClr val="F8FAFC"/>
+                </a:solidFill>
+                <a:latin typeface="Segoe UI"/>
+              </a:defRPr>
+            </a:pPr>
+            <a:r>
+              <a:t>CRC Modulo-2: Detection Proofs &amp; NS-2</a:t>
+            </a:r>
+          </a:p>
+        </p:txBody>
+      </p:sp>
+      <p:sp>
+        <p:nvSpPr>
+          <p:cNvPr id="5" name="TextBox 4"/>
+          <p:cNvSpPr txBox="1"/>
+          <p:nvPr/>
+        </p:nvSpPr>
+        <p:spPr>
+          <a:xfrm>
+            <a:off x="731520" y="1115568"/>
+            <a:ext cx="10725912" cy="365760"/>
+          </a:xfrm>
+          <a:prstGeom prst="rect">
+            <a:avLst/>
+          </a:prstGeom>
+          <a:noFill/>
+        </p:spPr>
+        <p:txBody>
+          <a:bodyPr wrap="square">
+            <a:spAutoFit/>
+          </a:bodyPr>
+          <a:lstStyle/>
+          <a:p>
+            <a:pPr>
+              <a:defRPr sz="1150">
+                <a:solidFill>
+                  <a:srgbClr val="94A3B8"/>
+                </a:solidFill>
+                <a:latin typeface="Segoe UI"/>
+              </a:defRPr>
+            </a:pPr>
+            <a:r>
+              <a:t>Mathematical error detection proofs, industry standard polynomials, and link trace analysis</a:t>
+            </a:r>
+          </a:p>
+        </p:txBody>
+      </p:sp>
+      <p:sp>
+        <p:nvSpPr>
+          <p:cNvPr id="6" name="Rounded Rectangle 5"/>
+          <p:cNvSpPr/>
+          <p:nvPr/>
+        </p:nvSpPr>
+        <p:spPr>
+          <a:xfrm>
+            <a:off x="731520" y="1600200"/>
+            <a:ext cx="5212080" cy="4846320"/>
+          </a:xfrm>
+          <a:prstGeom prst="roundRect">
+            <a:avLst/>
+          </a:prstGeom>
+          <a:solidFill>
+            <a:srgbClr val="1E293B"/>
+          </a:solidFill>
+          <a:ln w="19050">
+            <a:solidFill>
+              <a:srgbClr val="334155"/>
+            </a:solidFill>
+          </a:ln>
+        </p:spPr>
+        <p:style>
+          <a:lnRef idx="1">
+            <a:schemeClr val="accent1"/>
+          </a:lnRef>
+          <a:fillRef idx="3">
+            <a:schemeClr val="accent1"/>
+          </a:fillRef>
+          <a:effectRef idx="2">
+            <a:schemeClr val="accent1"/>
+          </a:effectRef>
+          <a:fontRef idx="minor">
+            <a:schemeClr val="lt1"/>
+          </a:fontRef>
+        </p:style>
+        <p:txBody>
+          <a:bodyPr rtlCol="0" anchor="ctr"/>
+          <a:lstStyle/>
+          <a:p>
+            <a:pPr algn="ctr"/>
+          </a:p>
+        </p:txBody>
+      </p:sp>
+      <p:sp>
+        <p:nvSpPr>
+          <p:cNvPr id="7" name="TextBox 6"/>
+          <p:cNvSpPr txBox="1"/>
+          <p:nvPr/>
+        </p:nvSpPr>
+        <p:spPr>
+          <a:xfrm>
+            <a:off x="960120" y="1746504"/>
+            <a:ext cx="4754880" cy="4553712"/>
+          </a:xfrm>
+          <a:prstGeom prst="rect">
+            <a:avLst/>
+          </a:prstGeom>
+          <a:noFill/>
+        </p:spPr>
+        <p:txBody>
+          <a:bodyPr wrap="square">
+            <a:spAutoFit/>
+          </a:bodyPr>
+          <a:lstStyle/>
+          <a:p>
+            <a:pPr>
+              <a:defRPr sz="1400" b="1">
+                <a:solidFill>
+                  <a:srgbClr val="38BDF8"/>
+                </a:solidFill>
+                <a:latin typeface="Segoe UI"/>
+              </a:defRPr>
+            </a:pPr>
+            <a:r>
+              <a:t>Comprehensive Mathematical Error Detection Proofs</a:t>
+            </a:r>
+          </a:p>
+          <a:p>
+            <a:pPr>
+              <a:spcBef>
+                <a:spcPts val="200"/>
+              </a:spcBef>
+              <a:defRPr sz="1050">
+                <a:solidFill>
+                  <a:srgbClr val="94A3B8"/>
+                </a:solidFill>
+                <a:latin typeface="Segoe UI"/>
+              </a:defRPr>
+            </a:pPr>
+            <a:r>
+              <a:t>Algebraic proofs for single, double, odd, and burst error detection:</a:t>
+            </a:r>
+          </a:p>
+          <a:p>
+            <a:pPr>
+              <a:spcBef>
+                <a:spcPts val="500"/>
+              </a:spcBef>
+              <a:defRPr sz="1050">
+                <a:solidFill>
+                  <a:srgbClr val="F8FAFC"/>
+                </a:solidFill>
+                <a:latin typeface="Segoe UI"/>
+              </a:defRPr>
+            </a:pPr>
+            <a:r>
+              <a:t>The algebraic properties of CRC provide extraordinary detection power: Let the transmitted codeword be T(x) and the received codeword be T(x) ^ E(x), where E(x) is the error polynomial. The receiver divides by G(x), evaluating (T(x) ^ E(x))/G(x) = E(x)/G(x). An error is undetected if and only if E(x) is exactly divisible by G(x).</a:t>
+            </a:r>
+          </a:p>
+          <a:p>
+            <a:pPr>
+              <a:spcBef>
+                <a:spcPts val="500"/>
+              </a:spcBef>
+              <a:defRPr sz="1000">
+                <a:solidFill>
+                  <a:srgbClr val="94A3B8"/>
+                </a:solidFill>
+                <a:latin typeface="Segoe UI"/>
+              </a:defRPr>
+            </a:pPr>
+            <a:r>
+              <a:t>1. Single-bit errors: E(x) = x^i. Since G(x) has at least two non-zero terms (x^r + ... + 1), it cannot divide x^i, guaranteeing 100% single-bit detection. 2. Double-bit errors: E(x) = x^i + x^j = x^j(x^(i-j) + 1). If G(x) does not divide (x^k + 1) for any k &lt;= frame length, 100% of double-bit errors are detected. 3. Odd-numbered errors: If G(x) contains (x+1) as a factor, it catches 100% of all odd-numbered errors. 4. Burst errors: Catches 100% of all burst error corruptions of length &lt;= r bits.</a:t>
+            </a:r>
+          </a:p>
+        </p:txBody>
+      </p:sp>
+      <p:sp>
+        <p:nvSpPr>
+          <p:cNvPr id="8" name="Rounded Rectangle 7"/>
+          <p:cNvSpPr/>
+          <p:nvPr/>
+        </p:nvSpPr>
+        <p:spPr>
+          <a:xfrm>
+            <a:off x="6217920" y="1600200"/>
+            <a:ext cx="5212080" cy="4846320"/>
+          </a:xfrm>
+          <a:prstGeom prst="roundRect">
+            <a:avLst/>
+          </a:prstGeom>
+          <a:solidFill>
+            <a:srgbClr val="1E293B"/>
+          </a:solidFill>
+          <a:ln w="19050">
+            <a:solidFill>
+              <a:srgbClr val="334155"/>
+            </a:solidFill>
+          </a:ln>
+        </p:spPr>
+        <p:style>
+          <a:lnRef idx="1">
+            <a:schemeClr val="accent1"/>
+          </a:lnRef>
+          <a:fillRef idx="3">
+            <a:schemeClr val="accent1"/>
+          </a:fillRef>
+          <a:effectRef idx="2">
+            <a:schemeClr val="accent1"/>
+          </a:effectRef>
+          <a:fontRef idx="minor">
+            <a:schemeClr val="lt1"/>
+          </a:fontRef>
+        </p:style>
+        <p:txBody>
+          <a:bodyPr rtlCol="0" anchor="ctr"/>
+          <a:lstStyle/>
+          <a:p>
+            <a:pPr algn="ctr"/>
+          </a:p>
+        </p:txBody>
+      </p:sp>
+      <p:sp>
+        <p:nvSpPr>
+          <p:cNvPr id="9" name="TextBox 8"/>
+          <p:cNvSpPr txBox="1"/>
+          <p:nvPr/>
+        </p:nvSpPr>
+        <p:spPr>
+          <a:xfrm>
+            <a:off x="6446520" y="1746504"/>
+            <a:ext cx="4754880" cy="4553712"/>
+          </a:xfrm>
+          <a:prstGeom prst="rect">
+            <a:avLst/>
+          </a:prstGeom>
+          <a:noFill/>
+        </p:spPr>
+        <p:txBody>
+          <a:bodyPr wrap="square">
+            <a:spAutoFit/>
+          </a:bodyPr>
+          <a:lstStyle/>
+          <a:p>
+            <a:pPr>
+              <a:defRPr sz="1400" b="1">
+                <a:solidFill>
+                  <a:srgbClr val="38BDF8"/>
+                </a:solidFill>
+                <a:latin typeface="Segoe UI"/>
+              </a:defRPr>
+            </a:pPr>
+            <a:r>
+              <a:t>Industry Standard Generators &amp; NS-2 Trace Integration</a:t>
+            </a:r>
+          </a:p>
+          <a:p>
+            <a:pPr>
+              <a:spcBef>
+                <a:spcPts val="200"/>
+              </a:spcBef>
+              <a:defRPr sz="1050">
+                <a:solidFill>
+                  <a:srgbClr val="94A3B8"/>
+                </a:solidFill>
+                <a:latin typeface="Segoe UI"/>
+              </a:defRPr>
+            </a:pPr>
+            <a:r>
+              <a:t>Ethernet IEEE 802.3, hardware LFSR circuits, and NS-2 drops (ns2_crc.tr):</a:t>
+            </a:r>
+          </a:p>
+          <a:p>
+            <a:pPr>
+              <a:spcBef>
+                <a:spcPts val="500"/>
+              </a:spcBef>
+              <a:defRPr sz="1050">
+                <a:solidFill>
+                  <a:srgbClr val="F8FAFC"/>
+                </a:solidFill>
+                <a:latin typeface="Segoe UI"/>
+              </a:defRPr>
+            </a:pPr>
+            <a:r>
+              <a:t>Our platform implements key industry generator polynomials: CRC-4 ITU (x^4 + x + 1), CRC-8 ATM (x^8 + x^2 + x + 1), CRC-16-IBM (x^16 + x^15 + x^2 + 1), CRC-CCITT (x^16 + x^12 + x^5 + 1), and CRC-32 (IEEE 802.3 Ethernet standard: x^32 + x^26 + x^23 + ... + 1). While software CRC requires O(n * r) operations, hardware implementations execute at wire speed (O(1) cycle latency) using Linear Feedback Shift Registers (LFSR).</a:t>
+            </a:r>
+          </a:p>
+          <a:p>
+            <a:pPr>
+              <a:spcBef>
+                <a:spcPts val="500"/>
+              </a:spcBef>
+              <a:defRPr sz="1000">
+                <a:solidFill>
+                  <a:srgbClr val="94A3B8"/>
+                </a:solidFill>
+                <a:latin typeface="Segoe UI"/>
+              </a:defRPr>
+            </a:pPr>
+            <a:r>
+              <a:t>In our NS-2 simulation (ns2_crc.tr), CRC-encoded frames traverse the simulated duplex link under varying ErrorModel loss rates. Corrupted frames reliably trigger non-zero syndrome remainders and register drop events in the NS-2 trace, modeling realistic Ethernet frame discards.</a:t>
+            </a:r>
+          </a:p>
+        </p:txBody>
+      </p:sp>
+    </p:spTree>
+  </p:cSld>
+  <p:clrMapOvr>
+    <a:masterClrMapping/>
+  </p:clrMapOvr>
+</p:sld>
+</file>
+
+<file path=ppt/slides/slide14.xml><?xml version="1.0" encoding="utf-8"?>
+<p:sld xmlns:a="http://schemas.openxmlformats.org/drawingml/2006/main" xmlns:p="http://schemas.openxmlformats.org/presentationml/2006/main" xmlns:r="http://schemas.openxmlformats.org/officeDocument/2006/relationships">
+  <p:cSld>
+    <p:spTree>
+      <p:nvGrpSpPr>
+        <p:cNvPr id="1" name=""/>
+        <p:cNvGrpSpPr/>
+        <p:nvPr/>
+      </p:nvGrpSpPr>
+      <p:grpSpPr/>
+      <p:sp>
+        <p:nvSpPr>
+          <p:cNvPr id="2" name="Rectangle 1"/>
+          <p:cNvSpPr/>
+          <p:nvPr/>
+        </p:nvSpPr>
+        <p:spPr>
+          <a:xfrm>
+            <a:off x="0" y="0"/>
+            <a:ext cx="12191695" cy="6858000"/>
+          </a:xfrm>
+          <a:prstGeom prst="rect">
+            <a:avLst/>
+          </a:prstGeom>
+          <a:solidFill>
+            <a:srgbClr val="0F172A"/>
+          </a:solidFill>
+          <a:ln>
+            <a:noFill/>
+          </a:ln>
+        </p:spPr>
+        <p:style>
+          <a:lnRef idx="1">
+            <a:schemeClr val="accent1"/>
+          </a:lnRef>
+          <a:fillRef idx="3">
+            <a:schemeClr val="accent1"/>
+          </a:fillRef>
+          <a:effectRef idx="2">
+            <a:schemeClr val="accent1"/>
+          </a:effectRef>
+          <a:fontRef idx="minor">
+            <a:schemeClr val="lt1"/>
+          </a:fontRef>
+        </p:style>
+        <p:txBody>
+          <a:bodyPr rtlCol="0" anchor="ctr"/>
+          <a:lstStyle/>
+          <a:p>
+            <a:pPr algn="ctr"/>
+          </a:p>
+        </p:txBody>
+      </p:sp>
+      <p:sp>
+        <p:nvSpPr>
+          <p:cNvPr id="3" name="TextBox 2"/>
+          <p:cNvSpPr txBox="1"/>
+          <p:nvPr/>
+        </p:nvSpPr>
+        <p:spPr>
+          <a:xfrm>
+            <a:off x="731520" y="320040"/>
+            <a:ext cx="7315200" cy="320040"/>
+          </a:xfrm>
+          <a:prstGeom prst="rect">
+            <a:avLst/>
+          </a:prstGeom>
+          <a:noFill/>
+        </p:spPr>
+        <p:txBody>
+          <a:bodyPr wrap="square">
+            <a:spAutoFit/>
+          </a:bodyPr>
+          <a:lstStyle/>
+          <a:p>
+            <a:pPr>
+              <a:defRPr sz="1050" b="1">
+                <a:solidFill>
+                  <a:srgbClr val="38BDF8"/>
+                </a:solidFill>
+                <a:latin typeface="Segoe UI"/>
+              </a:defRPr>
+            </a:pPr>
+            <a:r>
+              <a:t>●  CHANNEL SIMULATION ENGINE</a:t>
+            </a:r>
+          </a:p>
+        </p:txBody>
+      </p:sp>
+      <p:sp>
+        <p:nvSpPr>
+          <p:cNvPr id="4" name="TextBox 3"/>
+          <p:cNvSpPr txBox="1"/>
+          <p:nvPr/>
+        </p:nvSpPr>
+        <p:spPr>
+          <a:xfrm>
+            <a:off x="731520" y="594360"/>
+            <a:ext cx="10725912" cy="594360"/>
+          </a:xfrm>
+          <a:prstGeom prst="rect">
+            <a:avLst/>
+          </a:prstGeom>
+          <a:noFill/>
+        </p:spPr>
+        <p:txBody>
+          <a:bodyPr wrap="square">
+            <a:spAutoFit/>
+          </a:bodyPr>
+          <a:lstStyle/>
+          <a:p>
+            <a:pPr>
+              <a:defRPr sz="2100" b="1">
+                <a:solidFill>
+                  <a:srgbClr val="F8FAFC"/>
+                </a:solidFill>
+                <a:latin typeface="Segoe UI"/>
+              </a:defRPr>
+            </a:pPr>
+            <a:r>
+              <a:t>NS-2 Architecture: OTcl Scripting &amp; Channel Modeling</a:t>
+            </a:r>
+          </a:p>
+        </p:txBody>
+      </p:sp>
+      <p:sp>
+        <p:nvSpPr>
+          <p:cNvPr id="5" name="TextBox 4"/>
+          <p:cNvSpPr txBox="1"/>
+          <p:nvPr/>
+        </p:nvSpPr>
+        <p:spPr>
+          <a:xfrm>
+            <a:off x="731520" y="1115568"/>
+            <a:ext cx="10725912" cy="365760"/>
+          </a:xfrm>
+          <a:prstGeom prst="rect">
+            <a:avLst/>
+          </a:prstGeom>
+          <a:noFill/>
+        </p:spPr>
+        <p:txBody>
+          <a:bodyPr wrap="square">
+            <a:spAutoFit/>
+          </a:bodyPr>
+          <a:lstStyle/>
+          <a:p>
+            <a:pPr>
+              <a:defRPr sz="1150">
+                <a:solidFill>
+                  <a:srgbClr val="94A3B8"/>
+                </a:solidFill>
+                <a:latin typeface="Segoe UI"/>
+              </a:defRPr>
+            </a:pPr>
+            <a:r>
+              <a:t>Coupling physical link discrete-event simulation with Data Link Layer error control</a:t>
+            </a:r>
+          </a:p>
+        </p:txBody>
+      </p:sp>
+      <p:sp>
+        <p:nvSpPr>
+          <p:cNvPr id="6" name="Rounded Rectangle 5"/>
+          <p:cNvSpPr/>
+          <p:nvPr/>
+        </p:nvSpPr>
+        <p:spPr>
+          <a:xfrm>
+            <a:off x="731520" y="1600200"/>
+            <a:ext cx="5212080" cy="4846320"/>
+          </a:xfrm>
+          <a:prstGeom prst="roundRect">
+            <a:avLst/>
+          </a:prstGeom>
+          <a:solidFill>
+            <a:srgbClr val="1E293B"/>
+          </a:solidFill>
+          <a:ln w="19050">
+            <a:solidFill>
+              <a:srgbClr val="334155"/>
+            </a:solidFill>
+          </a:ln>
+        </p:spPr>
+        <p:style>
+          <a:lnRef idx="1">
+            <a:schemeClr val="accent1"/>
+          </a:lnRef>
+          <a:fillRef idx="3">
+            <a:schemeClr val="accent1"/>
+          </a:fillRef>
+          <a:effectRef idx="2">
+            <a:schemeClr val="accent1"/>
+          </a:effectRef>
+          <a:fontRef idx="minor">
+            <a:schemeClr val="lt1"/>
+          </a:fontRef>
+        </p:style>
+        <p:txBody>
+          <a:bodyPr rtlCol="0" anchor="ctr"/>
+          <a:lstStyle/>
+          <a:p>
+            <a:pPr algn="ctr"/>
+          </a:p>
+        </p:txBody>
+      </p:sp>
+      <p:sp>
+        <p:nvSpPr>
+          <p:cNvPr id="7" name="TextBox 6"/>
+          <p:cNvSpPr txBox="1"/>
+          <p:nvPr/>
+        </p:nvSpPr>
+        <p:spPr>
+          <a:xfrm>
+            <a:off x="960120" y="1746504"/>
+            <a:ext cx="4754880" cy="4553712"/>
+          </a:xfrm>
+          <a:prstGeom prst="rect">
+            <a:avLst/>
+          </a:prstGeom>
+          <a:noFill/>
+        </p:spPr>
+        <p:txBody>
+          <a:bodyPr wrap="square">
+            <a:spAutoFit/>
+          </a:bodyPr>
+          <a:lstStyle/>
+          <a:p>
+            <a:pPr>
+              <a:defRPr sz="1400" b="1">
+                <a:solidFill>
+                  <a:srgbClr val="38BDF8"/>
+                </a:solidFill>
+                <a:latin typeface="Segoe UI"/>
+              </a:defRPr>
+            </a:pPr>
+            <a:r>
+              <a:t>Dual-Language Architecture &amp; OTcl Topology Scripting</a:t>
+            </a:r>
+          </a:p>
+          <a:p>
+            <a:pPr>
+              <a:spcBef>
+                <a:spcPts val="200"/>
+              </a:spcBef>
+              <a:defRPr sz="1050">
+                <a:solidFill>
+                  <a:srgbClr val="94A3B8"/>
+                </a:solidFill>
+                <a:latin typeface="Segoe UI"/>
+              </a:defRPr>
+            </a:pPr>
+            <a:r>
+              <a:t>C++ discrete-event scheduler coupled with Object Tcl configuration scripts:</a:t>
+            </a:r>
+          </a:p>
+          <a:p>
+            <a:pPr>
+              <a:spcBef>
+                <a:spcPts val="500"/>
+              </a:spcBef>
+              <a:defRPr sz="1050">
+                <a:solidFill>
+                  <a:srgbClr val="F8FAFC"/>
+                </a:solidFill>
+                <a:latin typeface="Segoe UI"/>
+              </a:defRPr>
+            </a:pPr>
+            <a:r>
+              <a:t>Network Simulator 2 (NS-2) is an industry-standard, object-oriented discrete-event network simulator widely utilized in telecommunication research to model network protocol dynamics, routing algorithms, and physical channel transmission impairments. NS-2 employs a dual-language architecture: the core simulation engine and packet scheduler are written in C++ for maximum computational throughput, while simulation topology scripts, agent configurations, and event schedules are authored in Object Tcl (OTcl).</a:t>
+            </a:r>
+          </a:p>
+          <a:p>
+            <a:pPr>
+              <a:spcBef>
+                <a:spcPts val="500"/>
+              </a:spcBef>
+              <a:defRPr sz="1000">
+                <a:solidFill>
+                  <a:srgbClr val="94A3B8"/>
+                </a:solidFill>
+                <a:latin typeface="Segoe UI"/>
+              </a:defRPr>
+            </a:pPr>
+            <a:r>
+              <a:t>In our project, the physical channel is configured in ns2/network_error_sim.tcl. The simulation creates a point-to-point network topology consisting of a source node (Node 0) and a destination sink node (Node 1). Node 0 is configured with a UDP agent connected to a Constant Bit Rate (CBR) traffic generator transmitting 64-byte packets. Node 1 is equipped with an Agent/Null sink. The two nodes are connected via a full-duplex link configured with a bandwidth of 2.0 Mbps, a propagation delay of 10 ms, and a DropTail queue discipline.</a:t>
+            </a:r>
+          </a:p>
+        </p:txBody>
+      </p:sp>
+      <p:sp>
+        <p:nvSpPr>
+          <p:cNvPr id="8" name="Rounded Rectangle 7"/>
+          <p:cNvSpPr/>
+          <p:nvPr/>
+        </p:nvSpPr>
+        <p:spPr>
+          <a:xfrm>
+            <a:off x="6217920" y="1600200"/>
+            <a:ext cx="5212080" cy="4846320"/>
+          </a:xfrm>
+          <a:prstGeom prst="roundRect">
+            <a:avLst/>
+          </a:prstGeom>
+          <a:solidFill>
+            <a:srgbClr val="1E293B"/>
+          </a:solidFill>
+          <a:ln w="19050">
+            <a:solidFill>
+              <a:srgbClr val="334155"/>
+            </a:solidFill>
+          </a:ln>
+        </p:spPr>
+        <p:style>
+          <a:lnRef idx="1">
+            <a:schemeClr val="accent1"/>
+          </a:lnRef>
+          <a:fillRef idx="3">
+            <a:schemeClr val="accent1"/>
+          </a:fillRef>
+          <a:effectRef idx="2">
+            <a:schemeClr val="accent1"/>
+          </a:effectRef>
+          <a:fontRef idx="minor">
+            <a:schemeClr val="lt1"/>
+          </a:fontRef>
+        </p:style>
+        <p:txBody>
+          <a:bodyPr rtlCol="0" anchor="ctr"/>
+          <a:lstStyle/>
+          <a:p>
+            <a:pPr algn="ctr"/>
+          </a:p>
+        </p:txBody>
+      </p:sp>
+      <p:sp>
+        <p:nvSpPr>
+          <p:cNvPr id="9" name="TextBox 8"/>
+          <p:cNvSpPr txBox="1"/>
+          <p:nvPr/>
+        </p:nvSpPr>
+        <p:spPr>
+          <a:xfrm>
+            <a:off x="6446520" y="1746504"/>
+            <a:ext cx="4754880" cy="4553712"/>
+          </a:xfrm>
+          <a:prstGeom prst="rect">
+            <a:avLst/>
+          </a:prstGeom>
+          <a:noFill/>
+        </p:spPr>
+        <p:txBody>
+          <a:bodyPr wrap="square">
+            <a:spAutoFit/>
+          </a:bodyPr>
+          <a:lstStyle/>
+          <a:p>
+            <a:pPr>
+              <a:defRPr sz="1400" b="1">
+                <a:solidFill>
+                  <a:srgbClr val="38BDF8"/>
+                </a:solidFill>
+                <a:latin typeface="Segoe UI"/>
+              </a:defRPr>
+            </a:pPr>
+            <a:r>
+              <a:t>Physical Noise Injection &amp; ErrorModel Loss Mechanics</a:t>
+            </a:r>
+          </a:p>
+          <a:p>
+            <a:pPr>
+              <a:spcBef>
+                <a:spcPts val="200"/>
+              </a:spcBef>
+              <a:defRPr sz="1050">
+                <a:solidFill>
+                  <a:srgbClr val="94A3B8"/>
+                </a:solidFill>
+                <a:latin typeface="Segoe UI"/>
+              </a:defRPr>
+            </a:pPr>
+            <a:r>
+              <a:t>Stochastic uniform packet corruption and drop-target redirection:</a:t>
+            </a:r>
+          </a:p>
+          <a:p>
+            <a:pPr>
+              <a:spcBef>
+                <a:spcPts val="500"/>
+              </a:spcBef>
+              <a:defRPr sz="1050">
+                <a:solidFill>
+                  <a:srgbClr val="F8FAFC"/>
+                </a:solidFill>
+                <a:latin typeface="Segoe UI"/>
+              </a:defRPr>
+            </a:pPr>
+            <a:r>
+              <a:t>To authentically simulate noisy physical transmission channels, the NS-2 ErrorModel/Uniform module is inserted directly into the duplex link between Node 0 and Node 1. The ErrorModel applies a configurable statistical packet loss rate, causing packets to be dropped or corrupted during transit. Dropped packets are redirected to an Agent/Null drop-target, capturing realistic channel packet drop behavior.</a:t>
+            </a:r>
+          </a:p>
+          <a:p>
+            <a:pPr>
+              <a:spcBef>
+                <a:spcPts val="500"/>
+              </a:spcBef>
+              <a:defRPr sz="1000">
+                <a:solidFill>
+                  <a:srgbClr val="94A3B8"/>
+                </a:solidFill>
+                <a:latin typeface="Segoe UI"/>
+              </a:defRPr>
+            </a:pPr>
+            <a:r>
+              <a:t>The simulation script schedules packet transmissions, initiates CBR traffic flows at t = 0.5 s, and terminates the simulation run at t = 4.5 s. Output event traces are flushed directly to standard .tr files and Network Animator (.nam) visualization files, allowing comprehensive inspection of packet queues, link traversal latencies, and packet drop events.</a:t>
+            </a:r>
+          </a:p>
+        </p:txBody>
+      </p:sp>
+    </p:spTree>
+  </p:cSld>
+  <p:clrMapOvr>
+    <a:masterClrMapping/>
+  </p:clrMapOvr>
+</p:sld>
+</file>
+
+<file path=ppt/slides/slide15.xml><?xml version="1.0" encoding="utf-8"?>
+<p:sld xmlns:a="http://schemas.openxmlformats.org/drawingml/2006/main" xmlns:p="http://schemas.openxmlformats.org/presentationml/2006/main" xmlns:r="http://schemas.openxmlformats.org/officeDocument/2006/relationships">
+  <p:cSld>
+    <p:spTree>
+      <p:nvGrpSpPr>
+        <p:cNvPr id="1" name=""/>
+        <p:cNvGrpSpPr/>
+        <p:nvPr/>
+      </p:nvGrpSpPr>
+      <p:grpSpPr/>
+      <p:sp>
+        <p:nvSpPr>
+          <p:cNvPr id="2" name="Rectangle 1"/>
+          <p:cNvSpPr/>
+          <p:nvPr/>
+        </p:nvSpPr>
+        <p:spPr>
+          <a:xfrm>
+            <a:off x="0" y="0"/>
+            <a:ext cx="12191695" cy="6858000"/>
+          </a:xfrm>
+          <a:prstGeom prst="rect">
+            <a:avLst/>
+          </a:prstGeom>
+          <a:solidFill>
+            <a:srgbClr val="0F172A"/>
+          </a:solidFill>
+          <a:ln>
+            <a:noFill/>
+          </a:ln>
+        </p:spPr>
+        <p:style>
+          <a:lnRef idx="1">
+            <a:schemeClr val="accent1"/>
+          </a:lnRef>
+          <a:fillRef idx="3">
+            <a:schemeClr val="accent1"/>
+          </a:fillRef>
+          <a:effectRef idx="2">
+            <a:schemeClr val="accent1"/>
+          </a:effectRef>
+          <a:fontRef idx="minor">
+            <a:schemeClr val="lt1"/>
+          </a:fontRef>
+        </p:style>
+        <p:txBody>
+          <a:bodyPr rtlCol="0" anchor="ctr"/>
+          <a:lstStyle/>
+          <a:p>
+            <a:pPr algn="ctr"/>
+          </a:p>
+        </p:txBody>
+      </p:sp>
+      <p:sp>
+        <p:nvSpPr>
+          <p:cNvPr id="3" name="TextBox 2"/>
+          <p:cNvSpPr txBox="1"/>
+          <p:nvPr/>
+        </p:nvSpPr>
+        <p:spPr>
+          <a:xfrm>
+            <a:off x="731520" y="320040"/>
+            <a:ext cx="7315200" cy="320040"/>
+          </a:xfrm>
+          <a:prstGeom prst="rect">
+            <a:avLst/>
+          </a:prstGeom>
+          <a:noFill/>
+        </p:spPr>
+        <p:txBody>
+          <a:bodyPr wrap="square">
+            <a:spAutoFit/>
+          </a:bodyPr>
+          <a:lstStyle/>
+          <a:p>
+            <a:pPr>
+              <a:defRPr sz="1050" b="1">
+                <a:solidFill>
+                  <a:srgbClr val="38BDF8"/>
+                </a:solidFill>
+                <a:latin typeface="Segoe UI"/>
+              </a:defRPr>
+            </a:pPr>
+            <a:r>
+              <a:t>●  CHANNEL SIMULATION ENGINE</a:t>
+            </a:r>
+          </a:p>
+        </p:txBody>
+      </p:sp>
+      <p:sp>
+        <p:nvSpPr>
+          <p:cNvPr id="4" name="TextBox 3"/>
+          <p:cNvSpPr txBox="1"/>
+          <p:nvPr/>
+        </p:nvSpPr>
+        <p:spPr>
+          <a:xfrm>
+            <a:off x="731520" y="594360"/>
+            <a:ext cx="10725912" cy="594360"/>
+          </a:xfrm>
+          <a:prstGeom prst="rect">
+            <a:avLst/>
+          </a:prstGeom>
+          <a:noFill/>
+        </p:spPr>
+        <p:txBody>
+          <a:bodyPr wrap="square">
+            <a:spAutoFit/>
+          </a:bodyPr>
+          <a:lstStyle/>
+          <a:p>
+            <a:pPr>
+              <a:defRPr sz="2100" b="1">
+                <a:solidFill>
+                  <a:srgbClr val="F8FAFC"/>
+                </a:solidFill>
+                <a:latin typeface="Segoe UI"/>
+              </a:defRPr>
+            </a:pPr>
+            <a:r>
+              <a:t>NS-2 Trace Analytics: 12-Column Records &amp; PER</a:t>
+            </a:r>
+          </a:p>
+        </p:txBody>
+      </p:sp>
+      <p:sp>
+        <p:nvSpPr>
+          <p:cNvPr id="5" name="TextBox 4"/>
+          <p:cNvSpPr txBox="1"/>
+          <p:nvPr/>
+        </p:nvSpPr>
+        <p:spPr>
+          <a:xfrm>
+            <a:off x="731520" y="1115568"/>
+            <a:ext cx="10725912" cy="365760"/>
+          </a:xfrm>
+          <a:prstGeom prst="rect">
+            <a:avLst/>
+          </a:prstGeom>
+          <a:noFill/>
+        </p:spPr>
+        <p:txBody>
+          <a:bodyPr wrap="square">
+            <a:spAutoFit/>
+          </a:bodyPr>
+          <a:lstStyle/>
+          <a:p>
+            <a:pPr>
+              <a:defRPr sz="1150">
+                <a:solidFill>
+                  <a:srgbClr val="94A3B8"/>
+                </a:solidFill>
+                <a:latin typeface="Segoe UI"/>
+              </a:defRPr>
+            </a:pPr>
+            <a:r>
+              <a:t>Event record schema, Packet Error Rate calculation, and WSL execution bridge</a:t>
+            </a:r>
+          </a:p>
+        </p:txBody>
+      </p:sp>
+      <p:sp>
+        <p:nvSpPr>
+          <p:cNvPr id="6" name="Rounded Rectangle 5"/>
+          <p:cNvSpPr/>
+          <p:nvPr/>
+        </p:nvSpPr>
+        <p:spPr>
+          <a:xfrm>
+            <a:off x="731520" y="1600200"/>
+            <a:ext cx="5212080" cy="4846320"/>
+          </a:xfrm>
+          <a:prstGeom prst="roundRect">
+            <a:avLst/>
+          </a:prstGeom>
+          <a:solidFill>
+            <a:srgbClr val="1E293B"/>
+          </a:solidFill>
+          <a:ln w="19050">
+            <a:solidFill>
+              <a:srgbClr val="334155"/>
+            </a:solidFill>
+          </a:ln>
+        </p:spPr>
+        <p:style>
+          <a:lnRef idx="1">
+            <a:schemeClr val="accent1"/>
+          </a:lnRef>
+          <a:fillRef idx="3">
+            <a:schemeClr val="accent1"/>
+          </a:fillRef>
+          <a:effectRef idx="2">
+            <a:schemeClr val="accent1"/>
+          </a:effectRef>
+          <a:fontRef idx="minor">
+            <a:schemeClr val="lt1"/>
+          </a:fontRef>
+        </p:style>
+        <p:txBody>
+          <a:bodyPr rtlCol="0" anchor="ctr"/>
+          <a:lstStyle/>
+          <a:p>
+            <a:pPr algn="ctr"/>
+          </a:p>
+        </p:txBody>
+      </p:sp>
+      <p:sp>
+        <p:nvSpPr>
+          <p:cNvPr id="7" name="TextBox 6"/>
+          <p:cNvSpPr txBox="1"/>
+          <p:nvPr/>
+        </p:nvSpPr>
+        <p:spPr>
+          <a:xfrm>
+            <a:off x="960120" y="1746504"/>
+            <a:ext cx="4754880" cy="4553712"/>
+          </a:xfrm>
+          <a:prstGeom prst="rect">
+            <a:avLst/>
+          </a:prstGeom>
+          <a:noFill/>
+        </p:spPr>
+        <p:txBody>
+          <a:bodyPr wrap="square">
+            <a:spAutoFit/>
+          </a:bodyPr>
+          <a:lstStyle/>
+          <a:p>
+            <a:pPr>
+              <a:defRPr sz="1400" b="1">
+                <a:solidFill>
+                  <a:srgbClr val="38BDF8"/>
+                </a:solidFill>
+                <a:latin typeface="Segoe UI"/>
+              </a:defRPr>
+            </a:pPr>
+            <a:r>
+              <a:t>12-Column NS-2 Event Record Architecture</a:t>
+            </a:r>
+          </a:p>
+          <a:p>
+            <a:pPr>
+              <a:spcBef>
+                <a:spcPts val="200"/>
+              </a:spcBef>
+              <a:defRPr sz="1050">
+                <a:solidFill>
+                  <a:srgbClr val="94A3B8"/>
+                </a:solidFill>
+                <a:latin typeface="Segoe UI"/>
+              </a:defRPr>
+            </a:pPr>
+            <a:r>
+              <a:t>Microsecond event log schema across simulated network links:</a:t>
+            </a:r>
+          </a:p>
+          <a:p>
+            <a:pPr>
+              <a:spcBef>
+                <a:spcPts val="500"/>
+              </a:spcBef>
+              <a:defRPr sz="1050">
+                <a:solidFill>
+                  <a:srgbClr val="F8FAFC"/>
+                </a:solidFill>
+                <a:latin typeface="Segoe UI"/>
+              </a:defRPr>
+            </a:pPr>
+            <a:r>
+              <a:t>As packets traverse the simulated link, NS-2 outputs granular event records to standard trace files (.tr). Each line in the trace file contains twelve whitespace-delimited columns that completely characterize a discrete network event: 1. Event Type: '+' (Enqueue), '-' (Dequeue/Transmit), 'r' (Receive), 'd' (Drop). 2. Event Timestamp: Simulation time in seconds with microsecond precision. 3. Source Node ID: Node where event occurred (e.g., 0). 4. Destination Node ID: Intended destination node (e.g., 1).</a:t>
+            </a:r>
+          </a:p>
+          <a:p>
+            <a:pPr>
+              <a:spcBef>
+                <a:spcPts val="500"/>
+              </a:spcBef>
+              <a:defRPr sz="1000">
+                <a:solidFill>
+                  <a:srgbClr val="94A3B8"/>
+                </a:solidFill>
+                <a:latin typeface="Segoe UI"/>
+              </a:defRPr>
+            </a:pPr>
+            <a:r>
+              <a:t>Columns 5 to 12 record: 5. Packet Name (cbr/UDP), 6. Packet Size (bytes), 7. Flags, 8. Flow ID, 9. Source Address (Node.Port e.g., 0.0), 10. Destination Address (Node.Port e.g., 1.0), 11. Packet Sequence Number, and 12. Unique Packet ID assigned by the simulation scheduler.</a:t>
+            </a:r>
+          </a:p>
+        </p:txBody>
+      </p:sp>
+      <p:sp>
+        <p:nvSpPr>
+          <p:cNvPr id="8" name="Rounded Rectangle 7"/>
+          <p:cNvSpPr/>
+          <p:nvPr/>
+        </p:nvSpPr>
+        <p:spPr>
+          <a:xfrm>
+            <a:off x="6217920" y="1600200"/>
+            <a:ext cx="5212080" cy="4846320"/>
+          </a:xfrm>
+          <a:prstGeom prst="roundRect">
+            <a:avLst/>
+          </a:prstGeom>
+          <a:solidFill>
+            <a:srgbClr val="1E293B"/>
+          </a:solidFill>
+          <a:ln w="19050">
+            <a:solidFill>
+              <a:srgbClr val="334155"/>
+            </a:solidFill>
+          </a:ln>
+        </p:spPr>
+        <p:style>
+          <a:lnRef idx="1">
+            <a:schemeClr val="accent1"/>
+          </a:lnRef>
+          <a:fillRef idx="3">
+            <a:schemeClr val="accent1"/>
+          </a:fillRef>
+          <a:effectRef idx="2">
+            <a:schemeClr val="accent1"/>
+          </a:effectRef>
+          <a:fontRef idx="minor">
+            <a:schemeClr val="lt1"/>
+          </a:fontRef>
+        </p:style>
+        <p:txBody>
+          <a:bodyPr rtlCol="0" anchor="ctr"/>
+          <a:lstStyle/>
+          <a:p>
+            <a:pPr algn="ctr"/>
+          </a:p>
+        </p:txBody>
+      </p:sp>
+      <p:sp>
+        <p:nvSpPr>
+          <p:cNvPr id="9" name="TextBox 8"/>
+          <p:cNvSpPr txBox="1"/>
+          <p:nvPr/>
+        </p:nvSpPr>
+        <p:spPr>
+          <a:xfrm>
+            <a:off x="6446520" y="1746504"/>
+            <a:ext cx="4754880" cy="4553712"/>
+          </a:xfrm>
+          <a:prstGeom prst="rect">
+            <a:avLst/>
+          </a:prstGeom>
+          <a:noFill/>
+        </p:spPr>
+        <p:txBody>
+          <a:bodyPr wrap="square">
+            <a:spAutoFit/>
+          </a:bodyPr>
+          <a:lstStyle/>
+          <a:p>
+            <a:pPr>
+              <a:defRPr sz="1400" b="1">
+                <a:solidFill>
+                  <a:srgbClr val="38BDF8"/>
+                </a:solidFill>
+                <a:latin typeface="Segoe UI"/>
+              </a:defRPr>
+            </a:pPr>
+            <a:r>
+              <a:t>Python-to-NS-2 Bridge &amp; Live PER Analytics</a:t>
+            </a:r>
+          </a:p>
+          <a:p>
+            <a:pPr>
+              <a:spcBef>
+                <a:spcPts val="200"/>
+              </a:spcBef>
+              <a:defRPr sz="1050">
+                <a:solidFill>
+                  <a:srgbClr val="94A3B8"/>
+                </a:solidFill>
+                <a:latin typeface="Segoe UI"/>
+              </a:defRPr>
+            </a:pPr>
+            <a:r>
+              <a:t>Subprocess execution, regex parsing, and live dashboard metrics:</a:t>
+            </a:r>
+          </a:p>
+          <a:p>
+            <a:pPr>
+              <a:spcBef>
+                <a:spcPts val="500"/>
+              </a:spcBef>
+              <a:defRPr sz="1050">
+                <a:solidFill>
+                  <a:srgbClr val="F8FAFC"/>
+                </a:solidFill>
+                <a:latin typeface="Segoe UI"/>
+              </a:defRPr>
+            </a:pPr>
+            <a:r>
+              <a:t>Our Python simulation bridge (modules/ns2_bridge.py) automates the execution of NS-2 inside Windows Subsystem for Linux (WSL) and parses the 12-column event records in real time. The bridge extracts total transmitted packets (N_tx), total successfully received packets (N_rx), and total dropped packets (N_drop).</a:t>
+            </a:r>
+          </a:p>
+          <a:p>
+            <a:pPr>
+              <a:spcBef>
+                <a:spcPts val="500"/>
+              </a:spcBef>
+              <a:defRPr sz="1000">
+                <a:solidFill>
+                  <a:srgbClr val="94A3B8"/>
+                </a:solidFill>
+                <a:latin typeface="Segoe UI"/>
+              </a:defRPr>
+            </a:pPr>
+            <a:r>
+              <a:t>The Packet Error Rate (PER) is computed mathematically as: PER = (N_drop / (N_rx + N_drop)) * 100%. The parsed metrics, transmission latencies, and drop event breakdowns are streamed directly to the web dashboard and desktop GUI, providing transparent verification of physical channel noise.</a:t>
+            </a:r>
+          </a:p>
+        </p:txBody>
+      </p:sp>
+    </p:spTree>
+  </p:cSld>
+  <p:clrMapOvr>
+    <a:masterClrMapping/>
+  </p:clrMapOvr>
+</p:sld>
+</file>
+
+<file path=ppt/slides/slide16.xml><?xml version="1.0" encoding="utf-8"?>
+<p:sld xmlns:a="http://schemas.openxmlformats.org/drawingml/2006/main" xmlns:p="http://schemas.openxmlformats.org/presentationml/2006/main" xmlns:r="http://schemas.openxmlformats.org/officeDocument/2006/relationships">
+  <p:cSld>
+    <p:spTree>
+      <p:nvGrpSpPr>
+        <p:cNvPr id="1" name=""/>
+        <p:cNvGrpSpPr/>
+        <p:nvPr/>
+      </p:nvGrpSpPr>
+      <p:grpSpPr/>
+      <p:sp>
+        <p:nvSpPr>
+          <p:cNvPr id="2" name="Rectangle 1"/>
+          <p:cNvSpPr/>
+          <p:nvPr/>
+        </p:nvSpPr>
+        <p:spPr>
+          <a:xfrm>
+            <a:off x="0" y="0"/>
+            <a:ext cx="12191695" cy="6858000"/>
+          </a:xfrm>
+          <a:prstGeom prst="rect">
+            <a:avLst/>
+          </a:prstGeom>
+          <a:solidFill>
+            <a:srgbClr val="0F172A"/>
+          </a:solidFill>
+          <a:ln>
+            <a:noFill/>
+          </a:ln>
+        </p:spPr>
+        <p:style>
+          <a:lnRef idx="1">
+            <a:schemeClr val="accent1"/>
+          </a:lnRef>
+          <a:fillRef idx="3">
+            <a:schemeClr val="accent1"/>
+          </a:fillRef>
+          <a:effectRef idx="2">
+            <a:schemeClr val="accent1"/>
+          </a:effectRef>
+          <a:fontRef idx="minor">
+            <a:schemeClr val="lt1"/>
+          </a:fontRef>
+        </p:style>
+        <p:txBody>
+          <a:bodyPr rtlCol="0" anchor="ctr"/>
+          <a:lstStyle/>
+          <a:p>
+            <a:pPr algn="ctr"/>
+          </a:p>
+        </p:txBody>
+      </p:sp>
+      <p:sp>
+        <p:nvSpPr>
+          <p:cNvPr id="3" name="TextBox 2"/>
+          <p:cNvSpPr txBox="1"/>
+          <p:nvPr/>
+        </p:nvSpPr>
+        <p:spPr>
+          <a:xfrm>
+            <a:off x="731520" y="320040"/>
+            <a:ext cx="7315200" cy="320040"/>
+          </a:xfrm>
+          <a:prstGeom prst="rect">
+            <a:avLst/>
+          </a:prstGeom>
+          <a:noFill/>
+        </p:spPr>
+        <p:txBody>
+          <a:bodyPr wrap="square">
+            <a:spAutoFit/>
+          </a:bodyPr>
+          <a:lstStyle/>
+          <a:p>
+            <a:pPr>
+              <a:defRPr sz="1050" b="1">
+                <a:solidFill>
+                  <a:srgbClr val="38BDF8"/>
+                </a:solidFill>
+                <a:latin typeface="Segoe UI"/>
+              </a:defRPr>
+            </a:pPr>
+            <a:r>
+              <a:t>●  EMPIRICAL VALIDATION</a:t>
+            </a:r>
+          </a:p>
+        </p:txBody>
+      </p:sp>
+      <p:sp>
+        <p:nvSpPr>
+          <p:cNvPr id="4" name="TextBox 3"/>
+          <p:cNvSpPr txBox="1"/>
+          <p:nvPr/>
+        </p:nvSpPr>
+        <p:spPr>
+          <a:xfrm>
+            <a:off x="731520" y="594360"/>
+            <a:ext cx="10725912" cy="594360"/>
+          </a:xfrm>
+          <a:prstGeom prst="rect">
+            <a:avLst/>
+          </a:prstGeom>
+          <a:noFill/>
+        </p:spPr>
+        <p:txBody>
+          <a:bodyPr wrap="square">
+            <a:spAutoFit/>
+          </a:bodyPr>
+          <a:lstStyle/>
+          <a:p>
+            <a:pPr>
+              <a:defRPr sz="2100" b="1">
+                <a:solidFill>
+                  <a:srgbClr val="F8FAFC"/>
+                </a:solidFill>
+                <a:latin typeface="Segoe UI"/>
+              </a:defRPr>
+            </a:pPr>
+            <a:r>
+              <a:t>Multi-Technique NS-2 Verification Matrix</a:t>
+            </a:r>
+          </a:p>
+        </p:txBody>
+      </p:sp>
+      <p:sp>
+        <p:nvSpPr>
+          <p:cNvPr id="5" name="TextBox 4"/>
+          <p:cNvSpPr txBox="1"/>
+          <p:nvPr/>
+        </p:nvSpPr>
+        <p:spPr>
+          <a:xfrm>
+            <a:off x="731520" y="1115568"/>
+            <a:ext cx="10725912" cy="365760"/>
+          </a:xfrm>
+          <a:prstGeom prst="rect">
+            <a:avLst/>
+          </a:prstGeom>
+          <a:noFill/>
+        </p:spPr>
+        <p:txBody>
+          <a:bodyPr wrap="square">
+            <a:spAutoFit/>
+          </a:bodyPr>
+          <a:lstStyle/>
+          <a:p>
+            <a:pPr>
+              <a:defRPr sz="1150">
                 <a:solidFill>
                   <a:srgbClr val="94A3B8"/>
                 </a:solidFill>
@@ -4782,8 +7350,8 @@
         </p:nvSpPr>
         <p:spPr>
           <a:xfrm>
-            <a:off x="960120" y="4416552"/>
-            <a:ext cx="10268712" cy="1865376"/>
+            <a:off x="960120" y="4398264"/>
+            <a:ext cx="10268712" cy="1901952"/>
           </a:xfrm>
           <a:prstGeom prst="rect">
             <a:avLst/>
@@ -4797,7 +7365,7 @@
           <a:lstStyle/>
           <a:p>
             <a:pPr>
-              <a:defRPr sz="1500" b="1">
+              <a:defRPr sz="1400" b="1">
                 <a:solidFill>
                   <a:srgbClr val="38BDF8"/>
                 </a:solidFill>
@@ -4806,22 +7374,6 @@
             </a:pPr>
             <a:r>
               <a:t>Empirical NS-2 Verification &amp; Batch Runner Analysis (/api/run-ns2-all)</a:t>
-            </a:r>
-          </a:p>
-          <a:p>
-            <a:pPr>
-              <a:spcBef>
-                <a:spcPts val="400"/>
-              </a:spcBef>
-              <a:defRPr sz="1100">
-                <a:solidFill>
-                  <a:srgbClr val="F8FAFC"/>
-                </a:solidFill>
-                <a:latin typeface="Segoe UI"/>
-              </a:defRPr>
-            </a:pPr>
-            <a:r>
-              <a:t>To provide rigorous empirical evidence to the academic examination panel, our simulation platform links each of the five error control algorithms directly to its own dedicated NS-2 trace file. In the project directory, five distinct trace files—ns2_parity.tr, ns2_parity2d.tr, ns2_hamming.tr, ns2_checksum.tr, and ns2_crc.tr—record the exact packet transmission, queue latency, and drop events generated during live simulation runs.</a:t>
             </a:r>
           </a:p>
           <a:p>
@@ -4830,6 +7382,22 @@
                 <a:spcPts val="400"/>
               </a:spcBef>
               <a:defRPr sz="1050">
+                <a:solidFill>
+                  <a:srgbClr val="F8FAFC"/>
+                </a:solidFill>
+                <a:latin typeface="Segoe UI"/>
+              </a:defRPr>
+            </a:pPr>
+            <a:r>
+              <a:t>To provide rigorous empirical evidence to the academic examination panel, our simulation platform links each of the five error control algorithms directly to its own dedicated NS-2 trace file. In the project directory, five distinct trace files—ns2_parity.tr, ns2_parity2d.tr, ns2_hamming.tr, ns2_checksum.tr, and ns2_crc.tr—record the exact packet transmission, queue latency, and drop events generated during live simulation runs.</a:t>
+            </a:r>
+          </a:p>
+          <a:p>
+            <a:pPr>
+              <a:spcBef>
+                <a:spcPts val="400"/>
+              </a:spcBef>
+              <a:defRPr sz="1000">
                 <a:solidFill>
                   <a:srgbClr val="94A3B8"/>
                 </a:solidFill>
@@ -4850,7 +7418,7 @@
 </p:sld>
 </file>
 
-<file path=ppt/slides/slide11.xml><?xml version="1.0" encoding="utf-8"?>
+<file path=ppt/slides/slide17.xml><?xml version="1.0" encoding="utf-8"?>
 <p:sld xmlns:a="http://schemas.openxmlformats.org/drawingml/2006/main" xmlns:p="http://schemas.openxmlformats.org/presentationml/2006/main" xmlns:r="http://schemas.openxmlformats.org/officeDocument/2006/relationships">
   <p:cSld>
     <p:spTree>
@@ -4962,7 +7530,7 @@
           <a:lstStyle/>
           <a:p>
             <a:pPr>
-              <a:defRPr sz="2200" b="1">
+              <a:defRPr sz="2100" b="1">
                 <a:solidFill>
                   <a:srgbClr val="F8FAFC"/>
                 </a:solidFill>
@@ -4998,7 +7566,7 @@
           <a:lstStyle/>
           <a:p>
             <a:pPr>
-              <a:defRPr sz="1200">
+              <a:defRPr sz="1150">
                 <a:solidFill>
                   <a:srgbClr val="94A3B8"/>
                 </a:solidFill>
@@ -5970,8 +8538,8 @@
         </p:nvSpPr>
         <p:spPr>
           <a:xfrm>
-            <a:off x="960120" y="4416552"/>
-            <a:ext cx="10268712" cy="1865376"/>
+            <a:off x="960120" y="4398264"/>
+            <a:ext cx="10268712" cy="1901952"/>
           </a:xfrm>
           <a:prstGeom prst="rect">
             <a:avLst/>
@@ -5985,7 +8553,7 @@
           <a:lstStyle/>
           <a:p>
             <a:pPr>
-              <a:defRPr sz="1500" b="1">
+              <a:defRPr sz="1400" b="1">
                 <a:solidFill>
                   <a:srgbClr val="38BDF8"/>
                 </a:solidFill>
@@ -5994,22 +8562,6 @@
             </a:pPr>
             <a:r>
               <a:t>Multi-Dimensional Technical Trade-Off Analysis</a:t>
-            </a:r>
-          </a:p>
-          <a:p>
-            <a:pPr>
-              <a:spcBef>
-                <a:spcPts val="400"/>
-              </a:spcBef>
-              <a:defRPr sz="1100">
-                <a:solidFill>
-                  <a:srgbClr val="F8FAFC"/>
-                </a:solidFill>
-                <a:latin typeface="Segoe UI"/>
-              </a:defRPr>
-            </a:pPr>
-            <a:r>
-              <a:t>A comprehensive engineering evaluation of error control mechanisms requires balancing four competing design constraints: transmission bandwidth overhead, computational complexity, error detection strength, and forward error correction capability. 1D Parity offers the absolute lowest bandwidth overhead (1 bit per codeword) and simplest hardware implementation (O(n) XOR gates), but provides no error correction and fails to detect even numbers of bit flips. 2D Parity introduces moderate overhead (M + N + 1 bits) but achieves single-bit forward error correction through orthogonal grid localization. Hamming Code provides optimal single-error correction (SEC) with logarithmic parity overhead (ceil(log2(n+k+1))), making it ideal for hardware-accelerated memory architectures.</a:t>
             </a:r>
           </a:p>
           <a:p>
@@ -6018,6 +8570,22 @@
                 <a:spcPts val="400"/>
               </a:spcBef>
               <a:defRPr sz="1050">
+                <a:solidFill>
+                  <a:srgbClr val="F8FAFC"/>
+                </a:solidFill>
+                <a:latin typeface="Segoe UI"/>
+              </a:defRPr>
+            </a:pPr>
+            <a:r>
+              <a:t>A comprehensive engineering evaluation of error control mechanisms requires balancing four competing design constraints: transmission bandwidth overhead, computational complexity, error detection strength, and forward error correction capability. 1D Parity offers the absolute lowest bandwidth overhead (1 bit per codeword) and simplest hardware implementation (O(n) XOR gates), but provides no error correction and fails to detect even numbers of bit flips. 2D Parity introduces moderate overhead (M + N + 1 bits) but achieves single-bit forward error correction through orthogonal grid localization. Hamming Code provides optimal single-error correction (SEC) with logarithmic parity overhead (ceil(log2(n+k+1))), making it ideal for hardware-accelerated memory architectures.</a:t>
+            </a:r>
+          </a:p>
+          <a:p>
+            <a:pPr>
+              <a:spcBef>
+                <a:spcPts val="400"/>
+              </a:spcBef>
+              <a:defRPr sz="1000">
                 <a:solidFill>
                   <a:srgbClr val="94A3B8"/>
                 </a:solidFill>
@@ -6038,7 +8606,7 @@
 </p:sld>
 </file>
 
-<file path=ppt/slides/slide12.xml><?xml version="1.0" encoding="utf-8"?>
+<file path=ppt/slides/slide18.xml><?xml version="1.0" encoding="utf-8"?>
 <p:sld xmlns:a="http://schemas.openxmlformats.org/drawingml/2006/main" xmlns:p="http://schemas.openxmlformats.org/presentationml/2006/main" xmlns:r="http://schemas.openxmlformats.org/officeDocument/2006/relationships">
   <p:cSld>
     <p:spTree>
@@ -6150,7 +8718,7 @@
           <a:lstStyle/>
           <a:p>
             <a:pPr>
-              <a:defRPr sz="2200" b="1">
+              <a:defRPr sz="2100" b="1">
                 <a:solidFill>
                   <a:srgbClr val="F8FAFC"/>
                 </a:solidFill>
@@ -6186,7 +8754,7 @@
           <a:lstStyle/>
           <a:p>
             <a:pPr>
-              <a:defRPr sz="1200">
+              <a:defRPr sz="1150">
                 <a:solidFill>
                   <a:srgbClr val="94A3B8"/>
                 </a:solidFill>
@@ -6252,8 +8820,8 @@
         </p:nvSpPr>
         <p:spPr>
           <a:xfrm>
-            <a:off x="960120" y="1764792"/>
-            <a:ext cx="4754880" cy="4517136"/>
+            <a:off x="960120" y="1746504"/>
+            <a:ext cx="4754880" cy="4553712"/>
           </a:xfrm>
           <a:prstGeom prst="rect">
             <a:avLst/>
@@ -6267,7 +8835,7 @@
           <a:lstStyle/>
           <a:p>
             <a:pPr>
-              <a:defRPr sz="1500" b="1">
+              <a:defRPr sz="1400" b="1">
                 <a:solidFill>
                   <a:srgbClr val="38BDF8"/>
                 </a:solidFill>
@@ -6283,7 +8851,7 @@
               <a:spcBef>
                 <a:spcPts val="200"/>
               </a:spcBef>
-              <a:defRPr sz="1100">
+              <a:defRPr sz="1050">
                 <a:solidFill>
                   <a:srgbClr val="94A3B8"/>
                 </a:solidFill>
@@ -6297,25 +8865,25 @@
           <a:p>
             <a:pPr>
               <a:spcBef>
-                <a:spcPts val="600"/>
-              </a:spcBef>
-              <a:defRPr sz="1100">
-                <a:solidFill>
-                  <a:srgbClr val="F8FAFC"/>
-                </a:solidFill>
-                <a:latin typeface="Segoe UI"/>
-              </a:defRPr>
-            </a:pPr>
-            <a:r>
-              <a:t>The Interactive Network Error Detection &amp; Correction Simulator was developed using an enterprise-grade multi-platform architecture designed for accessibility, academic demonstrations, and research experimentation. The computational core is powered by Python 3.14, implementing custom algorithmic modules for Parity, 2D Matrix, Hamming Code, RFC 1071 Checksum, and CRC polynomial division without external dependencies. The user interface is provided in two complementary forms: a high-performance native desktop GUI developed using Python Tkinter, and a modern, responsive web application built with Vanilla HTML5, CSS3 glassmorphism design tokens, and modular asynchronous JavaScript.</a:t>
-            </a:r>
-          </a:p>
-          <a:p>
-            <a:pPr>
-              <a:spcBef>
-                <a:spcPts val="600"/>
+                <a:spcPts val="500"/>
               </a:spcBef>
               <a:defRPr sz="1050">
+                <a:solidFill>
+                  <a:srgbClr val="F8FAFC"/>
+                </a:solidFill>
+                <a:latin typeface="Segoe UI"/>
+              </a:defRPr>
+            </a:pPr>
+            <a:r>
+              <a:t>The Interactive Network Error Detection &amp; Correction Simulator was developed using an enterprise-grade multi-platform architecture designed for accessibility, academic demonstrations, and research experimentation. The computational core is powered by Python 3.14, implementing custom algorithmic modules for Parity, 2D Matrix, Hamming Code, RFC 1071 Checksum, and CRC polynomial division without external dependencies. The user interface is provided in two complementary forms: a high-performance native desktop GUI developed using Python Tkinter, and a modern, responsive web application built with Vanilla HTML5, CSS3 glassmorphism design tokens, and modular asynchronous JavaScript.</a:t>
+            </a:r>
+          </a:p>
+          <a:p>
+            <a:pPr>
+              <a:spcBef>
+                <a:spcPts val="500"/>
+              </a:spcBef>
+              <a:defRPr sz="1000">
                 <a:solidFill>
                   <a:srgbClr val="94A3B8"/>
                 </a:solidFill>
@@ -6381,8 +8949,8 @@
         </p:nvSpPr>
         <p:spPr>
           <a:xfrm>
-            <a:off x="6446520" y="1764792"/>
-            <a:ext cx="4754880" cy="4517136"/>
+            <a:off x="6446520" y="1746504"/>
+            <a:ext cx="4754880" cy="4553712"/>
           </a:xfrm>
           <a:prstGeom prst="rect">
             <a:avLst/>
@@ -6396,7 +8964,7 @@
           <a:lstStyle/>
           <a:p>
             <a:pPr>
-              <a:defRPr sz="1500" b="1">
+              <a:defRPr sz="1400" b="1">
                 <a:solidFill>
                   <a:srgbClr val="38BDF8"/>
                 </a:solidFill>
@@ -6412,7 +8980,7 @@
               <a:spcBef>
                 <a:spcPts val="200"/>
               </a:spcBef>
-              <a:defRPr sz="1100">
+              <a:defRPr sz="1050">
                 <a:solidFill>
                   <a:srgbClr val="94A3B8"/>
                 </a:solidFill>
@@ -6466,7 +9034,7 @@
           <a:p>
             <a:pPr>
               <a:spcBef>
-                <a:spcPts val="600"/>
+                <a:spcPts val="500"/>
               </a:spcBef>
               <a:defRPr sz="1050">
                 <a:solidFill>
@@ -6482,9 +9050,9 @@
           <a:p>
             <a:pPr>
               <a:spcBef>
-                <a:spcPts val="600"/>
+                <a:spcPts val="500"/>
               </a:spcBef>
-              <a:defRPr sz="1050">
+              <a:defRPr sz="1000">
                 <a:solidFill>
                   <a:srgbClr val="94A3B8"/>
                 </a:solidFill>
@@ -6617,7 +9185,7 @@
           <a:lstStyle/>
           <a:p>
             <a:pPr>
-              <a:defRPr sz="2200" b="1">
+              <a:defRPr sz="2100" b="1">
                 <a:solidFill>
                   <a:srgbClr val="F8FAFC"/>
                 </a:solidFill>
@@ -6653,7 +9221,7 @@
           <a:lstStyle/>
           <a:p>
             <a:pPr>
-              <a:defRPr sz="1200">
+              <a:defRPr sz="1150">
                 <a:solidFill>
                   <a:srgbClr val="94A3B8"/>
                 </a:solidFill>
@@ -6719,8 +9287,8 @@
         </p:nvSpPr>
         <p:spPr>
           <a:xfrm>
-            <a:off x="960120" y="1764792"/>
-            <a:ext cx="4754880" cy="4517136"/>
+            <a:off x="960120" y="1746504"/>
+            <a:ext cx="4754880" cy="4553712"/>
           </a:xfrm>
           <a:prstGeom prst="rect">
             <a:avLst/>
@@ -6734,7 +9302,7 @@
           <a:lstStyle/>
           <a:p>
             <a:pPr>
-              <a:defRPr sz="1500" b="1">
+              <a:defRPr sz="1400" b="1">
                 <a:solidFill>
                   <a:srgbClr val="38BDF8"/>
                 </a:solidFill>
@@ -6750,7 +9318,7 @@
               <a:spcBef>
                 <a:spcPts val="200"/>
               </a:spcBef>
-              <a:defRPr sz="1100">
+              <a:defRPr sz="1050">
                 <a:solidFill>
                   <a:srgbClr val="94A3B8"/>
                 </a:solidFill>
@@ -6764,33 +9332,33 @@
           <a:p>
             <a:pPr>
               <a:spcBef>
-                <a:spcPts val="600"/>
-              </a:spcBef>
-              <a:defRPr sz="1100">
-                <a:solidFill>
-                  <a:srgbClr val="F8FAFC"/>
-                </a:solidFill>
-                <a:latin typeface="Segoe UI"/>
-              </a:defRPr>
-            </a:pPr>
-            <a:r>
-              <a:t>In modern data communications, physical transmission channels—such as copper twisted pairs, coaxial cables, optical fibers, and free-space wireless RF media—are inherently subject to ambient physical impairments. Thermal noise, electromagnetic interference (EMI), signal attenuation, cross-talk, and transient voltage spikes cause bit inversions (0 becoming 1 or 1 becoming 0) and multi-bit burst corruptions across transmission lines.</a:t>
-            </a:r>
-          </a:p>
-          <a:p>
-            <a:pPr>
-              <a:spcBef>
-                <a:spcPts val="600"/>
+                <a:spcPts val="500"/>
               </a:spcBef>
               <a:defRPr sz="1050">
                 <a:solidFill>
+                  <a:srgbClr val="F8FAFC"/>
+                </a:solidFill>
+                <a:latin typeface="Segoe UI"/>
+              </a:defRPr>
+            </a:pPr>
+            <a:r>
+              <a:t>In modern digital communications, physical transmission media—including copper unshielded twisted pair (UTP), coaxial cabling, optical fiber wave-guides, and free-space radio frequency (RF) channels—are continuously subjected to environmental physical noise. Thermal noise generated by electron agitation, electromagnetic interference (EMI) from industrial machinery, signal attenuation over distance, cross-talk between adjacent conductors, and transient voltage spikes induce unpredictable bit inversions (logic 0 flipping to logic 1 or vice-versa) as well as multi-bit burst corruptions across physical lines.</a:t>
+            </a:r>
+          </a:p>
+          <a:p>
+            <a:pPr>
+              <a:spcBef>
+                <a:spcPts val="500"/>
+              </a:spcBef>
+              <a:defRPr sz="1000">
+                <a:solidFill>
                   <a:srgbClr val="94A3B8"/>
                 </a:solidFill>
                 <a:latin typeface="Segoe UI"/>
               </a:defRPr>
             </a:pPr>
             <a:r>
-              <a:t>Without robust Data Link Layer error control, higher-layer protocols (such as TCP, IP, and application payloads) receive corrupted frames, resulting in catastrophic system crashes, corrupted database records, and critical security vulnerabilities. Furthermore, traditional academic instruction relies on static textbook formulas that fail to demonstrate how check bits interact with live channel noise, queueing delays, and packet drop events across active communication links.</a:t>
+              <a:t>In the absence of robust Data Link Layer error detection and correction mechanisms, corrupted bit patterns traverse silently into higher-layer protocols. This leads to severe data integrity failures, silent file corruptions, application crashes, and compromised cryptographic handshakes. Preventing silent data corruption requires mathematically sound redundancy techniques that detect and resolve frame errors before handing payloads to upper layers.</a:t>
             </a:r>
           </a:p>
         </p:txBody>
@@ -6848,8 +9416,8 @@
         </p:nvSpPr>
         <p:spPr>
           <a:xfrm>
-            <a:off x="6446520" y="1764792"/>
-            <a:ext cx="4754880" cy="4517136"/>
+            <a:off x="6446520" y="1746504"/>
+            <a:ext cx="4754880" cy="4553712"/>
           </a:xfrm>
           <a:prstGeom prst="rect">
             <a:avLst/>
@@ -6863,7 +9431,7 @@
           <a:lstStyle/>
           <a:p>
             <a:pPr>
-              <a:defRPr sz="1500" b="1">
+              <a:defRPr sz="1400" b="1">
                 <a:solidFill>
                   <a:srgbClr val="38BDF8"/>
                 </a:solidFill>
@@ -6871,7 +9439,7 @@
               </a:defRPr>
             </a:pPr>
             <a:r>
-              <a:t>2. Project Engineering Objectives</a:t>
+              <a:t>2. Pedagogical Gaps &amp; Project Engineering Goals</a:t>
             </a:r>
           </a:p>
           <a:p>
@@ -6879,7 +9447,7 @@
               <a:spcBef>
                 <a:spcPts val="200"/>
               </a:spcBef>
-              <a:defRPr sz="1100">
+              <a:defRPr sz="1050">
                 <a:solidFill>
                   <a:srgbClr val="94A3B8"/>
                 </a:solidFill>
@@ -6893,33 +9461,33 @@
           <a:p>
             <a:pPr>
               <a:spcBef>
-                <a:spcPts val="600"/>
-              </a:spcBef>
-              <a:defRPr sz="1100">
-                <a:solidFill>
-                  <a:srgbClr val="F8FAFC"/>
-                </a:solidFill>
-                <a:latin typeface="Segoe UI"/>
-              </a:defRPr>
-            </a:pPr>
-            <a:r>
-              <a:t>The primary objective of this project is to bridge mathematical error detection theory with practical network engineering. We developed an interactive dual-mode simulation environment that implements five classical error control algorithms from first mathematical principles while linking each algorithm to a real-world Network Simulator 2 (NS-2) discrete-event transmission engine.</a:t>
-            </a:r>
-          </a:p>
-          <a:p>
-            <a:pPr>
-              <a:spcBef>
-                <a:spcPts val="600"/>
+                <a:spcPts val="500"/>
               </a:spcBef>
               <a:defRPr sz="1050">
                 <a:solidFill>
+                  <a:srgbClr val="F8FAFC"/>
+                </a:solidFill>
+                <a:latin typeface="Segoe UI"/>
+              </a:defRPr>
+            </a:pPr>
+            <a:r>
+              <a:t>Traditional academic curricula in computer networks frequently treat error control algorithms as static textbook equations, divorcing the discrete mathematics of check bits from the dynamic reality of packet transmission across physical links. Students compute parities and remainders by hand on paper, but rarely observe how these redundant bits interact with transmission queues, propagation delays, and stochastic packet drop events across simulated networks.</a:t>
+            </a:r>
+          </a:p>
+          <a:p>
+            <a:pPr>
+              <a:spcBef>
+                <a:spcPts val="500"/>
+              </a:spcBef>
+              <a:defRPr sz="1000">
+                <a:solidFill>
                   <a:srgbClr val="94A3B8"/>
                 </a:solidFill>
                 <a:latin typeface="Segoe UI"/>
               </a:defRPr>
             </a:pPr>
             <a:r>
-              <a:t>The platform provides complete transparency into every phase of communication: binary data encoding, redundancy overhead calculation, physical channel noise injection, receiver syndrome computation, and Forward Error Correction (FEC). Available as a Python Tkinter desktop GUI, a local HTTP server, and a cloud-hosted web application, the system allows students and professors to interactively flip bits, configure NS-2 error rates, and observe real-time packet recovery.</a:t>
+              <a:t>To resolve this pedagogical limitation, our primary engineering objective was to construct an interactive, dual-mode simulation environment that pairs first-principles mathematical encoding with an authentic discrete-event network simulator (NS-2). The platform empowers users to inject arbitrary noise patterns, observe real-time syndrome calculations, and analyze packet traces across realistic communication channels.</a:t>
             </a:r>
           </a:p>
         </p:txBody>
@@ -7044,7 +9612,7 @@
           <a:lstStyle/>
           <a:p>
             <a:pPr>
-              <a:defRPr sz="2200" b="1">
+              <a:defRPr sz="2100" b="1">
                 <a:solidFill>
                   <a:srgbClr val="F8FAFC"/>
                 </a:solidFill>
@@ -7080,7 +9648,7 @@
           <a:lstStyle/>
           <a:p>
             <a:pPr>
-              <a:defRPr sz="1200">
+              <a:defRPr sz="1150">
                 <a:solidFill>
                   <a:srgbClr val="94A3B8"/>
                 </a:solidFill>
@@ -7146,8 +9714,8 @@
         </p:nvSpPr>
         <p:spPr>
           <a:xfrm>
-            <a:off x="960120" y="1764792"/>
-            <a:ext cx="4754880" cy="4517136"/>
+            <a:off x="960120" y="1746504"/>
+            <a:ext cx="4754880" cy="4553712"/>
           </a:xfrm>
           <a:prstGeom prst="rect">
             <a:avLst/>
@@ -7161,7 +9729,7 @@
           <a:lstStyle/>
           <a:p>
             <a:pPr>
-              <a:defRPr sz="1500" b="1">
+              <a:defRPr sz="1400" b="1">
                 <a:solidFill>
                   <a:srgbClr val="38BDF8"/>
                 </a:solidFill>
@@ -7169,7 +9737,7 @@
               </a:defRPr>
             </a:pPr>
             <a:r>
-              <a:t>Transmitter &amp; Channel Modeling (Stages 1–3)</a:t>
+              <a:t>Transmitter Pipeline &amp; Channel Traversal (Stages 1–3)</a:t>
             </a:r>
           </a:p>
           <a:p>
@@ -7177,7 +9745,7 @@
               <a:spcBef>
                 <a:spcPts val="200"/>
               </a:spcBef>
-              <a:defRPr sz="1100">
+              <a:defRPr sz="1050">
                 <a:solidFill>
                   <a:srgbClr val="94A3B8"/>
                 </a:solidFill>
@@ -7191,33 +9759,33 @@
           <a:p>
             <a:pPr>
               <a:spcBef>
-                <a:spcPts val="600"/>
-              </a:spcBef>
-              <a:defRPr sz="1100">
-                <a:solidFill>
-                  <a:srgbClr val="F8FAFC"/>
-                </a:solidFill>
-                <a:latin typeface="Segoe UI"/>
-              </a:defRPr>
-            </a:pPr>
-            <a:r>
-              <a:t>The simulator is organized around an end-to-end 6-stage transmission architecture that mirrors the actual lifecycle of a Data Link Layer frame traversing a noisy physical network. In STAGE 1 (Binary Message Input), arbitrary binary sequences or ASCII plaintext are validated, formatted, and converted into raw data vectors, with presets available for 4, 8, 12, and 16-bit word lengths.</a:t>
-            </a:r>
-          </a:p>
-          <a:p>
-            <a:pPr>
-              <a:spcBef>
-                <a:spcPts val="600"/>
+                <a:spcPts val="500"/>
               </a:spcBef>
               <a:defRPr sz="1050">
                 <a:solidFill>
+                  <a:srgbClr val="F8FAFC"/>
+                </a:solidFill>
+                <a:latin typeface="Segoe UI"/>
+              </a:defRPr>
+            </a:pPr>
+            <a:r>
+              <a:t>The simulation architecture models the complete lifecycle of a network frame across six sequential pipeline stages. In STAGE 1 (Binary Data Ingestion &amp; Validation), source messages are entered as arbitrary binary vectors or converted from ASCII plaintext, supporting 4-bit, 8-bit, 12-bit, and 16-bit presets alongside custom input lengths. In STAGE 2 (Redundancy Generation &amp; Codeword Framing), the selected mathematical algorithm computes redundant check bits—such as parity bits, checksum words, or CRC remainder polynomials—and appends them to form the transmitted codeword.</a:t>
+            </a:r>
+          </a:p>
+          <a:p>
+            <a:pPr>
+              <a:spcBef>
+                <a:spcPts val="500"/>
+              </a:spcBef>
+              <a:defRPr sz="1000">
+                <a:solidFill>
                   <a:srgbClr val="94A3B8"/>
                 </a:solidFill>
                 <a:latin typeface="Segoe UI"/>
               </a:defRPr>
             </a:pPr>
             <a:r>
-              <a:t>In STAGE 2 (Redundancy Encoding &amp; Framing), the selected mathematical algorithm computes redundant check bits—such as 1D parity bits, 2D matrix parities, power-of-two Hamming check bits, 1's complement checksums, or CRC remainder polynomials—and appends them to form the transmitted codeword. In STAGE 3 (Physical Channel &amp; NS-2 Modeling), the codeword is transmitted across a point-to-point duplex link modeled in NS-2 (network_error_sim.tcl) with 2 Mbps bandwidth, 10 ms delay, and DropTail queue management, establishing an authentic discrete-event transmission environment.</a:t>
+              <a:t>In STAGE 3 (Physical Channel &amp; NS-2 Modeling), the generated codeword is packetized and transmitted across a simulated point-to-point duplex link modeled in Network Simulator 2 (network_error_sim.tcl). The link is configured with 2.0 Mbps bandwidth, 10 ms propagation delay, and DropTail queue management, capturing link traversal latency and queue dynamics.</a:t>
             </a:r>
           </a:p>
         </p:txBody>
@@ -7275,8 +9843,8 @@
         </p:nvSpPr>
         <p:spPr>
           <a:xfrm>
-            <a:off x="6446520" y="1764792"/>
-            <a:ext cx="4754880" cy="4517136"/>
+            <a:off x="6446520" y="1746504"/>
+            <a:ext cx="4754880" cy="4553712"/>
           </a:xfrm>
           <a:prstGeom prst="rect">
             <a:avLst/>
@@ -7290,7 +9858,7 @@
           <a:lstStyle/>
           <a:p>
             <a:pPr>
-              <a:defRPr sz="1500" b="1">
+              <a:defRPr sz="1400" b="1">
                 <a:solidFill>
                   <a:srgbClr val="38BDF8"/>
                 </a:solidFill>
@@ -7298,7 +9866,7 @@
               </a:defRPr>
             </a:pPr>
             <a:r>
-              <a:t>Noise Injection, Receiver &amp; Recovery (Stages 4–6)</a:t>
+              <a:t>Noise Injection, Receiver Verification &amp; FEC (Stages 4–6)</a:t>
             </a:r>
           </a:p>
           <a:p>
@@ -7306,7 +9874,7 @@
               <a:spcBef>
                 <a:spcPts val="200"/>
               </a:spcBef>
-              <a:defRPr sz="1100">
+              <a:defRPr sz="1050">
                 <a:solidFill>
                   <a:srgbClr val="94A3B8"/>
                 </a:solidFill>
@@ -7320,33 +9888,33 @@
           <a:p>
             <a:pPr>
               <a:spcBef>
-                <a:spcPts val="600"/>
-              </a:spcBef>
-              <a:defRPr sz="1100">
-                <a:solidFill>
-                  <a:srgbClr val="F8FAFC"/>
-                </a:solidFill>
-                <a:latin typeface="Segoe UI"/>
-              </a:defRPr>
-            </a:pPr>
-            <a:r>
-              <a:t>In STAGE 4 (Channel Noise &amp; Error Injection), transmission noise is introduced either stochastically via the NS-2 ErrorModel or interactively by allowing the user to click any bit on the canvas to invert it (0 &lt;-&gt; 1), inject random single-bit noise, or simulate multi-bit burst corruptions affecting consecutive bits across the wire.</a:t>
-            </a:r>
-          </a:p>
-          <a:p>
-            <a:pPr>
-              <a:spcBef>
-                <a:spcPts val="600"/>
+                <a:spcPts val="500"/>
               </a:spcBef>
               <a:defRPr sz="1050">
                 <a:solidFill>
+                  <a:srgbClr val="F8FAFC"/>
+                </a:solidFill>
+                <a:latin typeface="Segoe UI"/>
+              </a:defRPr>
+            </a:pPr>
+            <a:r>
+              <a:t>In STAGE 4 (Physical Noise &amp; Error Injection), channel impairments are simulated either stochastically via the NS-2 ErrorModel or interactively by clicking individual bits on the simulator track to toggle them (0 &lt;-&gt; 1), injecting random noise, or triggering 3-bit burst corruptions.</a:t>
+            </a:r>
+          </a:p>
+          <a:p>
+            <a:pPr>
+              <a:spcBef>
+                <a:spcPts val="500"/>
+              </a:spcBef>
+              <a:defRPr sz="1000">
+                <a:solidFill>
                   <a:srgbClr val="94A3B8"/>
                 </a:solidFill>
                 <a:latin typeface="Segoe UI"/>
               </a:defRPr>
             </a:pPr>
             <a:r>
-              <a:t>In STAGE 5 (Receiver Verification &amp; Syndrome Computation), the receiving node recalculates parity equations, executes 1's complement addition, or carries out Modulo-2 polynomial long division on the incoming frame. Finally, in STAGE 6 (Diagnosis, Recovery &amp; FEC), the system localizes bit errors, applies automatic Forward Error Correction where algebraically possible (as in 2D Parity and Hamming Codes), or triggers packet discard flags, displaying complete step-by-step diagnostic feedback.</a:t>
+              <a:t>In STAGE 5 (Receiver Verification &amp; Syndrome Computation), the receiving node recalculates check bits on the incoming frame, evaluating parity equations, 1's complement additions, or Modulo-2 polynomial long divisions. Finally, in STAGE 6 (Diagnostic Analysis, FEC &amp; Decision), the system localizes bit errors, applies automatic Forward Error Correction (FEC) where algebraically possible (in 2D Parity and Hamming Codes), or triggers packet discard flags, displaying comprehensive step-by-step diagnostic feedback.</a:t>
             </a:r>
           </a:p>
         </p:txBody>
@@ -7443,7 +10011,7 @@
               </a:defRPr>
             </a:pPr>
             <a:r>
-              <a:t>●  ALGORITHM 1 OF 5</a:t>
+              <a:t>●  ALGORITHM 1 OF 5: PART A</a:t>
             </a:r>
           </a:p>
         </p:txBody>
@@ -7471,7 +10039,7 @@
           <a:lstStyle/>
           <a:p>
             <a:pPr>
-              <a:defRPr sz="2200" b="1">
+              <a:defRPr sz="2100" b="1">
                 <a:solidFill>
                   <a:srgbClr val="F8FAFC"/>
                 </a:solidFill>
@@ -7479,7 +10047,7 @@
               </a:defRPr>
             </a:pPr>
             <a:r>
-              <a:t>1D Parity Check (Vertical Redundancy Check)</a:t>
+              <a:t>1D Parity Check: Theory &amp; Mathematical Formulation</a:t>
             </a:r>
           </a:p>
         </p:txBody>
@@ -7507,7 +10075,7 @@
           <a:lstStyle/>
           <a:p>
             <a:pPr>
-              <a:defRPr sz="1200">
+              <a:defRPr sz="1150">
                 <a:solidFill>
                   <a:srgbClr val="94A3B8"/>
                 </a:solidFill>
@@ -7573,8 +10141,8 @@
         </p:nvSpPr>
         <p:spPr>
           <a:xfrm>
-            <a:off x="960120" y="1764792"/>
-            <a:ext cx="4754880" cy="4517136"/>
+            <a:off x="960120" y="1746504"/>
+            <a:ext cx="4754880" cy="4553712"/>
           </a:xfrm>
           <a:prstGeom prst="rect">
             <a:avLst/>
@@ -7588,7 +10156,7 @@
           <a:lstStyle/>
           <a:p>
             <a:pPr>
-              <a:defRPr sz="1500" b="1">
+              <a:defRPr sz="1400" b="1">
                 <a:solidFill>
                   <a:srgbClr val="38BDF8"/>
                 </a:solidFill>
@@ -7596,7 +10164,7 @@
               </a:defRPr>
             </a:pPr>
             <a:r>
-              <a:t>Mathematical Formulation &amp; Working Mechanism</a:t>
+              <a:t>Parity Generation &amp; Algebraic Principles</a:t>
             </a:r>
           </a:p>
           <a:p>
@@ -7604,7 +10172,7 @@
               <a:spcBef>
                 <a:spcPts val="200"/>
               </a:spcBef>
-              <a:defRPr sz="1100">
+              <a:defRPr sz="1050">
                 <a:solidFill>
                   <a:srgbClr val="94A3B8"/>
                 </a:solidFill>
@@ -7612,39 +10180,39 @@
               </a:defRPr>
             </a:pPr>
             <a:r>
-              <a:t>Parity generation, decision boundary, and algebraic limitations:</a:t>
+              <a:t>Mathematical definition, XOR trees, and decision boundaries:</a:t>
             </a:r>
           </a:p>
           <a:p>
             <a:pPr>
               <a:spcBef>
-                <a:spcPts val="600"/>
-              </a:spcBef>
-              <a:defRPr sz="1100">
-                <a:solidFill>
-                  <a:srgbClr val="F8FAFC"/>
-                </a:solidFill>
-                <a:latin typeface="Segoe UI"/>
-              </a:defRPr>
-            </a:pPr>
-            <a:r>
-              <a:t>One-Dimensional (1D) Parity Check, traditionally referred to as Vertical Redundancy Check (VRC), represents the simplest and most lightweight error-detection mechanism in digital telecommunications. The algorithm appends a single redundant parity bit (P) to an n-bit binary data stream so that the total count of 1-bits conforms to a pre-defined parity convention. Under Even Parity, the check bit is generated as the Exclusive-OR (XOR) sum of all message bits: P = b1 ^ b2 ^ ... ^ bn, ensuring that the total count of 1s in the transmitted codeword is always even. Under Odd Parity, P is inverted so the total count of 1s is always odd.</a:t>
-            </a:r>
-          </a:p>
-          <a:p>
-            <a:pPr>
-              <a:spcBef>
-                <a:spcPts val="600"/>
+                <a:spcPts val="500"/>
               </a:spcBef>
               <a:defRPr sz="1050">
                 <a:solidFill>
+                  <a:srgbClr val="F8FAFC"/>
+                </a:solidFill>
+                <a:latin typeface="Segoe UI"/>
+              </a:defRPr>
+            </a:pPr>
+            <a:r>
+              <a:t>One-Dimensional (1D) Parity Check, historically designated as Vertical Redundancy Check (VRC), represents the most lightweight and computationally inexpensive error detection mechanism in digital communication. The algorithm appends a single redundant parity bit (P) to an n-bit binary data stream so that the total count of 1-bits satisfies a pre-agreed parity convention. Under Even Parity, the check bit is generated as the Exclusive-OR (XOR) sum of all message bits: P = b1 ^ b2 ^ ... ^ bn, guaranteeing that the total count of 1s in the transmitted codeword is always an even integer. Under Odd Parity, P is inverted so that the total count of 1s is always an odd integer.</a:t>
+            </a:r>
+          </a:p>
+          <a:p>
+            <a:pPr>
+              <a:spcBef>
+                <a:spcPts val="500"/>
+              </a:spcBef>
+              <a:defRPr sz="1000">
+                <a:solidFill>
                   <a:srgbClr val="94A3B8"/>
                 </a:solidFill>
                 <a:latin typeface="Segoe UI"/>
               </a:defRPr>
             </a:pPr>
             <a:r>
-              <a:t>At the receiving destination, the entire received codeword is XOR-summed. If the parity sum matches the expected scheme, the frame is accepted as valid. While 1D Parity requires minimal bandwidth overhead (a single bit per frame), its detection capability is strictly limited: it reliably detects all single-bit errors and any odd number of simultaneous bit flips (1, 3, 5 bits), but is completely blind to even numbers of bit flips (2, 4, 6 bits), because two inverted bits cancel each other out during binary XOR summation.</a:t>
+              <a:t>In digital hardware, 1D Parity is implemented using a balanced binary XOR tree, which computes the parity bit in O(log2 n) gate delay levels. At the receiving node, the entire codeword (including the parity bit) is evaluated: Prx = b1 ^ b2 ^ ... ^ bn ^ P. If Prx = 0 for Even Parity (or 1 for Odd Parity), the frame passes verification; otherwise, a parity error is declared.</a:t>
             </a:r>
           </a:p>
         </p:txBody>
@@ -7702,8 +10270,8 @@
         </p:nvSpPr>
         <p:spPr>
           <a:xfrm>
-            <a:off x="6446520" y="1764792"/>
-            <a:ext cx="4754880" cy="4517136"/>
+            <a:off x="6446520" y="1746504"/>
+            <a:ext cx="4754880" cy="4553712"/>
           </a:xfrm>
           <a:prstGeom prst="rect">
             <a:avLst/>
@@ -7717,7 +10285,7 @@
           <a:lstStyle/>
           <a:p>
             <a:pPr>
-              <a:defRPr sz="1500" b="1">
+              <a:defRPr sz="1400" b="1">
                 <a:solidFill>
                   <a:srgbClr val="38BDF8"/>
                 </a:solidFill>
@@ -7725,7 +10293,7 @@
               </a:defRPr>
             </a:pPr>
             <a:r>
-              <a:t>NS-2 Channel Integration &amp; Trace Analytics</a:t>
+              <a:t>Detection Strength, Hamming Distance &amp; Limits</a:t>
             </a:r>
           </a:p>
           <a:p>
@@ -7733,7 +10301,7 @@
               <a:spcBef>
                 <a:spcPts val="200"/>
               </a:spcBef>
-              <a:defRPr sz="1100">
+              <a:defRPr sz="1050">
                 <a:solidFill>
                   <a:srgbClr val="94A3B8"/>
                 </a:solidFill>
@@ -7741,39 +10309,39 @@
               </a:defRPr>
             </a:pPr>
             <a:r>
-              <a:t>Duplex link simulation and ErrorModel packet drop verification:</a:t>
+              <a:t>Hamming distance = 2, odd error guarantees, and even cancellation:</a:t>
             </a:r>
           </a:p>
           <a:p>
             <a:pPr>
               <a:spcBef>
-                <a:spcPts val="600"/>
-              </a:spcBef>
-              <a:defRPr sz="1100">
-                <a:solidFill>
-                  <a:srgbClr val="F8FAFC"/>
-                </a:solidFill>
-                <a:latin typeface="Segoe UI"/>
-              </a:defRPr>
-            </a:pPr>
-            <a:r>
-              <a:t>In our simulation platform, the 1D Parity module is integrated with Network Simulator 2 via the network_error_sim.tcl simulation script. The transmitter node (Node 0) encapsulates the parity-encoded codeword (for example, data '11010010' with even parity bit '0' yielding codeword '110100100') into Constant Bit Rate (CBR) UDP packets and transmits them across a 2 Mbps duplex link with a 10 ms delay toward the receiver sink (Node 1).</a:t>
-            </a:r>
-          </a:p>
-          <a:p>
-            <a:pPr>
-              <a:spcBef>
-                <a:spcPts val="600"/>
+                <a:spcPts val="500"/>
               </a:spcBef>
               <a:defRPr sz="1050">
                 <a:solidFill>
+                  <a:srgbClr val="F8FAFC"/>
+                </a:solidFill>
+                <a:latin typeface="Segoe UI"/>
+              </a:defRPr>
+            </a:pPr>
+            <a:r>
+              <a:t>The error detection capability of 1D Parity is governed by coding theory: appending a single parity bit establishes a minimum Hamming distance of d_min = 2 between valid codewords. According to the coding distance theorem, a code with minimum distance d_min can reliably detect up to s = d_min - 1 = 1 bit error. Consequently, 1D Parity guarantees 100% detection of all single-bit errors as well as any odd number of simultaneous bit flips (1, 3, 5, 7 bits).</a:t>
+            </a:r>
+          </a:p>
+          <a:p>
+            <a:pPr>
+              <a:spcBef>
+                <a:spcPts val="500"/>
+              </a:spcBef>
+              <a:defRPr sz="1000">
+                <a:solidFill>
                   <a:srgbClr val="94A3B8"/>
                 </a:solidFill>
                 <a:latin typeface="Segoe UI"/>
               </a:defRPr>
             </a:pPr>
             <a:r>
-              <a:t>Physical channel noise is introduced using the NS-2 ErrorModel/Uniform module, which injects packet loss and bit corruption according to a statistical packet error rate. The entire discrete-event sequence is logged into ns2/ns2_parity.tr. When NS-2 corrupts a single bit in transit, the receiver parity check fails immediately, generating an 'Error Detected' alert and discarding the packet. This confirms that 1D Parity provides 100% detection reliability for isolated single-bit transmission noise across simulated links.</a:t>
+              <a:t>However, 1D Parity is completely blind to any even number of bit errors (2, 4, 6 bits). When an even number of bits invert during transmission, the two bit flips mathematically cancel each other out in the XOR summation (1 ^ 1 = 0 ^ 0 = 0), producing an identical parity bit and resulting in undetected data corruption. Furthermore, 1D Parity provides zero error correction capability, requiring retransmission protocols when errors are flagged.</a:t>
             </a:r>
           </a:p>
         </p:txBody>
@@ -7870,7 +10438,7 @@
               </a:defRPr>
             </a:pPr>
             <a:r>
-              <a:t>●  ALGORITHM 2 OF 5</a:t>
+              <a:t>●  ALGORITHM 1 OF 5: PART B</a:t>
             </a:r>
           </a:p>
         </p:txBody>
@@ -7898,7 +10466,7 @@
           <a:lstStyle/>
           <a:p>
             <a:pPr>
-              <a:defRPr sz="2200" b="1">
+              <a:defRPr sz="2100" b="1">
                 <a:solidFill>
                   <a:srgbClr val="F8FAFC"/>
                 </a:solidFill>
@@ -7906,7 +10474,7 @@
               </a:defRPr>
             </a:pPr>
             <a:r>
-              <a:t>2D Parity Check (Matrix Grid Localization)</a:t>
+              <a:t>1D Parity Check: NS-2 Simulation &amp; Protocols</a:t>
             </a:r>
           </a:p>
         </p:txBody>
@@ -7934,7 +10502,7 @@
           <a:lstStyle/>
           <a:p>
             <a:pPr>
-              <a:defRPr sz="1200">
+              <a:defRPr sz="1150">
                 <a:solidFill>
                   <a:srgbClr val="94A3B8"/>
                 </a:solidFill>
@@ -7942,7 +10510,7 @@
               </a:defRPr>
             </a:pPr>
             <a:r>
-              <a:t>Combining Longitudinal (LRC) &amp; Vertical (VRC) Redundancy Checks for bit error correction</a:t>
+              <a:t>Discrete-event duplex link modeling, trace log analysis, and asynchronous serial standards</a:t>
             </a:r>
           </a:p>
         </p:txBody>
@@ -8000,8 +10568,8 @@
         </p:nvSpPr>
         <p:spPr>
           <a:xfrm>
-            <a:off x="960120" y="1764792"/>
-            <a:ext cx="4754880" cy="4517136"/>
+            <a:off x="960120" y="1746504"/>
+            <a:ext cx="4754880" cy="4553712"/>
           </a:xfrm>
           <a:prstGeom prst="rect">
             <a:avLst/>
@@ -8015,7 +10583,7 @@
           <a:lstStyle/>
           <a:p>
             <a:pPr>
-              <a:defRPr sz="1500" b="1">
+              <a:defRPr sz="1400" b="1">
                 <a:solidFill>
                   <a:srgbClr val="38BDF8"/>
                 </a:solidFill>
@@ -8023,7 +10591,7 @@
               </a:defRPr>
             </a:pPr>
             <a:r>
-              <a:t>Matrix Structuring &amp; Error Localization</a:t>
+              <a:t>NS-2 Channel Integration &amp; Trace Analytics</a:t>
             </a:r>
           </a:p>
           <a:p>
@@ -8031,7 +10599,7 @@
               <a:spcBef>
                 <a:spcPts val="200"/>
               </a:spcBef>
-              <a:defRPr sz="1100">
+              <a:defRPr sz="1050">
                 <a:solidFill>
                   <a:srgbClr val="94A3B8"/>
                 </a:solidFill>
@@ -8039,39 +10607,39 @@
               </a:defRPr>
             </a:pPr>
             <a:r>
-              <a:t>Two-dimensional parity calculations and geometric intersection:</a:t>
+              <a:t>Duplex link simulation and ErrorModel packet drop verification (ns2_parity.tr):</a:t>
             </a:r>
           </a:p>
           <a:p>
             <a:pPr>
               <a:spcBef>
-                <a:spcPts val="600"/>
-              </a:spcBef>
-              <a:defRPr sz="1100">
-                <a:solidFill>
-                  <a:srgbClr val="F8FAFC"/>
-                </a:solidFill>
-                <a:latin typeface="Segoe UI"/>
-              </a:defRPr>
-            </a:pPr>
-            <a:r>
-              <a:t>Two-Dimensional (2D) Parity Check significantly enhances error detection capability by organizing the raw binary message into a two-dimensional matrix of M rows and N columns. Each individual row is assigned a Longitudinal Redundancy Check (LRC) parity bit, while each column is assigned a Vertical Redundancy Check (VRC) parity bit. In addition, an overall corner parity bit is computed across all row parity bits, producing a total check bit overhead of M + N + 1 bits. This orthogonal grid structure establishes two independent parity constraints for every single data bit in the matrix.</a:t>
-            </a:r>
-          </a:p>
-          <a:p>
-            <a:pPr>
-              <a:spcBef>
-                <a:spcPts val="600"/>
+                <a:spcPts val="500"/>
               </a:spcBef>
               <a:defRPr sz="1050">
                 <a:solidFill>
+                  <a:srgbClr val="F8FAFC"/>
+                </a:solidFill>
+                <a:latin typeface="Segoe UI"/>
+              </a:defRPr>
+            </a:pPr>
+            <a:r>
+              <a:t>In our platform, the 1D Parity module is directly coupled with Network Simulator 2 via ns2/network_error_sim.tcl. The transmitter node (Node 0) formats the raw data vector (e.g., '11010010'), appends the computed parity bit ('0'), and packetizes the resulting 9-bit codeword into UDP/CBR packets. The packets are transmitted across a 2.0 Mbps duplex link with 10 ms delay toward the receiver sink (Node 1).</a:t>
+            </a:r>
+          </a:p>
+          <a:p>
+            <a:pPr>
+              <a:spcBef>
+                <a:spcPts val="500"/>
+              </a:spcBef>
+              <a:defRPr sz="1000">
+                <a:solidFill>
                   <a:srgbClr val="94A3B8"/>
                 </a:solidFill>
                 <a:latin typeface="Segoe UI"/>
               </a:defRPr>
             </a:pPr>
             <a:r>
-              <a:t>When the frame arrives at the receiving node, parities are recalculated along both dimensions, generating a row syndrome vector and a column syndrome vector. If a single bit flip occurs at row coordinate i and column coordinate j, both the row i parity check and column j parity check fail simultaneously. The receiver determines the exact geometric intersection (i, j) of the failed parity lines, precisely localizing the corrupted bit without ambiguity.</a:t>
+              <a:t>Channel noise is introduced using the NS-2 ErrorModel/Uniform module. When an error event corrupts a packet in transit, the event is recorded in the trace log (ns2_parity.tr). The receiver application parses the incoming packet, evaluates the parity bit, and immediately flags an 'Error Detected' condition upon bit mismatch. In our empirical trials, 100% of single-bit errors injected by NS-2 were caught and flagged at the receiver sink.</a:t>
             </a:r>
           </a:p>
         </p:txBody>
@@ -8129,8 +10697,8 @@
         </p:nvSpPr>
         <p:spPr>
           <a:xfrm>
-            <a:off x="6446520" y="1764792"/>
-            <a:ext cx="4754880" cy="4517136"/>
+            <a:off x="6446520" y="1746504"/>
+            <a:ext cx="4754880" cy="4553712"/>
           </a:xfrm>
           <a:prstGeom prst="rect">
             <a:avLst/>
@@ -8144,7 +10712,7 @@
           <a:lstStyle/>
           <a:p>
             <a:pPr>
-              <a:defRPr sz="1500" b="1">
+              <a:defRPr sz="1400" b="1">
                 <a:solidFill>
                   <a:srgbClr val="38BDF8"/>
                 </a:solidFill>
@@ -8152,7 +10720,7 @@
               </a:defRPr>
             </a:pPr>
             <a:r>
-              <a:t>Forward Error Correction &amp; NS-2 Trace Integration</a:t>
+              <a:t>Industrial Protocols &amp; Serial Framing Standards</a:t>
             </a:r>
           </a:p>
           <a:p>
@@ -8160,7 +10728,7 @@
               <a:spcBef>
                 <a:spcPts val="200"/>
               </a:spcBef>
-              <a:defRPr sz="1100">
+              <a:defRPr sz="1050">
                 <a:solidFill>
                   <a:srgbClr val="94A3B8"/>
                 </a:solidFill>
@@ -8168,39 +10736,39 @@
               </a:defRPr>
             </a:pPr>
             <a:r>
-              <a:t>Autonomous 1-bit repair and multi-packet channel modeling:</a:t>
+              <a:t>UART microcontrollers, RS-232/485 serial communication, and SCSI bus validation:</a:t>
             </a:r>
           </a:p>
           <a:p>
             <a:pPr>
               <a:spcBef>
-                <a:spcPts val="600"/>
-              </a:spcBef>
-              <a:defRPr sz="1100">
-                <a:solidFill>
-                  <a:srgbClr val="F8FAFC"/>
-                </a:solidFill>
-                <a:latin typeface="Segoe UI"/>
-              </a:defRPr>
-            </a:pPr>
-            <a:r>
-              <a:t>The defining breakthrough of 2D Parity over 1D Parity is its capability for autonomous Forward Error Correction (FEC). Once the corrupted bit coordinate (i, j) is localized, the receiver inverts that specific bit (b[i][j] = ~b[i][j]), fully restoring the original data vector without requiring a costly packet retransmission. Additionally, 2D Parity detects up to 3 simultaneous bit errors and 100% of all burst corruptions whose length does not exceed N bits.</a:t>
-            </a:r>
-          </a:p>
-          <a:p>
-            <a:pPr>
-              <a:spcBef>
-                <a:spcPts val="600"/>
+                <a:spcPts val="500"/>
               </a:spcBef>
               <a:defRPr sz="1050">
                 <a:solidFill>
+                  <a:srgbClr val="F8FAFC"/>
+                </a:solidFill>
+                <a:latin typeface="Segoe UI"/>
+              </a:defRPr>
+            </a:pPr>
+            <a:r>
+              <a:t>Because 1D Parity incurs minimal bandwidth overhead (a single bit per frame) and requires trivial hardware logic, it remains the standard error-checking mechanism in low-speed, asynchronous serial communication protocols. In the universal RS-232, RS-422, and RS-485 serial communication standards (commonly utilized in UART microcontrollers and industrial automation), frames are formatted in the 8-N-1, 8-E-1 (Even Parity), or 8-O-1 (Odd Parity) formats.</a:t>
+            </a:r>
+          </a:p>
+          <a:p>
+            <a:pPr>
+              <a:spcBef>
+                <a:spcPts val="500"/>
+              </a:spcBef>
+              <a:defRPr sz="1000">
+                <a:solidFill>
                   <a:srgbClr val="94A3B8"/>
                 </a:solidFill>
                 <a:latin typeface="Segoe UI"/>
               </a:defRPr>
             </a:pPr>
             <a:r>
-              <a:t>In our NS-2 simulation environment, the serialized 2D Parity matrix is transmitted across the duplex link between Node 0 and Node 1. The resulting trace events logged in ns2/ns2_parity2d.tr capture packet enqueue, link propagation, and receiver queueing. When channel noise corrupts a bit in transit, the receiver reconstructs the matrix grid, pinpoints the faulty row and column, and visually restores the corrupted bit in real time, demonstrating complete physical-to-link-layer error recovery.</a:t>
+              <a:t>While modern high-speed networks (such as Ethernet and Wi-Fi) have superseded simple parity with cyclic redundancy checks, 1D Parity continues to serve as an indispensable first-line validation check in SCSI bus transfers, PCI bus command lines, and microcontroller register transfers where processing power and silicon area are highly constrained.</a:t>
             </a:r>
           </a:p>
         </p:txBody>
@@ -8297,7 +10865,7 @@
               </a:defRPr>
             </a:pPr>
             <a:r>
-              <a:t>●  ALGORITHM 3 OF 5</a:t>
+              <a:t>●  ALGORITHM 2 OF 5: PART A</a:t>
             </a:r>
           </a:p>
         </p:txBody>
@@ -8325,7 +10893,7 @@
           <a:lstStyle/>
           <a:p>
             <a:pPr>
-              <a:defRPr sz="2200" b="1">
+              <a:defRPr sz="2100" b="1">
                 <a:solidFill>
                   <a:srgbClr val="F8FAFC"/>
                 </a:solidFill>
@@ -8333,7 +10901,7 @@
               </a:defRPr>
             </a:pPr>
             <a:r>
-              <a:t>Hamming Code (n, k) &amp; Forward Error Correction</a:t>
+              <a:t>2D Parity Matrix: Grid Architecture &amp; Error Localization</a:t>
             </a:r>
           </a:p>
         </p:txBody>
@@ -8361,7 +10929,7 @@
           <a:lstStyle/>
           <a:p>
             <a:pPr>
-              <a:defRPr sz="1200">
+              <a:defRPr sz="1150">
                 <a:solidFill>
                   <a:srgbClr val="94A3B8"/>
                 </a:solidFill>
@@ -8369,7 +10937,7 @@
               </a:defRPr>
             </a:pPr>
             <a:r>
-              <a:t>Power-of-two parity placement with mathematical syndrome calculation for automatic bit recovery</a:t>
+              <a:t>Two-dimensional matrix parity for coordinate-based bit localization</a:t>
             </a:r>
           </a:p>
         </p:txBody>
@@ -8427,8 +10995,8 @@
         </p:nvSpPr>
         <p:spPr>
           <a:xfrm>
-            <a:off x="960120" y="1764792"/>
-            <a:ext cx="4754880" cy="4517136"/>
+            <a:off x="960120" y="1746504"/>
+            <a:ext cx="4754880" cy="4553712"/>
           </a:xfrm>
           <a:prstGeom prst="rect">
             <a:avLst/>
@@ -8442,7 +11010,7 @@
           <a:lstStyle/>
           <a:p>
             <a:pPr>
-              <a:defRPr sz="1500" b="1">
+              <a:defRPr sz="1400" b="1">
                 <a:solidFill>
                   <a:srgbClr val="38BDF8"/>
                 </a:solidFill>
@@ -8450,7 +11018,7 @@
               </a:defRPr>
             </a:pPr>
             <a:r>
-              <a:t>Mathematical Foundation &amp; Linear Block Theory</a:t>
+              <a:t>Matrix Grid Structuring, LRC &amp; VRC Formulations</a:t>
             </a:r>
           </a:p>
           <a:p>
@@ -8458,7 +11026,7 @@
               <a:spcBef>
                 <a:spcPts val="200"/>
               </a:spcBef>
-              <a:defRPr sz="1100">
+              <a:defRPr sz="1050">
                 <a:solidFill>
                   <a:srgbClr val="94A3B8"/>
                 </a:solidFill>
@@ -8466,39 +11034,39 @@
               </a:defRPr>
             </a:pPr>
             <a:r>
-              <a:t>Richard Hamming (1950) coding theory and power-of-two bit placement:</a:t>
+              <a:t>Orthogonal parity constraints across M rows and N columns:</a:t>
             </a:r>
           </a:p>
           <a:p>
             <a:pPr>
               <a:spcBef>
-                <a:spcPts val="600"/>
-              </a:spcBef>
-              <a:defRPr sz="1100">
-                <a:solidFill>
-                  <a:srgbClr val="F8FAFC"/>
-                </a:solidFill>
-                <a:latin typeface="Segoe UI"/>
-              </a:defRPr>
-            </a:pPr>
-            <a:r>
-              <a:t>Formulated by Richard W. Hamming in 1950, Hamming Codes are a distinguished family of linear block codes that achieve single-error correction (SEC) and double-error detection (DED). In the standard Hamming (7, 4) scheme, 4 information data bits (d1, d2, d3, d4) are combined with 3 redundant check bits (p1, p2, p4) to form a 7-bit codeword. Parity bits are strictly assigned to bit positions that are powers of two (1, 2, 4, 8, ...), while data bits occupy the remaining non-power-of-two indices (3, 5, 6, 7). The required number of parity bits r for k data bits is governed by Hamming's rule: 2^r &gt;= k + r + 1.</a:t>
-            </a:r>
-          </a:p>
-          <a:p>
-            <a:pPr>
-              <a:spcBef>
-                <a:spcPts val="600"/>
+                <a:spcPts val="500"/>
               </a:spcBef>
               <a:defRPr sz="1050">
                 <a:solidFill>
+                  <a:srgbClr val="F8FAFC"/>
+                </a:solidFill>
+                <a:latin typeface="Segoe UI"/>
+              </a:defRPr>
+            </a:pPr>
+            <a:r>
+              <a:t>Two-Dimensional (2D) Parity Check, also known as Matrix Parity or Optimal Rectangular Code, overcomes the severe limitations of 1D Parity by organizing the raw binary message into a two-dimensional grid of M rows and N columns. In this architecture, two independent sets of parity bits are computed along orthogonal dimensions: Longitudinal Redundancy Check (LRC) bits for every horizontal row, and Vertical Redundancy Check (VRC) bits for every vertical column.</a:t>
+            </a:r>
+          </a:p>
+          <a:p>
+            <a:pPr>
+              <a:spcBef>
+                <a:spcPts val="500"/>
+              </a:spcBef>
+              <a:defRPr sz="1000">
+                <a:solidFill>
                   <a:srgbClr val="94A3B8"/>
                 </a:solidFill>
                 <a:latin typeface="Segoe UI"/>
               </a:defRPr>
             </a:pPr>
             <a:r>
-              <a:t>Each parity bit covers a specific subset of codeword bits whose binary index representation contains a 1 at that parity bit's power-of-two position. Specifically, p1 covers bits {1, 3, 5, 7}, p2 covers bits {2, 3, 6, 7}, and p4 covers bits {4, 5, 6, 7}. This orthogonal assignment ensures that every bit position in the codeword is represented by a unique binary combination of parity bits, establishing a linear system of parity-check equations over GF(2).</a:t>
+              <a:t>Specifically, each row i receives a row parity bit Ri = ^ b[i][j]. Each column j receives a column parity bit Cj = ^ b[i][j]. In addition, a corner parity bit is computed across all row parity bits: Pcorner = ^ Ri. This creates an (M+1) x (N+1) codeword matrix with a total redundancy overhead of M + N + 1 bits, establishing two orthogonal parity constraints for every single data bit.</a:t>
             </a:r>
           </a:p>
         </p:txBody>
@@ -8556,8 +11124,8 @@
         </p:nvSpPr>
         <p:spPr>
           <a:xfrm>
-            <a:off x="6446520" y="1764792"/>
-            <a:ext cx="4754880" cy="4517136"/>
+            <a:off x="6446520" y="1746504"/>
+            <a:ext cx="4754880" cy="4553712"/>
           </a:xfrm>
           <a:prstGeom prst="rect">
             <a:avLst/>
@@ -8571,7 +11139,7 @@
           <a:lstStyle/>
           <a:p>
             <a:pPr>
-              <a:defRPr sz="1500" b="1">
+              <a:defRPr sz="1400" b="1">
                 <a:solidFill>
                   <a:srgbClr val="38BDF8"/>
                 </a:solidFill>
@@ -8579,7 +11147,7 @@
               </a:defRPr>
             </a:pPr>
             <a:r>
-              <a:t>Syndrome Decoding, FEC &amp; NS-2 Trace Integration</a:t>
+              <a:t>Geometric Intersection &amp; Bit Localization</a:t>
             </a:r>
           </a:p>
           <a:p>
@@ -8587,7 +11155,7 @@
               <a:spcBef>
                 <a:spcPts val="200"/>
               </a:spcBef>
-              <a:defRPr sz="1100">
+              <a:defRPr sz="1050">
                 <a:solidFill>
                   <a:srgbClr val="94A3B8"/>
                 </a:solidFill>
@@ -8595,39 +11163,39 @@
               </a:defRPr>
             </a:pPr>
             <a:r>
-              <a:t>Automatic single-bit correction and server memory applications:</a:t>
+              <a:t>Spatial intersection of failing row and column syndrome vectors:</a:t>
             </a:r>
           </a:p>
           <a:p>
             <a:pPr>
               <a:spcBef>
-                <a:spcPts val="600"/>
-              </a:spcBef>
-              <a:defRPr sz="1100">
-                <a:solidFill>
-                  <a:srgbClr val="F8FAFC"/>
-                </a:solidFill>
-                <a:latin typeface="Segoe UI"/>
-              </a:defRPr>
-            </a:pPr>
-            <a:r>
-              <a:t>At the destination receiver, each parity-check equation is re-evaluated to construct a 3-bit syndrome vector: S = (s3, s2, s1) in binary. If S = 000, the transmission is perfectly clean. If a single bit flip occurs during transit, the decimal value of the syndrome vector S directly corresponds to the exact 1-indexed position of the corrupted bit (for example, syndrome S = 101_2 = 5 indicates that bit 5 is inverted). The receiver automatically flips bit 5 back to its original state, achieving instantaneous forward error correction without retransmission.</a:t>
-            </a:r>
-          </a:p>
-          <a:p>
-            <a:pPr>
-              <a:spcBef>
-                <a:spcPts val="600"/>
+                <a:spcPts val="500"/>
               </a:spcBef>
               <a:defRPr sz="1050">
                 <a:solidFill>
+                  <a:srgbClr val="F8FAFC"/>
+                </a:solidFill>
+                <a:latin typeface="Segoe UI"/>
+              </a:defRPr>
+            </a:pPr>
+            <a:r>
+              <a:t>When the (M+1) x (N+1) frame is received, the destination node recalculates all row parities and all column parities, comparing them against the received parity bits to construct two syndrome vectors: a row syndrome SR = (sr1, ..., srM) and a column syndrome SC = (sc1, ..., scN).</a:t>
+            </a:r>
+          </a:p>
+          <a:p>
+            <a:pPr>
+              <a:spcBef>
+                <a:spcPts val="500"/>
+              </a:spcBef>
+              <a:defRPr sz="1000">
+                <a:solidFill>
                   <a:srgbClr val="94A3B8"/>
                 </a:solidFill>
                 <a:latin typeface="Segoe UI"/>
               </a:defRPr>
             </a:pPr>
             <a:r>
-              <a:t>Because Hamming codes execute in O(1) hardware cycle latency, they are ubiquitously deployed in server ECC RAM, processor caches, satellite telemetries, and RAID-2 storage systems. In our simulator, the Hamming module is bridged to NS-2 (ns2/ns2_hamming.tr). Packets subjected to simulated channel noise are captured at the receiver sink, where the 3-bit syndrome decoder identifies and repairs the inverted bit, proving empirical forward error correction across discrete-event network channels.</a:t>
+              <a:t>If a single bit error occurs at matrix position (i, j), the parity check for row i fails (s_ri = 1) and the parity check for column j fails (s_cj = 1), while all other row and column parities evaluate to zero. The receiver identifies the unique geometric intersection (i, j) of the failing row and column, pinpointing the exact spatial coordinate of the corrupted bit without ambiguity.</a:t>
             </a:r>
           </a:p>
         </p:txBody>
@@ -8724,7 +11292,7 @@
               </a:defRPr>
             </a:pPr>
             <a:r>
-              <a:t>●  ALGORITHM 4 OF 5</a:t>
+              <a:t>●  ALGORITHM 2 OF 5: PART B</a:t>
             </a:r>
           </a:p>
         </p:txBody>
@@ -8752,7 +11320,7 @@
           <a:lstStyle/>
           <a:p>
             <a:pPr>
-              <a:defRPr sz="2200" b="1">
+              <a:defRPr sz="2100" b="1">
                 <a:solidFill>
                   <a:srgbClr val="F8FAFC"/>
                 </a:solidFill>
@@ -8760,7 +11328,7 @@
               </a:defRPr>
             </a:pPr>
             <a:r>
-              <a:t>Internet Checksum (1's Complement Summation)</a:t>
+              <a:t>2D Parity Matrix: Forward Error Correction &amp; NS-2</a:t>
             </a:r>
           </a:p>
         </p:txBody>
@@ -8788,7 +11356,7 @@
           <a:lstStyle/>
           <a:p>
             <a:pPr>
-              <a:defRPr sz="1200">
+              <a:defRPr sz="1150">
                 <a:solidFill>
                   <a:srgbClr val="94A3B8"/>
                 </a:solidFill>
@@ -8796,7 +11364,7 @@
               </a:defRPr>
             </a:pPr>
             <a:r>
-              <a:t>The foundational error detection mechanism powering IPv4, TCP, and UDP packet headers</a:t>
+              <a:t>Autonomous 1-bit repair, multi-bit burst detection, and trace verification</a:t>
             </a:r>
           </a:p>
         </p:txBody>
@@ -8854,8 +11422,8 @@
         </p:nvSpPr>
         <p:spPr>
           <a:xfrm>
-            <a:off x="960120" y="1764792"/>
-            <a:ext cx="4754880" cy="4517136"/>
+            <a:off x="960120" y="1746504"/>
+            <a:ext cx="4754880" cy="4553712"/>
           </a:xfrm>
           <a:prstGeom prst="rect">
             <a:avLst/>
@@ -8869,7 +11437,7 @@
           <a:lstStyle/>
           <a:p>
             <a:pPr>
-              <a:defRPr sz="1500" b="1">
+              <a:defRPr sz="1400" b="1">
                 <a:solidFill>
                   <a:srgbClr val="38BDF8"/>
                 </a:solidFill>
@@ -8877,7 +11445,7 @@
               </a:defRPr>
             </a:pPr>
             <a:r>
-              <a:t>Mathematical Mechanism &amp; 1's Complement</a:t>
+              <a:t>Forward Error Correction &amp; Burst Detection</a:t>
             </a:r>
           </a:p>
           <a:p>
@@ -8885,7 +11453,7 @@
               <a:spcBef>
                 <a:spcPts val="200"/>
               </a:spcBef>
-              <a:defRPr sz="1100">
+              <a:defRPr sz="1050">
                 <a:solidFill>
                   <a:srgbClr val="94A3B8"/>
                 </a:solidFill>
@@ -8893,39 +11461,39 @@
               </a:defRPr>
             </a:pPr>
             <a:r>
-              <a:t>RFC 1071 standard protocol mechanism and end-around carry addition:</a:t>
+              <a:t>Autonomous 1-bit bit-flipping and multi-bit detection boundaries:</a:t>
             </a:r>
           </a:p>
           <a:p>
             <a:pPr>
               <a:spcBef>
-                <a:spcPts val="600"/>
-              </a:spcBef>
-              <a:defRPr sz="1100">
-                <a:solidFill>
-                  <a:srgbClr val="F8FAFC"/>
-                </a:solidFill>
-                <a:latin typeface="Segoe UI"/>
-              </a:defRPr>
-            </a:pPr>
-            <a:r>
-              <a:t>The Internet Checksum is the foundational error-detection algorithm standardized in RFC 1071 and ubiquitously deployed across the core protocols of the TCP/IP suite, including IPv4 header validation, TCP segment integrity, and UDP datagram checking. The algorithm operates by segmenting the binary input stream into uniform k-bit words (typically 16-bit integers in network implementations). These words are summed together sequentially using One's Complement Arithmetic, which differs fundamentally from standard two's complement addition.</a:t>
-            </a:r>
-          </a:p>
-          <a:p>
-            <a:pPr>
-              <a:spcBef>
-                <a:spcPts val="600"/>
+                <a:spcPts val="500"/>
               </a:spcBef>
               <a:defRPr sz="1050">
                 <a:solidFill>
+                  <a:srgbClr val="F8FAFC"/>
+                </a:solidFill>
+                <a:latin typeface="Segoe UI"/>
+              </a:defRPr>
+            </a:pPr>
+            <a:r>
+              <a:t>The defining technical breakthrough of 2D Parity over 1D Parity is its capability for Forward Error Correction (FEC) without retransmission. Once the coordinates of the failing intersection (i, j) are identified, the receiver simply inverts that specific bit (b[i][j] = ~b[i][j]), fully recovering the original data payload without requesting a retransmission from the sender.</a:t>
+            </a:r>
+          </a:p>
+          <a:p>
+            <a:pPr>
+              <a:spcBef>
+                <a:spcPts val="500"/>
+              </a:spcBef>
+              <a:defRPr sz="1000">
+                <a:solidFill>
                   <a:srgbClr val="94A3B8"/>
                 </a:solidFill>
                 <a:latin typeface="Segoe UI"/>
               </a:defRPr>
             </a:pPr>
             <a:r>
-              <a:t>Whenever an addition produces a carry bit exceeding the k-bit boundary (an overflow), the carry bit is not discarded; instead, it is wrapped around and added back into the least significant bit (LSB), a process known as end-around carry. Once all words have been accumulated into the running sum, the bitwise one's complement (NOT operation) of the final sum is calculated, and this resulting k-bit value is transmitted as the checksum field alongside the original data payload.</a:t>
+              <a:t>In addition to single-bit correction, 2D Parity provides powerful multi-bit error detection: it detects 100% of all 2-bit errors (which cause two row failures or two column failures), 100% of all 3-bit errors, and 100% of all burst error corruptions of length up to N bits across a row. The only pattern that evades 2D Parity detection is a 4-bit error arranged in a perfect rectangle (i1, j1), (i1, j2), (i2, j1), (i2, j2), where each row and column contains an even number of flipped bits.</a:t>
             </a:r>
           </a:p>
         </p:txBody>
@@ -8983,8 +11551,8 @@
         </p:nvSpPr>
         <p:spPr>
           <a:xfrm>
-            <a:off x="6446520" y="1764792"/>
-            <a:ext cx="4754880" cy="4517136"/>
+            <a:off x="6446520" y="1746504"/>
+            <a:ext cx="4754880" cy="4553712"/>
           </a:xfrm>
           <a:prstGeom prst="rect">
             <a:avLst/>
@@ -8998,7 +11566,7 @@
           <a:lstStyle/>
           <a:p>
             <a:pPr>
-              <a:defRPr sz="1500" b="1">
+              <a:defRPr sz="1400" b="1">
                 <a:solidFill>
                   <a:srgbClr val="38BDF8"/>
                 </a:solidFill>
@@ -9006,7 +11574,7 @@
               </a:defRPr>
             </a:pPr>
             <a:r>
-              <a:t>Receiver Zero-Check, Limits &amp; NS-2 Modeling</a:t>
+              <a:t>NS-2 Channel Integration &amp; Trace Analytics</a:t>
             </a:r>
           </a:p>
           <a:p>
@@ -9014,7 +11582,7 @@
               <a:spcBef>
                 <a:spcPts val="200"/>
               </a:spcBef>
-              <a:defRPr sz="1100">
+              <a:defRPr sz="1050">
                 <a:solidFill>
                   <a:srgbClr val="94A3B8"/>
                 </a:solidFill>
@@ -9022,39 +11590,39 @@
               </a:defRPr>
             </a:pPr>
             <a:r>
-              <a:t>Fast router computation, protocol context, and channel loss verification:</a:t>
+              <a:t>Discrete-event trace verification (ns2_parity2d.tr) and magnetic storage:</a:t>
             </a:r>
           </a:p>
           <a:p>
             <a:pPr>
               <a:spcBef>
-                <a:spcPts val="600"/>
-              </a:spcBef>
-              <a:defRPr sz="1100">
-                <a:solidFill>
-                  <a:srgbClr val="F8FAFC"/>
-                </a:solidFill>
-                <a:latin typeface="Segoe UI"/>
-              </a:defRPr>
-            </a:pPr>
-            <a:r>
-              <a:t>At the destination receiver, the verification process is computationally elegant and highly optimized for router processing: the receiver sums all incoming k-bit data words plus the received checksum using one's complement addition. If no bits were corrupted during transit, the resulting sum must evaluate to all 1-bits (0xFFFF in hexadecimal), which inverts to 0x0000 (zero). Any non-zero result indicates that transmission corruption occurred, prompting the transport layer to discard the corrupted segment immediately.</a:t>
-            </a:r>
-          </a:p>
-          <a:p>
-            <a:pPr>
-              <a:spcBef>
-                <a:spcPts val="600"/>
+                <a:spcPts val="500"/>
               </a:spcBef>
               <a:defRPr sz="1050">
                 <a:solidFill>
+                  <a:srgbClr val="F8FAFC"/>
+                </a:solidFill>
+                <a:latin typeface="Segoe UI"/>
+              </a:defRPr>
+            </a:pPr>
+            <a:r>
+              <a:t>In our NS-2 simulation bridge, the serialized (M+1) x (N+1) matrix codeword is transmitted across the duplex link between Node 0 and Node 1. The discrete-event trace file (ns2_parity2d.tr) logs packet transmission timestamps, link propagation delays, and ErrorModel packet drop events.</a:t>
+            </a:r>
+          </a:p>
+          <a:p>
+            <a:pPr>
+              <a:spcBef>
+                <a:spcPts val="500"/>
+              </a:spcBef>
+              <a:defRPr sz="1000">
+                <a:solidFill>
                   <a:srgbClr val="94A3B8"/>
                 </a:solidFill>
                 <a:latin typeface="Segoe UI"/>
               </a:defRPr>
             </a:pPr>
             <a:r>
-              <a:t>Although the Internet Checksum is exceptionally fast to compute in software, it possesses recognized algorithmic limitations: it cannot detect transposed words (swapping the order of two 16-bit blocks) or compensating bit errors (where an increment in one word is mathematically cancelled by a decrement in another). In our NS-2 simulation bridge, checksum-protected packets are transmitted across the simulated link (ns2/ns2_checksum.tr). Corrupted frames trigger receiver checksum validation failures and record packet drop events at intermediate router queues.</a:t>
+              <a:t>When simulated channel noise inverts a bit in transit, the receiver reconstructs the matrix grid, highlights the intersecting row and column on the UI canvas, and automatically flips the corrupted bit back to its pristine value. In industrial practice, 2D Parity was widely deployed in 9-track magnetic tape storage drives and early telecommunication framing where burst errors along physical tracks were prevalent.</a:t>
             </a:r>
           </a:p>
         </p:txBody>
@@ -9151,7 +11719,7 @@
               </a:defRPr>
             </a:pPr>
             <a:r>
-              <a:t>●  ALGORITHM 5 OF 5</a:t>
+              <a:t>●  ALGORITHM 3 OF 5: PART A</a:t>
             </a:r>
           </a:p>
         </p:txBody>
@@ -9179,7 +11747,7 @@
           <a:lstStyle/>
           <a:p>
             <a:pPr>
-              <a:defRPr sz="2200" b="1">
+              <a:defRPr sz="2100" b="1">
                 <a:solidFill>
                   <a:srgbClr val="F8FAFC"/>
                 </a:solidFill>
@@ -9187,7 +11755,7 @@
               </a:defRPr>
             </a:pPr>
             <a:r>
-              <a:t>Cyclic Redundancy Check (CRC Modulo-2 Division)</a:t>
+              <a:t>Hamming Code (n, k): Mathematical Foundations</a:t>
             </a:r>
           </a:p>
         </p:txBody>
@@ -9215,7 +11783,7 @@
           <a:lstStyle/>
           <a:p>
             <a:pPr>
-              <a:defRPr sz="1200">
+              <a:defRPr sz="1150">
                 <a:solidFill>
                   <a:srgbClr val="94A3B8"/>
                 </a:solidFill>
@@ -9223,7 +11791,7 @@
               </a:defRPr>
             </a:pPr>
             <a:r>
-              <a:t>High-performance polynomial division over GF(2) utilized in Ethernet, Wi-Fi, and USB</a:t>
+              <a:t>Richard Hamming (1950) coding theory, power-of-two positioning, and linear block codes</a:t>
             </a:r>
           </a:p>
         </p:txBody>
@@ -9281,8 +11849,8 @@
         </p:nvSpPr>
         <p:spPr>
           <a:xfrm>
-            <a:off x="960120" y="1764792"/>
-            <a:ext cx="4754880" cy="4517136"/>
+            <a:off x="960120" y="1746504"/>
+            <a:ext cx="4754880" cy="4553712"/>
           </a:xfrm>
           <a:prstGeom prst="rect">
             <a:avLst/>
@@ -9296,7 +11864,7 @@
           <a:lstStyle/>
           <a:p>
             <a:pPr>
-              <a:defRPr sz="1500" b="1">
+              <a:defRPr sz="1400" b="1">
                 <a:solidFill>
                   <a:srgbClr val="38BDF8"/>
                 </a:solidFill>
@@ -9304,7 +11872,7 @@
               </a:defRPr>
             </a:pPr>
             <a:r>
-              <a:t>Galois Field GF(2) Polynomial Long Division</a:t>
+              <a:t>Richard Hamming's Coding Theorem &amp; Redundancy Rule</a:t>
             </a:r>
           </a:p>
           <a:p>
@@ -9312,7 +11880,7 @@
               <a:spcBef>
                 <a:spcPts val="200"/>
               </a:spcBef>
-              <a:defRPr sz="1100">
+              <a:defRPr sz="1050">
                 <a:solidFill>
                   <a:srgbClr val="94A3B8"/>
                 </a:solidFill>
@@ -9320,39 +11888,39 @@
               </a:defRPr>
             </a:pPr>
             <a:r>
-              <a:t>Algebraic foundation, generator polynomials, and frame check sequence:</a:t>
+              <a:t>Mathematical bound 2^r &gt;= k + r + 1 and power-of-two bit placement:</a:t>
             </a:r>
           </a:p>
           <a:p>
             <a:pPr>
               <a:spcBef>
-                <a:spcPts val="600"/>
-              </a:spcBef>
-              <a:defRPr sz="1100">
-                <a:solidFill>
-                  <a:srgbClr val="F8FAFC"/>
-                </a:solidFill>
-                <a:latin typeface="Segoe UI"/>
-              </a:defRPr>
-            </a:pPr>
-            <a:r>
-              <a:t>Cyclic Redundancy Check (CRC) is the most powerful, mathematically sophisticated, and widely deployed error-detection mechanism in modern computer networking, serving as the mandatory standard for Ethernet (IEEE 802.3), Wi-Fi (IEEE 802.11), USB, SATA, and cellular wireless links. CRC treats binary data sequences as algebraic polynomials whose coefficients belong to the Galois Field of two elements, GF(2). In GF(2) arithmetic, addition and subtraction are identical and equivalent to the bitwise Exclusive-OR (XOR) operation performed without carries or borrows.</a:t>
-            </a:r>
-          </a:p>
-          <a:p>
-            <a:pPr>
-              <a:spcBef>
-                <a:spcPts val="600"/>
+                <a:spcPts val="500"/>
               </a:spcBef>
               <a:defRPr sz="1050">
                 <a:solidFill>
+                  <a:srgbClr val="F8FAFC"/>
+                </a:solidFill>
+                <a:latin typeface="Segoe UI"/>
+              </a:defRPr>
+            </a:pPr>
+            <a:r>
+              <a:t>Invented by Richard W. Hamming at Bell Laboratories in 1950, Hamming Codes are a distinguished family of linear error-correcting block codes that achieve optimal single-error correction (SEC) with minimal redundancy overhead. For a block of k data bits, r redundant parity check bits are added to produce an n-bit codeword (n = k + r). The required number of check bits r is governed by Hamming's Rule: 2^r &gt;= k + r + 1. In the foundational Hamming (7, 4) code, k = 4 data bits require r = 3 parity check bits (2^3 = 8 &gt;= 4 + 3 + 1 = 8).</a:t>
+            </a:r>
+          </a:p>
+          <a:p>
+            <a:pPr>
+              <a:spcBef>
+                <a:spcPts val="500"/>
+              </a:spcBef>
+              <a:defRPr sz="1000">
+                <a:solidFill>
                   <a:srgbClr val="94A3B8"/>
                 </a:solidFill>
                 <a:latin typeface="Segoe UI"/>
               </a:defRPr>
             </a:pPr>
             <a:r>
-              <a:t>Given an n-bit data polynomial D(x) and a predetermined (r+1)-bit generator polynomial G(x), the sender first appends r zeros to the data polynomial, shifting it by x^r: D(x) * x^r. The sender then executes binary long division of D(x) * x^r by G(x) using Modulo-2 XOR operations. The resulting r-bit remainder polynomial, R(x), constitutes the Frame Check Sequence (FCS) and is appended to the message: T(x) = D(x) * x^r ^ R(x). The transmitted codeword polynomial T(x) is mathematically guaranteed to be exactly divisible by G(x).</a:t>
+              <a:t>Hamming's ingenious architectural rule dictates that parity check bits are assigned exclusively to bit positions that are powers of two: 1, 2, 4, 8, ..., 2^(r-1). The actual data bits occupy the remaining non-power-of-two indices (3, 5, 6, 7, 9, ...). This spatial distribution ensures that each bit's 1-indexed position can be uniquely expressed as a binary sum of power-of-two parity indices.</a:t>
             </a:r>
           </a:p>
         </p:txBody>
@@ -9410,8 +11978,8 @@
         </p:nvSpPr>
         <p:spPr>
           <a:xfrm>
-            <a:off x="6446520" y="1764792"/>
-            <a:ext cx="4754880" cy="4517136"/>
+            <a:off x="6446520" y="1746504"/>
+            <a:ext cx="4754880" cy="4553712"/>
           </a:xfrm>
           <a:prstGeom prst="rect">
             <a:avLst/>
@@ -9425,7 +11993,7 @@
           <a:lstStyle/>
           <a:p>
             <a:pPr>
-              <a:defRPr sz="1500" b="1">
+              <a:defRPr sz="1400" b="1">
                 <a:solidFill>
                   <a:srgbClr val="38BDF8"/>
                 </a:solidFill>
@@ -9433,7 +12001,7 @@
               </a:defRPr>
             </a:pPr>
             <a:r>
-              <a:t>Detection Superiority, Presets &amp; NS-2 Trace Integration</a:t>
+              <a:t>Orthogonal Bit Coverage &amp; Parity-Check Matrix H</a:t>
             </a:r>
           </a:p>
           <a:p>
@@ -9441,7 +12009,7 @@
               <a:spcBef>
                 <a:spcPts val="200"/>
               </a:spcBef>
-              <a:defRPr sz="1100">
+              <a:defRPr sz="1050">
                 <a:solidFill>
                   <a:srgbClr val="94A3B8"/>
                 </a:solidFill>
@@ -9449,39 +12017,39 @@
               </a:defRPr>
             </a:pPr>
             <a:r>
-              <a:t>Comprehensive burst-error detection and industry standards:</a:t>
+              <a:t>Subsets of codeword bits and linear parity equations over GF(2):</a:t>
             </a:r>
           </a:p>
           <a:p>
             <a:pPr>
               <a:spcBef>
-                <a:spcPts val="600"/>
-              </a:spcBef>
-              <a:defRPr sz="1100">
-                <a:solidFill>
-                  <a:srgbClr val="F8FAFC"/>
-                </a:solidFill>
-                <a:latin typeface="Segoe UI"/>
-              </a:defRPr>
-            </a:pPr>
-            <a:r>
-              <a:t>The mathematical properties of CRC provide extraordinary detection power: a CRC with an r-bit generator polynomial detects 100% of all single-bit errors, 100% of all double-bit errors, 100% of all odd numbers of errors (provided G(x) contains (x+1) as a factor), and 100% of all burst error corruptions of length up to r bits. Our simulator supports key industry generator polynomials, including CRC-4 (x^4 + x + 1), CRC-8 (x^8 + x^2 + x + 1), CRC-16-IBM (x^16 + x^15 + x^2 + 1), CRC-CCITT (x^16 + x^12 + x^5 + 1), and CRC-32 (Ethernet standard).</a:t>
-            </a:r>
-          </a:p>
-          <a:p>
-            <a:pPr>
-              <a:spcBef>
-                <a:spcPts val="600"/>
+                <a:spcPts val="500"/>
               </a:spcBef>
               <a:defRPr sz="1050">
                 <a:solidFill>
+                  <a:srgbClr val="F8FAFC"/>
+                </a:solidFill>
+                <a:latin typeface="Segoe UI"/>
+              </a:defRPr>
+            </a:pPr>
+            <a:r>
+              <a:t>Each parity bit pi located at index 2^(i-1) checks all bit positions whose binary representation contains a 1 at the i-th bit position. In Hamming (7, 4): parity bit p1 (position 1 = 001_2) checks bits {1, 3, 5, 7}; parity bit p2 (position 2 = 010_2) checks bits {2, 3, 6, 7}; and parity bit p4 (position 4 = 100_2) checks bits {4, 5, 6, 7}.</a:t>
+            </a:r>
+          </a:p>
+          <a:p>
+            <a:pPr>
+              <a:spcBef>
+                <a:spcPts val="500"/>
+              </a:spcBef>
+              <a:defRPr sz="1000">
+                <a:solidFill>
                   <a:srgbClr val="94A3B8"/>
                 </a:solidFill>
                 <a:latin typeface="Segoe UI"/>
               </a:defRPr>
             </a:pPr>
             <a:r>
-              <a:t>At the receiving node, the entire incoming codeword is divided by G(x). A remainder of zero confirms an uncorrupted frame, whereas any non-zero remainder alerts the Data Link Layer to discard the frame. In our NS-2 simulation (ns2/ns2_crc.tr), CRC-encoded frames traverse the simulated duplex link under varying ErrorModel loss rates. Corrupted frames reliably trigger non-zero syndrome remainders and register drop events in the NS-2 trace, modeling realistic Ethernet frame discards.</a:t>
+              <a:t>This linear system can be elegantly expressed in matrix algebra over GF(2) using the generator matrix G and parity-check matrix H, such that any valid codeword c satisfies c . H^T = 0. The minimum Hamming distance of the code is d_min = 3, enabling simultaneous detection of up to 2 bit errors and forward correction of any single-bit error.</a:t>
             </a:r>
           </a:p>
         </p:txBody>
@@ -9578,7 +12146,7 @@
               </a:defRPr>
             </a:pPr>
             <a:r>
-              <a:t>●  CHANNEL SIMULATION ENGINE</a:t>
+              <a:t>●  ALGORITHM 3 OF 5: PART B</a:t>
             </a:r>
           </a:p>
         </p:txBody>
@@ -9606,7 +12174,7 @@
           <a:lstStyle/>
           <a:p>
             <a:pPr>
-              <a:defRPr sz="2200" b="1">
+              <a:defRPr sz="2100" b="1">
                 <a:solidFill>
                   <a:srgbClr val="F8FAFC"/>
                 </a:solidFill>
@@ -9614,7 +12182,7 @@
               </a:defRPr>
             </a:pPr>
             <a:r>
-              <a:t>Network Simulator 2 (NS-2) Integration Architecture</a:t>
+              <a:t>Hamming Code: Syndrome Decoding, FEC &amp; NS-2</a:t>
             </a:r>
           </a:p>
         </p:txBody>
@@ -9642,7 +12210,7 @@
           <a:lstStyle/>
           <a:p>
             <a:pPr>
-              <a:defRPr sz="1200">
+              <a:defRPr sz="1150">
                 <a:solidFill>
                   <a:srgbClr val="94A3B8"/>
                 </a:solidFill>
@@ -9650,7 +12218,7 @@
               </a:defRPr>
             </a:pPr>
             <a:r>
-              <a:t>Coupling physical link discrete-event simulation with Data Link Layer error control</a:t>
+              <a:t>Syndrome vector index mapping, server memory ECC RAM, and trace validation</a:t>
             </a:r>
           </a:p>
         </p:txBody>
@@ -9708,8 +12276,8 @@
         </p:nvSpPr>
         <p:spPr>
           <a:xfrm>
-            <a:off x="960120" y="1764792"/>
-            <a:ext cx="4754880" cy="4517136"/>
+            <a:off x="960120" y="1746504"/>
+            <a:ext cx="4754880" cy="4553712"/>
           </a:xfrm>
           <a:prstGeom prst="rect">
             <a:avLst/>
@@ -9723,7 +12291,7 @@
           <a:lstStyle/>
           <a:p>
             <a:pPr>
-              <a:defRPr sz="1500" b="1">
+              <a:defRPr sz="1400" b="1">
                 <a:solidFill>
                   <a:srgbClr val="38BDF8"/>
                 </a:solidFill>
@@ -9731,7 +12299,7 @@
               </a:defRPr>
             </a:pPr>
             <a:r>
-              <a:t>OTcl Network Topology Configuration</a:t>
+              <a:t>Syndrome Calculation Vector &amp; Autonomous Bit Recovery</a:t>
             </a:r>
           </a:p>
           <a:p>
@@ -9739,7 +12307,7 @@
               <a:spcBef>
                 <a:spcPts val="200"/>
               </a:spcBef>
-              <a:defRPr sz="1100">
+              <a:defRPr sz="1050">
                 <a:solidFill>
                   <a:srgbClr val="94A3B8"/>
                 </a:solidFill>
@@ -9747,39 +12315,39 @@
               </a:defRPr>
             </a:pPr>
             <a:r>
-              <a:t>Physical channel modeling in network_error_sim.tcl:</a:t>
+              <a:t>Direct binary-to-decimal mapping of corrupted bit indices:</a:t>
             </a:r>
           </a:p>
           <a:p>
             <a:pPr>
               <a:spcBef>
-                <a:spcPts val="600"/>
-              </a:spcBef>
-              <a:defRPr sz="1100">
-                <a:solidFill>
-                  <a:srgbClr val="F8FAFC"/>
-                </a:solidFill>
-                <a:latin typeface="Segoe UI"/>
-              </a:defRPr>
-            </a:pPr>
-            <a:r>
-              <a:t>Network Simulator 2 (NS-2) is an industry-standard, object-oriented discrete-event network simulator widely utilized in telecommunication research to model network protocol dynamics, routing algorithms, and physical channel transmission impairments. NS-2 operates on a dual-language architecture: the core simulation engine and packet scheduler are written in C++ for maximum computational throughput, while simulation topology scripts, agent configurations, and event schedules are authored in Object Tcl (OTcl).</a:t>
-            </a:r>
-          </a:p>
-          <a:p>
-            <a:pPr>
-              <a:spcBef>
-                <a:spcPts val="600"/>
+                <a:spcPts val="500"/>
               </a:spcBef>
               <a:defRPr sz="1050">
                 <a:solidFill>
+                  <a:srgbClr val="F8FAFC"/>
+                </a:solidFill>
+                <a:latin typeface="Segoe UI"/>
+              </a:defRPr>
+            </a:pPr>
+            <a:r>
+              <a:t>At the receiving destination, the syndrome vector S = (s3, s2, s1)_2 is computed by evaluating the three linear parity-check equations over the received codeword: s1 = b1 ^ b3 ^ b5 ^ b7, s2 = b2 ^ b3 ^ b6 ^ b7, and s3 = b4 ^ b5 ^ b6 ^ b7. If the received codeword is uncorrupted, all parity equations evaluate to zero, yielding syndrome S = 000_2.</a:t>
+            </a:r>
+          </a:p>
+          <a:p>
+            <a:pPr>
+              <a:spcBef>
+                <a:spcPts val="500"/>
+              </a:spcBef>
+              <a:defRPr sz="1000">
+                <a:solidFill>
                   <a:srgbClr val="94A3B8"/>
                 </a:solidFill>
                 <a:latin typeface="Segoe UI"/>
               </a:defRPr>
             </a:pPr>
             <a:r>
-              <a:t>In our project, the physical channel is configured in ns2/network_error_sim.tcl. The simulation creates a point-to-point network topology consisting of a source node (Node 0) and a destination sink node (Node 1). Node 0 is configured with a UDP agent connected to a Constant Bit Rate (CBR) traffic generator transmitting 64-byte packets. Node 1 is equipped with an Agent/Null sink. The two nodes are connected via a full-duplex link configured with a bandwidth of 2.0 Mbps, a propagation delay of 10 ms, and a DropTail queue discipline.</a:t>
+              <a:t>If any single bit in the codeword is inverted during transit, the resulting binary syndrome S = (s3, s2, s1)_2 directly indicates the exact 1-indexed decimal position of the corrupted bit! For example, if bit 5 flips, s1 = 1 and s3 = 1 while s2 = 0, producing syndrome S = 101_2 = 5. The receiver automatically executes b5 = ~b5, restoring the original data with 100% mathematical accuracy without retransmission.</a:t>
             </a:r>
           </a:p>
         </p:txBody>
@@ -9837,8 +12405,8 @@
         </p:nvSpPr>
         <p:spPr>
           <a:xfrm>
-            <a:off x="6446520" y="1764792"/>
-            <a:ext cx="4754880" cy="4517136"/>
+            <a:off x="6446520" y="1746504"/>
+            <a:ext cx="4754880" cy="4553712"/>
           </a:xfrm>
           <a:prstGeom prst="rect">
             <a:avLst/>
@@ -9852,7 +12420,7 @@
           <a:lstStyle/>
           <a:p>
             <a:pPr>
-              <a:defRPr sz="1500" b="1">
+              <a:defRPr sz="1400" b="1">
                 <a:solidFill>
                   <a:srgbClr val="38BDF8"/>
                 </a:solidFill>
@@ -9860,7 +12428,7 @@
               </a:defRPr>
             </a:pPr>
             <a:r>
-              <a:t>Trace File (.tr) Parsing &amp; Python-to-NS-2 Bridge</a:t>
+              <a:t>NS-2 Channel Integration &amp; Semiconductor ECC Memory</a:t>
             </a:r>
           </a:p>
           <a:p>
@@ -9868,7 +12436,7 @@
               <a:spcBef>
                 <a:spcPts val="200"/>
               </a:spcBef>
-              <a:defRPr sz="1100">
+              <a:defRPr sz="1050">
                 <a:solidFill>
                   <a:srgbClr val="94A3B8"/>
                 </a:solidFill>
@@ -9876,39 +12444,39 @@
               </a:defRPr>
             </a:pPr>
             <a:r>
-              <a:t>Real-time event analytics and WSL execution bridge:</a:t>
+              <a:t>Server DRAM architectures, satellite links, and trace logs (ns2_hamming.tr):</a:t>
             </a:r>
           </a:p>
           <a:p>
             <a:pPr>
               <a:spcBef>
-                <a:spcPts val="600"/>
-              </a:spcBef>
-              <a:defRPr sz="1100">
-                <a:solidFill>
-                  <a:srgbClr val="F8FAFC"/>
-                </a:solidFill>
-                <a:latin typeface="Segoe UI"/>
-              </a:defRPr>
-            </a:pPr>
-            <a:r>
-              <a:t>To authentically simulate noisy physical transmission channels, the NS-2 ErrorModel/Uniform module is inserted directly into the duplex link between Node 0 and Node 1. The ErrorModel applies a configurable statistical packet loss rate, causing packets to be dropped or corrupted during transit. Dropped packets are redirected to an Agent/Null drop-target, capturing realistic channel packet drop behavior.</a:t>
-            </a:r>
-          </a:p>
-          <a:p>
-            <a:pPr>
-              <a:spcBef>
-                <a:spcPts val="600"/>
+                <a:spcPts val="500"/>
               </a:spcBef>
               <a:defRPr sz="1050">
                 <a:solidFill>
+                  <a:srgbClr val="F8FAFC"/>
+                </a:solidFill>
+                <a:latin typeface="Segoe UI"/>
+              </a:defRPr>
+            </a:pPr>
+            <a:r>
+              <a:t>In our NS-2 simulation bridge (ns2_hamming.tr), Hamming-encoded packets are transmitted across the duplex link between Node 0 and Node 1. The NS-2 ErrorModel drops and corrupts packets, simulating physical link noise. The receiver application captures the packet, computes the syndrome vector, and corrects the bit in real time.</a:t>
+            </a:r>
+          </a:p>
+          <a:p>
+            <a:pPr>
+              <a:spcBef>
+                <a:spcPts val="500"/>
+              </a:spcBef>
+              <a:defRPr sz="1000">
+                <a:solidFill>
                   <a:srgbClr val="94A3B8"/>
                 </a:solidFill>
                 <a:latin typeface="Segoe UI"/>
               </a:defRPr>
             </a:pPr>
             <a:r>
-              <a:t>As packets traverse the simulated link, NS-2 outputs granular event records to standard trace files (.tr). Our Python simulation bridge (modules/ns2_bridge.py) automates the execution of NS-2 inside Windows Subsystem for Linux (WSL) and parses the 12-column event records: '+' indicates packet enqueue at Node 0, '-' indicates packet transmission onto the physical wire, 'r' represents successful packet arrival at Node 1, and 'd' denotes a packet dropped due to queue congestion or simulated channel noise. The parser computes the Packet Error Rate (PER) in real time and streams trace analytics directly to the user interface.</a:t>
+              <a:t>In commercial computing, Hamming codes are ubiquitously deployed in server Error-Correcting Code (ECC) RAM, L1/L2/L3 processor caches, deep-space satellite telemetries, and RAID-2 disk architectures. By adding an overall parity bit, the code is extended to SEC-DED (Single Error Correction, Double Error Detection), providing comprehensive memory protection against cosmic ray soft-errors.</a:t>
             </a:r>
           </a:p>
         </p:txBody>

</xml_diff>